<commit_message>
fix: use the edited RAG deck, with Part 2's divider saying Part 2
The deck is now the copy edited in PowerPoint on 4 October: the lead
author's quote on the definition slide is its own italic line, on its own
click. Two changes on top of it:

- The Part 2 divider is titled "Part 2: RAG in 2026", matching Part 1's
  divider and the Agenda, instead of announcing a ten-minute break.
- Slides 46 and 50 keep the builder's text sizes. Opening the deck made
  PowerPoint re-fit 42 text boxes; its sizes pass the checker everywhere
  except those two slides, where the text ran below its box (on 46, into
  the closing line).

Co-Authored-By: Claude Opus 5.5 <noreply@anthropic.com>
</commit_message>
<xml_diff>
--- a/lectures-and-labs/week04/rag-lecture.pptx
+++ b/lectures-and-labs/week04/rag-lecture.pptx
@@ -5,59 +5,59 @@
     <p:sldMasterId id="2147483648" r:id="rId1"/>
   </p:sldMasterIdLst>
   <p:sldIdLst>
-    <p:sldId id="256" r:id="rId3"/>
-    <p:sldId id="257" r:id="rId2"/>
-    <p:sldId id="258" r:id="rId10"/>
-    <p:sldId id="259" r:id="rId11"/>
-    <p:sldId id="260" r:id="rId12"/>
-    <p:sldId id="261" r:id="rId13"/>
-    <p:sldId id="262" r:id="rId14"/>
-    <p:sldId id="263" r:id="rId15"/>
-    <p:sldId id="264" r:id="rId16"/>
-    <p:sldId id="265" r:id="rId17"/>
-    <p:sldId id="266" r:id="rId18"/>
-    <p:sldId id="267" r:id="rId19"/>
-    <p:sldId id="268" r:id="rId20"/>
-    <p:sldId id="269" r:id="rId21"/>
-    <p:sldId id="270" r:id="rId22"/>
-    <p:sldId id="271" r:id="rId23"/>
-    <p:sldId id="272" r:id="rId24"/>
-    <p:sldId id="273" r:id="rId25"/>
-    <p:sldId id="274" r:id="rId26"/>
-    <p:sldId id="275" r:id="rId27"/>
-    <p:sldId id="276" r:id="rId28"/>
-    <p:sldId id="277" r:id="rId29"/>
-    <p:sldId id="278" r:id="rId30"/>
-    <p:sldId id="279" r:id="rId31"/>
-    <p:sldId id="280" r:id="rId32"/>
-    <p:sldId id="281" r:id="rId33"/>
-    <p:sldId id="282" r:id="rId34"/>
-    <p:sldId id="283" r:id="rId35"/>
-    <p:sldId id="284" r:id="rId36"/>
-    <p:sldId id="285" r:id="rId37"/>
-    <p:sldId id="286" r:id="rId38"/>
-    <p:sldId id="287" r:id="rId39"/>
-    <p:sldId id="288" r:id="rId40"/>
-    <p:sldId id="289" r:id="rId41"/>
-    <p:sldId id="290" r:id="rId42"/>
-    <p:sldId id="291" r:id="rId43"/>
-    <p:sldId id="292" r:id="rId44"/>
-    <p:sldId id="293" r:id="rId45"/>
-    <p:sldId id="294" r:id="rId46"/>
-    <p:sldId id="295" r:id="rId47"/>
-    <p:sldId id="296" r:id="rId48"/>
-    <p:sldId id="297" r:id="rId49"/>
-    <p:sldId id="298" r:id="rId50"/>
-    <p:sldId id="299" r:id="rId51"/>
-    <p:sldId id="300" r:id="rId52"/>
-    <p:sldId id="301" r:id="rId53"/>
-    <p:sldId id="302" r:id="rId54"/>
-    <p:sldId id="303" r:id="rId55"/>
-    <p:sldId id="304" r:id="rId56"/>
-    <p:sldId id="305" r:id="rId57"/>
-    <p:sldId id="306" r:id="rId58"/>
-    <p:sldId id="307" r:id="rId59"/>
-    <p:sldId id="308" r:id="rId60"/>
+    <p:sldId id="256" r:id="rId2"/>
+    <p:sldId id="257" r:id="rId3"/>
+    <p:sldId id="258" r:id="rId4"/>
+    <p:sldId id="259" r:id="rId5"/>
+    <p:sldId id="260" r:id="rId6"/>
+    <p:sldId id="261" r:id="rId7"/>
+    <p:sldId id="262" r:id="rId8"/>
+    <p:sldId id="263" r:id="rId9"/>
+    <p:sldId id="264" r:id="rId10"/>
+    <p:sldId id="265" r:id="rId11"/>
+    <p:sldId id="266" r:id="rId12"/>
+    <p:sldId id="267" r:id="rId13"/>
+    <p:sldId id="268" r:id="rId14"/>
+    <p:sldId id="269" r:id="rId15"/>
+    <p:sldId id="270" r:id="rId16"/>
+    <p:sldId id="271" r:id="rId17"/>
+    <p:sldId id="272" r:id="rId18"/>
+    <p:sldId id="273" r:id="rId19"/>
+    <p:sldId id="274" r:id="rId20"/>
+    <p:sldId id="275" r:id="rId21"/>
+    <p:sldId id="276" r:id="rId22"/>
+    <p:sldId id="277" r:id="rId23"/>
+    <p:sldId id="278" r:id="rId24"/>
+    <p:sldId id="279" r:id="rId25"/>
+    <p:sldId id="280" r:id="rId26"/>
+    <p:sldId id="281" r:id="rId27"/>
+    <p:sldId id="282" r:id="rId28"/>
+    <p:sldId id="283" r:id="rId29"/>
+    <p:sldId id="284" r:id="rId30"/>
+    <p:sldId id="285" r:id="rId31"/>
+    <p:sldId id="286" r:id="rId32"/>
+    <p:sldId id="287" r:id="rId33"/>
+    <p:sldId id="288" r:id="rId34"/>
+    <p:sldId id="289" r:id="rId35"/>
+    <p:sldId id="290" r:id="rId36"/>
+    <p:sldId id="291" r:id="rId37"/>
+    <p:sldId id="292" r:id="rId38"/>
+    <p:sldId id="293" r:id="rId39"/>
+    <p:sldId id="294" r:id="rId40"/>
+    <p:sldId id="295" r:id="rId41"/>
+    <p:sldId id="296" r:id="rId42"/>
+    <p:sldId id="297" r:id="rId43"/>
+    <p:sldId id="298" r:id="rId44"/>
+    <p:sldId id="299" r:id="rId45"/>
+    <p:sldId id="300" r:id="rId46"/>
+    <p:sldId id="301" r:id="rId47"/>
+    <p:sldId id="302" r:id="rId48"/>
+    <p:sldId id="303" r:id="rId49"/>
+    <p:sldId id="304" r:id="rId50"/>
+    <p:sldId id="305" r:id="rId51"/>
+    <p:sldId id="306" r:id="rId52"/>
+    <p:sldId id="307" r:id="rId53"/>
+    <p:sldId id="308" r:id="rId54"/>
   </p:sldIdLst>
   <p:sldSz cx="12192000" cy="6858000"/>
   <p:notesSz cx="6858000" cy="9144000"/>
@@ -156,13 +156,18 @@
       </a:defRPr>
     </a:lvl9pPr>
   </p:defaultTextStyle>
+  <p:extLst>
+    <p:ext uri="{EFAFB233-063F-42B5-8137-9DF3F51BA10A}">
+      <p15:sldGuideLst xmlns:p15="http://schemas.microsoft.com/office/powerpoint/2012/main"/>
+    </p:ext>
+  </p:extLst>
 </p:presentation>
 </file>
 
 <file path=ppt/revisionInfo.xml><?xml version="1.0" encoding="utf-8"?>
 <p1510:revInfo xmlns:a="http://schemas.openxmlformats.org/drawingml/2006/main" xmlns:r="http://schemas.openxmlformats.org/officeDocument/2006/relationships" xmlns:p1510="http://schemas.microsoft.com/office/powerpoint/2015/10/main">
   <p1510:revLst>
-    <p1510:client id="{AF643C40-E432-453B-92F5-60AF84F2336E}" v="4" dt="2025-10-09T21:24:32.175"/>
+    <p1510:client id="{F9040EC5-5C17-4416-958D-6C97F8997C2B}" v="4" dt="2026-10-04T22:29:29.760"/>
   </p1510:revLst>
 </p1510:revInfo>
 </file>
@@ -170,55 +175,549 @@
 <file path=ppt/changesInfos/changesInfo1.xml><?xml version="1.0" encoding="utf-8"?>
 <pc:chgInfo xmlns:a="http://schemas.openxmlformats.org/drawingml/2006/main" xmlns:r="http://schemas.openxmlformats.org/officeDocument/2006/relationships" xmlns:ac="http://schemas.microsoft.com/office/drawing/2013/main/command" xmlns:pc="http://schemas.microsoft.com/office/powerpoint/2013/main/command">
   <pc:docChgLst>
-    <pc:chgData name="Daniel Cregg" userId="a4417ebc-d1f9-4266-8a6c-2c7f21bbea7f" providerId="ADAL" clId="{AF643C40-E432-453B-92F5-60AF84F2336E}"/>
-    <pc:docChg chg="addSld modSld">
-      <pc:chgData name="Daniel Cregg" userId="a4417ebc-d1f9-4266-8a6c-2c7f21bbea7f" providerId="ADAL" clId="{AF643C40-E432-453B-92F5-60AF84F2336E}" dt="2025-10-09T21:24:34.582" v="83" actId="6549"/>
+    <pc:chgData name="Daniel Cregg" userId="a4417ebc-d1f9-4266-8a6c-2c7f21bbea7f" providerId="ADAL" clId="{B41FF6A5-8EE3-453F-9467-07EDEFDD4E20}"/>
+    <pc:docChg chg="custSel modSld">
+      <pc:chgData name="Daniel Cregg" userId="a4417ebc-d1f9-4266-8a6c-2c7f21bbea7f" providerId="ADAL" clId="{B41FF6A5-8EE3-453F-9467-07EDEFDD4E20}" dt="2026-10-04T22:29:29.760" v="47" actId="122"/>
       <pc:docMkLst>
         <pc:docMk/>
       </pc:docMkLst>
-      <pc:sldChg chg="modSp new mod">
-        <pc:chgData name="Daniel Cregg" userId="a4417ebc-d1f9-4266-8a6c-2c7f21bbea7f" providerId="ADAL" clId="{AF643C40-E432-453B-92F5-60AF84F2336E}" dt="2025-10-09T21:24:11.088" v="47" actId="20577"/>
+      <pc:sldChg chg="modSp modAnim">
+        <pc:chgData name="Daniel Cregg" userId="a4417ebc-d1f9-4266-8a6c-2c7f21bbea7f" providerId="ADAL" clId="{B41FF6A5-8EE3-453F-9467-07EDEFDD4E20}" dt="2026-10-04T22:29:29.760" v="47" actId="122"/>
         <pc:sldMkLst>
           <pc:docMk/>
-          <pc:sldMk cId="3497088910" sldId="256"/>
+          <pc:sldMk cId="0" sldId="257"/>
         </pc:sldMkLst>
         <pc:spChg chg="mod">
-          <ac:chgData name="Daniel Cregg" userId="a4417ebc-d1f9-4266-8a6c-2c7f21bbea7f" providerId="ADAL" clId="{AF643C40-E432-453B-92F5-60AF84F2336E}" dt="2025-10-09T21:24:03.176" v="22" actId="20577"/>
+          <ac:chgData name="Daniel Cregg" userId="a4417ebc-d1f9-4266-8a6c-2c7f21bbea7f" providerId="ADAL" clId="{B41FF6A5-8EE3-453F-9467-07EDEFDD4E20}" dt="2026-10-04T22:29:29.760" v="47" actId="122"/>
           <ac:spMkLst>
             <pc:docMk/>
-            <pc:sldMk cId="3497088910" sldId="256"/>
-            <ac:spMk id="2" creationId="{F2D37440-44C7-9EA2-81BB-0250D2A15B73}"/>
+            <pc:sldMk cId="0" sldId="257"/>
+            <ac:spMk id="3" creationId="{00000000-0000-0000-0000-000000000000}"/>
+          </ac:spMkLst>
+        </pc:spChg>
+      </pc:sldChg>
+      <pc:sldChg chg="modSp mod">
+        <pc:chgData name="Daniel Cregg" userId="a4417ebc-d1f9-4266-8a6c-2c7f21bbea7f" providerId="ADAL" clId="{B41FF6A5-8EE3-453F-9467-07EDEFDD4E20}" dt="2026-10-04T22:29:17.530" v="4" actId="27636"/>
+        <pc:sldMkLst>
+          <pc:docMk/>
+          <pc:sldMk cId="0" sldId="258"/>
+        </pc:sldMkLst>
+        <pc:spChg chg="mod">
+          <ac:chgData name="Daniel Cregg" userId="a4417ebc-d1f9-4266-8a6c-2c7f21bbea7f" providerId="ADAL" clId="{B41FF6A5-8EE3-453F-9467-07EDEFDD4E20}" dt="2026-10-04T22:29:17.530" v="2" actId="27636"/>
+          <ac:spMkLst>
+            <pc:docMk/>
+            <pc:sldMk cId="0" sldId="258"/>
+            <ac:spMk id="4" creationId="{00000000-0000-0000-0000-000000000000}"/>
           </ac:spMkLst>
         </pc:spChg>
         <pc:spChg chg="mod">
-          <ac:chgData name="Daniel Cregg" userId="a4417ebc-d1f9-4266-8a6c-2c7f21bbea7f" providerId="ADAL" clId="{AF643C40-E432-453B-92F5-60AF84F2336E}" dt="2025-10-09T21:24:11.088" v="47" actId="20577"/>
+          <ac:chgData name="Daniel Cregg" userId="a4417ebc-d1f9-4266-8a6c-2c7f21bbea7f" providerId="ADAL" clId="{B41FF6A5-8EE3-453F-9467-07EDEFDD4E20}" dt="2026-10-04T22:29:17.530" v="3" actId="27636"/>
           <ac:spMkLst>
             <pc:docMk/>
-            <pc:sldMk cId="3497088910" sldId="256"/>
-            <ac:spMk id="3" creationId="{4397FD6A-9BDB-EFA7-CAB2-E629A2C9718C}"/>
+            <pc:sldMk cId="0" sldId="258"/>
+            <ac:spMk id="6" creationId="{00000000-0000-0000-0000-000000000000}"/>
+          </ac:spMkLst>
+        </pc:spChg>
+        <pc:spChg chg="mod">
+          <ac:chgData name="Daniel Cregg" userId="a4417ebc-d1f9-4266-8a6c-2c7f21bbea7f" providerId="ADAL" clId="{B41FF6A5-8EE3-453F-9467-07EDEFDD4E20}" dt="2026-10-04T22:29:17.530" v="4" actId="27636"/>
+          <ac:spMkLst>
+            <pc:docMk/>
+            <pc:sldMk cId="0" sldId="258"/>
+            <ac:spMk id="7" creationId="{00000000-0000-0000-0000-000000000000}"/>
           </ac:spMkLst>
         </pc:spChg>
       </pc:sldChg>
-      <pc:sldChg chg="modSp new mod">
-        <pc:chgData name="Daniel Cregg" userId="a4417ebc-d1f9-4266-8a6c-2c7f21bbea7f" providerId="ADAL" clId="{AF643C40-E432-453B-92F5-60AF84F2336E}" dt="2025-10-09T21:24:34.582" v="83" actId="6549"/>
+      <pc:sldChg chg="modSp mod">
+        <pc:chgData name="Daniel Cregg" userId="a4417ebc-d1f9-4266-8a6c-2c7f21bbea7f" providerId="ADAL" clId="{B41FF6A5-8EE3-453F-9467-07EDEFDD4E20}" dt="2026-10-04T22:29:17.586" v="7" actId="27636"/>
         <pc:sldMkLst>
           <pc:docMk/>
-          <pc:sldMk cId="1135524420" sldId="257"/>
+          <pc:sldMk cId="0" sldId="259"/>
         </pc:sldMkLst>
         <pc:spChg chg="mod">
-          <ac:chgData name="Daniel Cregg" userId="a4417ebc-d1f9-4266-8a6c-2c7f21bbea7f" providerId="ADAL" clId="{AF643C40-E432-453B-92F5-60AF84F2336E}" dt="2025-10-09T21:24:19.752" v="60" actId="20577"/>
+          <ac:chgData name="Daniel Cregg" userId="a4417ebc-d1f9-4266-8a6c-2c7f21bbea7f" providerId="ADAL" clId="{B41FF6A5-8EE3-453F-9467-07EDEFDD4E20}" dt="2026-10-04T22:29:17.586" v="7" actId="27636"/>
           <ac:spMkLst>
             <pc:docMk/>
-            <pc:sldMk cId="1135524420" sldId="257"/>
-            <ac:spMk id="2" creationId="{C30C990F-C0FF-6121-03C7-FCDD7E7BBDBB}"/>
+            <pc:sldMk cId="0" sldId="259"/>
+            <ac:spMk id="4" creationId="{00000000-0000-0000-0000-000000000000}"/>
           </ac:spMkLst>
         </pc:spChg>
         <pc:spChg chg="mod">
-          <ac:chgData name="Daniel Cregg" userId="a4417ebc-d1f9-4266-8a6c-2c7f21bbea7f" providerId="ADAL" clId="{AF643C40-E432-453B-92F5-60AF84F2336E}" dt="2025-10-09T21:24:34.582" v="83" actId="6549"/>
+          <ac:chgData name="Daniel Cregg" userId="a4417ebc-d1f9-4266-8a6c-2c7f21bbea7f" providerId="ADAL" clId="{B41FF6A5-8EE3-453F-9467-07EDEFDD4E20}" dt="2026-10-04T22:29:17.585" v="6" actId="27636"/>
           <ac:spMkLst>
             <pc:docMk/>
-            <pc:sldMk cId="1135524420" sldId="257"/>
-            <ac:spMk id="3" creationId="{5C7784A8-CFDD-8862-CFCD-414464AEBDF5}"/>
+            <pc:sldMk cId="0" sldId="259"/>
+            <ac:spMk id="6" creationId="{00000000-0000-0000-0000-000000000000}"/>
+          </ac:spMkLst>
+        </pc:spChg>
+      </pc:sldChg>
+      <pc:sldChg chg="modSp mod">
+        <pc:chgData name="Daniel Cregg" userId="a4417ebc-d1f9-4266-8a6c-2c7f21bbea7f" providerId="ADAL" clId="{B41FF6A5-8EE3-453F-9467-07EDEFDD4E20}" dt="2026-10-04T22:29:17.638" v="10" actId="27636"/>
+        <pc:sldMkLst>
+          <pc:docMk/>
+          <pc:sldMk cId="0" sldId="262"/>
+        </pc:sldMkLst>
+        <pc:spChg chg="mod">
+          <ac:chgData name="Daniel Cregg" userId="a4417ebc-d1f9-4266-8a6c-2c7f21bbea7f" providerId="ADAL" clId="{B41FF6A5-8EE3-453F-9467-07EDEFDD4E20}" dt="2026-10-04T22:29:17.638" v="8" actId="27636"/>
+          <ac:spMkLst>
+            <pc:docMk/>
+            <pc:sldMk cId="0" sldId="262"/>
+            <ac:spMk id="4" creationId="{00000000-0000-0000-0000-000000000000}"/>
+          </ac:spMkLst>
+        </pc:spChg>
+        <pc:spChg chg="mod">
+          <ac:chgData name="Daniel Cregg" userId="a4417ebc-d1f9-4266-8a6c-2c7f21bbea7f" providerId="ADAL" clId="{B41FF6A5-8EE3-453F-9467-07EDEFDD4E20}" dt="2026-10-04T22:29:17.638" v="9" actId="27636"/>
+          <ac:spMkLst>
+            <pc:docMk/>
+            <pc:sldMk cId="0" sldId="262"/>
+            <ac:spMk id="6" creationId="{00000000-0000-0000-0000-000000000000}"/>
+          </ac:spMkLst>
+        </pc:spChg>
+        <pc:spChg chg="mod">
+          <ac:chgData name="Daniel Cregg" userId="a4417ebc-d1f9-4266-8a6c-2c7f21bbea7f" providerId="ADAL" clId="{B41FF6A5-8EE3-453F-9467-07EDEFDD4E20}" dt="2026-10-04T22:29:17.638" v="10" actId="27636"/>
+          <ac:spMkLst>
+            <pc:docMk/>
+            <pc:sldMk cId="0" sldId="262"/>
+            <ac:spMk id="7" creationId="{00000000-0000-0000-0000-000000000000}"/>
+          </ac:spMkLst>
+        </pc:spChg>
+      </pc:sldChg>
+      <pc:sldChg chg="modSp mod">
+        <pc:chgData name="Daniel Cregg" userId="a4417ebc-d1f9-4266-8a6c-2c7f21bbea7f" providerId="ADAL" clId="{B41FF6A5-8EE3-453F-9467-07EDEFDD4E20}" dt="2026-10-04T22:29:17.686" v="11" actId="27636"/>
+        <pc:sldMkLst>
+          <pc:docMk/>
+          <pc:sldMk cId="0" sldId="263"/>
+        </pc:sldMkLst>
+        <pc:spChg chg="mod">
+          <ac:chgData name="Daniel Cregg" userId="a4417ebc-d1f9-4266-8a6c-2c7f21bbea7f" providerId="ADAL" clId="{B41FF6A5-8EE3-453F-9467-07EDEFDD4E20}" dt="2026-10-04T22:29:17.686" v="11" actId="27636"/>
+          <ac:spMkLst>
+            <pc:docMk/>
+            <pc:sldMk cId="0" sldId="263"/>
+            <ac:spMk id="3" creationId="{00000000-0000-0000-0000-000000000000}"/>
+          </ac:spMkLst>
+        </pc:spChg>
+      </pc:sldChg>
+      <pc:sldChg chg="modSp mod">
+        <pc:chgData name="Daniel Cregg" userId="a4417ebc-d1f9-4266-8a6c-2c7f21bbea7f" providerId="ADAL" clId="{B41FF6A5-8EE3-453F-9467-07EDEFDD4E20}" dt="2026-10-04T22:29:17.770" v="12" actId="27636"/>
+        <pc:sldMkLst>
+          <pc:docMk/>
+          <pc:sldMk cId="0" sldId="264"/>
+        </pc:sldMkLst>
+        <pc:spChg chg="mod">
+          <ac:chgData name="Daniel Cregg" userId="a4417ebc-d1f9-4266-8a6c-2c7f21bbea7f" providerId="ADAL" clId="{B41FF6A5-8EE3-453F-9467-07EDEFDD4E20}" dt="2026-10-04T22:29:17.770" v="12" actId="27636"/>
+          <ac:spMkLst>
+            <pc:docMk/>
+            <pc:sldMk cId="0" sldId="264"/>
+            <ac:spMk id="3" creationId="{00000000-0000-0000-0000-000000000000}"/>
+          </ac:spMkLst>
+        </pc:spChg>
+      </pc:sldChg>
+      <pc:sldChg chg="modSp mod">
+        <pc:chgData name="Daniel Cregg" userId="a4417ebc-d1f9-4266-8a6c-2c7f21bbea7f" providerId="ADAL" clId="{B41FF6A5-8EE3-453F-9467-07EDEFDD4E20}" dt="2026-10-04T22:29:17.833" v="13" actId="27636"/>
+        <pc:sldMkLst>
+          <pc:docMk/>
+          <pc:sldMk cId="0" sldId="269"/>
+        </pc:sldMkLst>
+        <pc:spChg chg="mod">
+          <ac:chgData name="Daniel Cregg" userId="a4417ebc-d1f9-4266-8a6c-2c7f21bbea7f" providerId="ADAL" clId="{B41FF6A5-8EE3-453F-9467-07EDEFDD4E20}" dt="2026-10-04T22:29:17.833" v="13" actId="27636"/>
+          <ac:spMkLst>
+            <pc:docMk/>
+            <pc:sldMk cId="0" sldId="269"/>
+            <ac:spMk id="3" creationId="{00000000-0000-0000-0000-000000000000}"/>
+          </ac:spMkLst>
+        </pc:spChg>
+      </pc:sldChg>
+      <pc:sldChg chg="modSp mod">
+        <pc:chgData name="Daniel Cregg" userId="a4417ebc-d1f9-4266-8a6c-2c7f21bbea7f" providerId="ADAL" clId="{B41FF6A5-8EE3-453F-9467-07EDEFDD4E20}" dt="2026-10-04T22:29:18.093" v="14" actId="27636"/>
+        <pc:sldMkLst>
+          <pc:docMk/>
+          <pc:sldMk cId="0" sldId="270"/>
+        </pc:sldMkLst>
+        <pc:spChg chg="mod">
+          <ac:chgData name="Daniel Cregg" userId="a4417ebc-d1f9-4266-8a6c-2c7f21bbea7f" providerId="ADAL" clId="{B41FF6A5-8EE3-453F-9467-07EDEFDD4E20}" dt="2026-10-04T22:29:18.093" v="14" actId="27636"/>
+          <ac:spMkLst>
+            <pc:docMk/>
+            <pc:sldMk cId="0" sldId="270"/>
+            <ac:spMk id="3" creationId="{00000000-0000-0000-0000-000000000000}"/>
+          </ac:spMkLst>
+        </pc:spChg>
+      </pc:sldChg>
+      <pc:sldChg chg="modSp mod">
+        <pc:chgData name="Daniel Cregg" userId="a4417ebc-d1f9-4266-8a6c-2c7f21bbea7f" providerId="ADAL" clId="{B41FF6A5-8EE3-453F-9467-07EDEFDD4E20}" dt="2026-10-04T22:29:18.272" v="15" actId="27636"/>
+        <pc:sldMkLst>
+          <pc:docMk/>
+          <pc:sldMk cId="0" sldId="272"/>
+        </pc:sldMkLst>
+        <pc:spChg chg="mod">
+          <ac:chgData name="Daniel Cregg" userId="a4417ebc-d1f9-4266-8a6c-2c7f21bbea7f" providerId="ADAL" clId="{B41FF6A5-8EE3-453F-9467-07EDEFDD4E20}" dt="2026-10-04T22:29:18.272" v="15" actId="27636"/>
+          <ac:spMkLst>
+            <pc:docMk/>
+            <pc:sldMk cId="0" sldId="272"/>
+            <ac:spMk id="3" creationId="{00000000-0000-0000-0000-000000000000}"/>
+          </ac:spMkLst>
+        </pc:spChg>
+      </pc:sldChg>
+      <pc:sldChg chg="modSp mod">
+        <pc:chgData name="Daniel Cregg" userId="a4417ebc-d1f9-4266-8a6c-2c7f21bbea7f" providerId="ADAL" clId="{B41FF6A5-8EE3-453F-9467-07EDEFDD4E20}" dt="2026-10-04T22:29:18.387" v="16" actId="27636"/>
+        <pc:sldMkLst>
+          <pc:docMk/>
+          <pc:sldMk cId="0" sldId="273"/>
+        </pc:sldMkLst>
+        <pc:spChg chg="mod">
+          <ac:chgData name="Daniel Cregg" userId="a4417ebc-d1f9-4266-8a6c-2c7f21bbea7f" providerId="ADAL" clId="{B41FF6A5-8EE3-453F-9467-07EDEFDD4E20}" dt="2026-10-04T22:29:18.387" v="16" actId="27636"/>
+          <ac:spMkLst>
+            <pc:docMk/>
+            <pc:sldMk cId="0" sldId="273"/>
+            <ac:spMk id="3" creationId="{00000000-0000-0000-0000-000000000000}"/>
+          </ac:spMkLst>
+        </pc:spChg>
+      </pc:sldChg>
+      <pc:sldChg chg="modSp mod">
+        <pc:chgData name="Daniel Cregg" userId="a4417ebc-d1f9-4266-8a6c-2c7f21bbea7f" providerId="ADAL" clId="{B41FF6A5-8EE3-453F-9467-07EDEFDD4E20}" dt="2026-10-04T22:29:18.665" v="17" actId="27636"/>
+        <pc:sldMkLst>
+          <pc:docMk/>
+          <pc:sldMk cId="0" sldId="274"/>
+        </pc:sldMkLst>
+        <pc:spChg chg="mod">
+          <ac:chgData name="Daniel Cregg" userId="a4417ebc-d1f9-4266-8a6c-2c7f21bbea7f" providerId="ADAL" clId="{B41FF6A5-8EE3-453F-9467-07EDEFDD4E20}" dt="2026-10-04T22:29:18.665" v="17" actId="27636"/>
+          <ac:spMkLst>
+            <pc:docMk/>
+            <pc:sldMk cId="0" sldId="274"/>
+            <ac:spMk id="3" creationId="{00000000-0000-0000-0000-000000000000}"/>
+          </ac:spMkLst>
+        </pc:spChg>
+      </pc:sldChg>
+      <pc:sldChg chg="modSp mod">
+        <pc:chgData name="Daniel Cregg" userId="a4417ebc-d1f9-4266-8a6c-2c7f21bbea7f" providerId="ADAL" clId="{B41FF6A5-8EE3-453F-9467-07EDEFDD4E20}" dt="2026-10-04T22:29:18.934" v="18" actId="27636"/>
+        <pc:sldMkLst>
+          <pc:docMk/>
+          <pc:sldMk cId="0" sldId="277"/>
+        </pc:sldMkLst>
+        <pc:spChg chg="mod">
+          <ac:chgData name="Daniel Cregg" userId="a4417ebc-d1f9-4266-8a6c-2c7f21bbea7f" providerId="ADAL" clId="{B41FF6A5-8EE3-453F-9467-07EDEFDD4E20}" dt="2026-10-04T22:29:18.934" v="18" actId="27636"/>
+          <ac:spMkLst>
+            <pc:docMk/>
+            <pc:sldMk cId="0" sldId="277"/>
+            <ac:spMk id="3" creationId="{00000000-0000-0000-0000-000000000000}"/>
+          </ac:spMkLst>
+        </pc:spChg>
+      </pc:sldChg>
+      <pc:sldChg chg="modSp mod">
+        <pc:chgData name="Daniel Cregg" userId="a4417ebc-d1f9-4266-8a6c-2c7f21bbea7f" providerId="ADAL" clId="{B41FF6A5-8EE3-453F-9467-07EDEFDD4E20}" dt="2026-10-04T22:29:19.205" v="20" actId="27636"/>
+        <pc:sldMkLst>
+          <pc:docMk/>
+          <pc:sldMk cId="0" sldId="278"/>
+        </pc:sldMkLst>
+        <pc:spChg chg="mod">
+          <ac:chgData name="Daniel Cregg" userId="a4417ebc-d1f9-4266-8a6c-2c7f21bbea7f" providerId="ADAL" clId="{B41FF6A5-8EE3-453F-9467-07EDEFDD4E20}" dt="2026-10-04T22:29:19.205" v="20" actId="27636"/>
+          <ac:spMkLst>
+            <pc:docMk/>
+            <pc:sldMk cId="0" sldId="278"/>
+            <ac:spMk id="3" creationId="{00000000-0000-0000-0000-000000000000}"/>
+          </ac:spMkLst>
+        </pc:spChg>
+      </pc:sldChg>
+      <pc:sldChg chg="modSp mod">
+        <pc:chgData name="Daniel Cregg" userId="a4417ebc-d1f9-4266-8a6c-2c7f21bbea7f" providerId="ADAL" clId="{B41FF6A5-8EE3-453F-9467-07EDEFDD4E20}" dt="2026-10-04T22:29:19.489" v="21" actId="27636"/>
+        <pc:sldMkLst>
+          <pc:docMk/>
+          <pc:sldMk cId="0" sldId="280"/>
+        </pc:sldMkLst>
+        <pc:spChg chg="mod">
+          <ac:chgData name="Daniel Cregg" userId="a4417ebc-d1f9-4266-8a6c-2c7f21bbea7f" providerId="ADAL" clId="{B41FF6A5-8EE3-453F-9467-07EDEFDD4E20}" dt="2026-10-04T22:29:19.489" v="21" actId="27636"/>
+          <ac:spMkLst>
+            <pc:docMk/>
+            <pc:sldMk cId="0" sldId="280"/>
+            <ac:spMk id="3" creationId="{00000000-0000-0000-0000-000000000000}"/>
+          </ac:spMkLst>
+        </pc:spChg>
+      </pc:sldChg>
+      <pc:sldChg chg="modSp mod">
+        <pc:chgData name="Daniel Cregg" userId="a4417ebc-d1f9-4266-8a6c-2c7f21bbea7f" providerId="ADAL" clId="{B41FF6A5-8EE3-453F-9467-07EDEFDD4E20}" dt="2026-10-04T22:29:19.737" v="23" actId="27636"/>
+        <pc:sldMkLst>
+          <pc:docMk/>
+          <pc:sldMk cId="0" sldId="281"/>
+        </pc:sldMkLst>
+        <pc:spChg chg="mod">
+          <ac:chgData name="Daniel Cregg" userId="a4417ebc-d1f9-4266-8a6c-2c7f21bbea7f" providerId="ADAL" clId="{B41FF6A5-8EE3-453F-9467-07EDEFDD4E20}" dt="2026-10-04T22:29:19.737" v="22" actId="27636"/>
+          <ac:spMkLst>
+            <pc:docMk/>
+            <pc:sldMk cId="0" sldId="281"/>
+            <ac:spMk id="4" creationId="{00000000-0000-0000-0000-000000000000}"/>
+          </ac:spMkLst>
+        </pc:spChg>
+        <pc:spChg chg="mod">
+          <ac:chgData name="Daniel Cregg" userId="a4417ebc-d1f9-4266-8a6c-2c7f21bbea7f" providerId="ADAL" clId="{B41FF6A5-8EE3-453F-9467-07EDEFDD4E20}" dt="2026-10-04T22:29:19.737" v="23" actId="27636"/>
+          <ac:spMkLst>
+            <pc:docMk/>
+            <pc:sldMk cId="0" sldId="281"/>
+            <ac:spMk id="6" creationId="{00000000-0000-0000-0000-000000000000}"/>
+          </ac:spMkLst>
+        </pc:spChg>
+      </pc:sldChg>
+      <pc:sldChg chg="modSp mod">
+        <pc:chgData name="Daniel Cregg" userId="a4417ebc-d1f9-4266-8a6c-2c7f21bbea7f" providerId="ADAL" clId="{B41FF6A5-8EE3-453F-9467-07EDEFDD4E20}" dt="2026-10-04T22:29:19.994" v="24" actId="27636"/>
+        <pc:sldMkLst>
+          <pc:docMk/>
+          <pc:sldMk cId="0" sldId="282"/>
+        </pc:sldMkLst>
+        <pc:spChg chg="mod">
+          <ac:chgData name="Daniel Cregg" userId="a4417ebc-d1f9-4266-8a6c-2c7f21bbea7f" providerId="ADAL" clId="{B41FF6A5-8EE3-453F-9467-07EDEFDD4E20}" dt="2026-10-04T22:29:19.994" v="24" actId="27636"/>
+          <ac:spMkLst>
+            <pc:docMk/>
+            <pc:sldMk cId="0" sldId="282"/>
+            <ac:spMk id="7" creationId="{00000000-0000-0000-0000-000000000000}"/>
+          </ac:spMkLst>
+        </pc:spChg>
+      </pc:sldChg>
+      <pc:sldChg chg="modSp mod">
+        <pc:chgData name="Daniel Cregg" userId="a4417ebc-d1f9-4266-8a6c-2c7f21bbea7f" providerId="ADAL" clId="{B41FF6A5-8EE3-453F-9467-07EDEFDD4E20}" dt="2026-10-04T22:29:20.270" v="25" actId="27636"/>
+        <pc:sldMkLst>
+          <pc:docMk/>
+          <pc:sldMk cId="0" sldId="284"/>
+        </pc:sldMkLst>
+        <pc:spChg chg="mod">
+          <ac:chgData name="Daniel Cregg" userId="a4417ebc-d1f9-4266-8a6c-2c7f21bbea7f" providerId="ADAL" clId="{B41FF6A5-8EE3-453F-9467-07EDEFDD4E20}" dt="2026-10-04T22:29:20.270" v="25" actId="27636"/>
+          <ac:spMkLst>
+            <pc:docMk/>
+            <pc:sldMk cId="0" sldId="284"/>
+            <ac:spMk id="3" creationId="{00000000-0000-0000-0000-000000000000}"/>
+          </ac:spMkLst>
+        </pc:spChg>
+      </pc:sldChg>
+      <pc:sldChg chg="modSp mod">
+        <pc:chgData name="Daniel Cregg" userId="a4417ebc-d1f9-4266-8a6c-2c7f21bbea7f" providerId="ADAL" clId="{B41FF6A5-8EE3-453F-9467-07EDEFDD4E20}" dt="2026-10-04T22:29:20.532" v="28" actId="27636"/>
+        <pc:sldMkLst>
+          <pc:docMk/>
+          <pc:sldMk cId="0" sldId="286"/>
+        </pc:sldMkLst>
+        <pc:spChg chg="mod">
+          <ac:chgData name="Daniel Cregg" userId="a4417ebc-d1f9-4266-8a6c-2c7f21bbea7f" providerId="ADAL" clId="{B41FF6A5-8EE3-453F-9467-07EDEFDD4E20}" dt="2026-10-04T22:29:20.530" v="26" actId="27636"/>
+          <ac:spMkLst>
+            <pc:docMk/>
+            <pc:sldMk cId="0" sldId="286"/>
+            <ac:spMk id="4" creationId="{00000000-0000-0000-0000-000000000000}"/>
+          </ac:spMkLst>
+        </pc:spChg>
+        <pc:spChg chg="mod">
+          <ac:chgData name="Daniel Cregg" userId="a4417ebc-d1f9-4266-8a6c-2c7f21bbea7f" providerId="ADAL" clId="{B41FF6A5-8EE3-453F-9467-07EDEFDD4E20}" dt="2026-10-04T22:29:20.530" v="27" actId="27636"/>
+          <ac:spMkLst>
+            <pc:docMk/>
+            <pc:sldMk cId="0" sldId="286"/>
+            <ac:spMk id="6" creationId="{00000000-0000-0000-0000-000000000000}"/>
+          </ac:spMkLst>
+        </pc:spChg>
+        <pc:spChg chg="mod">
+          <ac:chgData name="Daniel Cregg" userId="a4417ebc-d1f9-4266-8a6c-2c7f21bbea7f" providerId="ADAL" clId="{B41FF6A5-8EE3-453F-9467-07EDEFDD4E20}" dt="2026-10-04T22:29:20.532" v="28" actId="27636"/>
+          <ac:spMkLst>
+            <pc:docMk/>
+            <pc:sldMk cId="0" sldId="286"/>
+            <ac:spMk id="7" creationId="{00000000-0000-0000-0000-000000000000}"/>
+          </ac:spMkLst>
+        </pc:spChg>
+      </pc:sldChg>
+      <pc:sldChg chg="modSp mod">
+        <pc:chgData name="Daniel Cregg" userId="a4417ebc-d1f9-4266-8a6c-2c7f21bbea7f" providerId="ADAL" clId="{B41FF6A5-8EE3-453F-9467-07EDEFDD4E20}" dt="2026-10-04T22:29:20.775" v="29" actId="27636"/>
+        <pc:sldMkLst>
+          <pc:docMk/>
+          <pc:sldMk cId="0" sldId="287"/>
+        </pc:sldMkLst>
+        <pc:spChg chg="mod">
+          <ac:chgData name="Daniel Cregg" userId="a4417ebc-d1f9-4266-8a6c-2c7f21bbea7f" providerId="ADAL" clId="{B41FF6A5-8EE3-453F-9467-07EDEFDD4E20}" dt="2026-10-04T22:29:20.775" v="29" actId="27636"/>
+          <ac:spMkLst>
+            <pc:docMk/>
+            <pc:sldMk cId="0" sldId="287"/>
+            <ac:spMk id="3" creationId="{00000000-0000-0000-0000-000000000000}"/>
+          </ac:spMkLst>
+        </pc:spChg>
+      </pc:sldChg>
+      <pc:sldChg chg="modSp mod">
+        <pc:chgData name="Daniel Cregg" userId="a4417ebc-d1f9-4266-8a6c-2c7f21bbea7f" providerId="ADAL" clId="{B41FF6A5-8EE3-453F-9467-07EDEFDD4E20}" dt="2026-10-04T22:29:21.051" v="32" actId="27636"/>
+        <pc:sldMkLst>
+          <pc:docMk/>
+          <pc:sldMk cId="0" sldId="297"/>
+        </pc:sldMkLst>
+        <pc:spChg chg="mod">
+          <ac:chgData name="Daniel Cregg" userId="a4417ebc-d1f9-4266-8a6c-2c7f21bbea7f" providerId="ADAL" clId="{B41FF6A5-8EE3-453F-9467-07EDEFDD4E20}" dt="2026-10-04T22:29:21.050" v="31" actId="27636"/>
+          <ac:spMkLst>
+            <pc:docMk/>
+            <pc:sldMk cId="0" sldId="297"/>
+            <ac:spMk id="4" creationId="{00000000-0000-0000-0000-000000000000}"/>
+          </ac:spMkLst>
+        </pc:spChg>
+        <pc:spChg chg="mod">
+          <ac:chgData name="Daniel Cregg" userId="a4417ebc-d1f9-4266-8a6c-2c7f21bbea7f" providerId="ADAL" clId="{B41FF6A5-8EE3-453F-9467-07EDEFDD4E20}" dt="2026-10-04T22:29:21.051" v="32" actId="27636"/>
+          <ac:spMkLst>
+            <pc:docMk/>
+            <pc:sldMk cId="0" sldId="297"/>
+            <ac:spMk id="6" creationId="{00000000-0000-0000-0000-000000000000}"/>
+          </ac:spMkLst>
+        </pc:spChg>
+        <pc:spChg chg="mod">
+          <ac:chgData name="Daniel Cregg" userId="a4417ebc-d1f9-4266-8a6c-2c7f21bbea7f" providerId="ADAL" clId="{B41FF6A5-8EE3-453F-9467-07EDEFDD4E20}" dt="2026-10-04T22:29:21.047" v="30" actId="27636"/>
+          <ac:spMkLst>
+            <pc:docMk/>
+            <pc:sldMk cId="0" sldId="297"/>
+            <ac:spMk id="7" creationId="{00000000-0000-0000-0000-000000000000}"/>
+          </ac:spMkLst>
+        </pc:spChg>
+      </pc:sldChg>
+      <pc:sldChg chg="modSp mod">
+        <pc:chgData name="Daniel Cregg" userId="a4417ebc-d1f9-4266-8a6c-2c7f21bbea7f" providerId="ADAL" clId="{B41FF6A5-8EE3-453F-9467-07EDEFDD4E20}" dt="2026-10-04T22:29:21.303" v="34" actId="27636"/>
+        <pc:sldMkLst>
+          <pc:docMk/>
+          <pc:sldMk cId="0" sldId="299"/>
+        </pc:sldMkLst>
+        <pc:spChg chg="mod">
+          <ac:chgData name="Daniel Cregg" userId="a4417ebc-d1f9-4266-8a6c-2c7f21bbea7f" providerId="ADAL" clId="{B41FF6A5-8EE3-453F-9467-07EDEFDD4E20}" dt="2026-10-04T22:29:21.303" v="34" actId="27636"/>
+          <ac:spMkLst>
+            <pc:docMk/>
+            <pc:sldMk cId="0" sldId="299"/>
+            <ac:spMk id="4" creationId="{00000000-0000-0000-0000-000000000000}"/>
+          </ac:spMkLst>
+        </pc:spChg>
+        <pc:spChg chg="mod">
+          <ac:chgData name="Daniel Cregg" userId="a4417ebc-d1f9-4266-8a6c-2c7f21bbea7f" providerId="ADAL" clId="{B41FF6A5-8EE3-453F-9467-07EDEFDD4E20}" dt="2026-10-04T22:29:21.301" v="33" actId="27636"/>
+          <ac:spMkLst>
+            <pc:docMk/>
+            <pc:sldMk cId="0" sldId="299"/>
+            <ac:spMk id="6" creationId="{00000000-0000-0000-0000-000000000000}"/>
+          </ac:spMkLst>
+        </pc:spChg>
+      </pc:sldChg>
+      <pc:sldChg chg="modSp mod">
+        <pc:chgData name="Daniel Cregg" userId="a4417ebc-d1f9-4266-8a6c-2c7f21bbea7f" providerId="ADAL" clId="{B41FF6A5-8EE3-453F-9467-07EDEFDD4E20}" dt="2026-10-04T22:29:21.479" v="35" actId="27636"/>
+        <pc:sldMkLst>
+          <pc:docMk/>
+          <pc:sldMk cId="0" sldId="300"/>
+        </pc:sldMkLst>
+        <pc:spChg chg="mod">
+          <ac:chgData name="Daniel Cregg" userId="a4417ebc-d1f9-4266-8a6c-2c7f21bbea7f" providerId="ADAL" clId="{B41FF6A5-8EE3-453F-9467-07EDEFDD4E20}" dt="2026-10-04T22:29:21.479" v="35" actId="27636"/>
+          <ac:spMkLst>
+            <pc:docMk/>
+            <pc:sldMk cId="0" sldId="300"/>
+            <ac:spMk id="3" creationId="{00000000-0000-0000-0000-000000000000}"/>
+          </ac:spMkLst>
+        </pc:spChg>
+      </pc:sldChg>
+      <pc:sldChg chg="modSp mod">
+        <pc:chgData name="Daniel Cregg" userId="a4417ebc-d1f9-4266-8a6c-2c7f21bbea7f" providerId="ADAL" clId="{B41FF6A5-8EE3-453F-9467-07EDEFDD4E20}" dt="2026-10-04T22:29:21.576" v="38" actId="27636"/>
+        <pc:sldMkLst>
+          <pc:docMk/>
+          <pc:sldMk cId="0" sldId="301"/>
+        </pc:sldMkLst>
+        <pc:spChg chg="mod">
+          <ac:chgData name="Daniel Cregg" userId="a4417ebc-d1f9-4266-8a6c-2c7f21bbea7f" providerId="ADAL" clId="{B41FF6A5-8EE3-453F-9467-07EDEFDD4E20}" dt="2026-10-04T22:29:21.574" v="37" actId="27636"/>
+          <ac:spMkLst>
+            <pc:docMk/>
+            <pc:sldMk cId="0" sldId="301"/>
+            <ac:spMk id="4" creationId="{00000000-0000-0000-0000-000000000000}"/>
+          </ac:spMkLst>
+        </pc:spChg>
+        <pc:spChg chg="mod">
+          <ac:chgData name="Daniel Cregg" userId="a4417ebc-d1f9-4266-8a6c-2c7f21bbea7f" providerId="ADAL" clId="{B41FF6A5-8EE3-453F-9467-07EDEFDD4E20}" dt="2026-10-04T22:29:21.576" v="38" actId="27636"/>
+          <ac:spMkLst>
+            <pc:docMk/>
+            <pc:sldMk cId="0" sldId="301"/>
+            <ac:spMk id="6" creationId="{00000000-0000-0000-0000-000000000000}"/>
+          </ac:spMkLst>
+        </pc:spChg>
+        <pc:spChg chg="mod">
+          <ac:chgData name="Daniel Cregg" userId="a4417ebc-d1f9-4266-8a6c-2c7f21bbea7f" providerId="ADAL" clId="{B41FF6A5-8EE3-453F-9467-07EDEFDD4E20}" dt="2026-10-04T22:29:21.570" v="36" actId="27636"/>
+          <ac:spMkLst>
+            <pc:docMk/>
+            <pc:sldMk cId="0" sldId="301"/>
+            <ac:spMk id="7" creationId="{00000000-0000-0000-0000-000000000000}"/>
+          </ac:spMkLst>
+        </pc:spChg>
+      </pc:sldChg>
+      <pc:sldChg chg="modSp mod">
+        <pc:chgData name="Daniel Cregg" userId="a4417ebc-d1f9-4266-8a6c-2c7f21bbea7f" providerId="ADAL" clId="{B41FF6A5-8EE3-453F-9467-07EDEFDD4E20}" dt="2026-10-04T22:29:21.839" v="39" actId="27636"/>
+        <pc:sldMkLst>
+          <pc:docMk/>
+          <pc:sldMk cId="0" sldId="302"/>
+        </pc:sldMkLst>
+        <pc:spChg chg="mod">
+          <ac:chgData name="Daniel Cregg" userId="a4417ebc-d1f9-4266-8a6c-2c7f21bbea7f" providerId="ADAL" clId="{B41FF6A5-8EE3-453F-9467-07EDEFDD4E20}" dt="2026-10-04T22:29:21.839" v="39" actId="27636"/>
+          <ac:spMkLst>
+            <pc:docMk/>
+            <pc:sldMk cId="0" sldId="302"/>
+            <ac:spMk id="3" creationId="{00000000-0000-0000-0000-000000000000}"/>
+          </ac:spMkLst>
+        </pc:spChg>
+      </pc:sldChg>
+      <pc:sldChg chg="modSp mod">
+        <pc:chgData name="Daniel Cregg" userId="a4417ebc-d1f9-4266-8a6c-2c7f21bbea7f" providerId="ADAL" clId="{B41FF6A5-8EE3-453F-9467-07EDEFDD4E20}" dt="2026-10-04T22:29:22.012" v="41" actId="27636"/>
+        <pc:sldMkLst>
+          <pc:docMk/>
+          <pc:sldMk cId="0" sldId="305"/>
+        </pc:sldMkLst>
+        <pc:spChg chg="mod">
+          <ac:chgData name="Daniel Cregg" userId="a4417ebc-d1f9-4266-8a6c-2c7f21bbea7f" providerId="ADAL" clId="{B41FF6A5-8EE3-453F-9467-07EDEFDD4E20}" dt="2026-10-04T22:29:22.009" v="40" actId="27636"/>
+          <ac:spMkLst>
+            <pc:docMk/>
+            <pc:sldMk cId="0" sldId="305"/>
+            <ac:spMk id="3" creationId="{00000000-0000-0000-0000-000000000000}"/>
+          </ac:spMkLst>
+        </pc:spChg>
+        <pc:spChg chg="mod">
+          <ac:chgData name="Daniel Cregg" userId="a4417ebc-d1f9-4266-8a6c-2c7f21bbea7f" providerId="ADAL" clId="{B41FF6A5-8EE3-453F-9467-07EDEFDD4E20}" dt="2026-10-04T22:29:22.012" v="41" actId="27636"/>
+          <ac:spMkLst>
+            <pc:docMk/>
+            <pc:sldMk cId="0" sldId="305"/>
+            <ac:spMk id="5" creationId="{00000000-0000-0000-0000-000000000000}"/>
+          </ac:spMkLst>
+        </pc:spChg>
+      </pc:sldChg>
+      <pc:sldChg chg="modSp mod">
+        <pc:chgData name="Daniel Cregg" userId="a4417ebc-d1f9-4266-8a6c-2c7f21bbea7f" providerId="ADAL" clId="{B41FF6A5-8EE3-453F-9467-07EDEFDD4E20}" dt="2026-10-04T22:29:22.120" v="42" actId="27636"/>
+        <pc:sldMkLst>
+          <pc:docMk/>
+          <pc:sldMk cId="0" sldId="306"/>
+        </pc:sldMkLst>
+        <pc:spChg chg="mod">
+          <ac:chgData name="Daniel Cregg" userId="a4417ebc-d1f9-4266-8a6c-2c7f21bbea7f" providerId="ADAL" clId="{B41FF6A5-8EE3-453F-9467-07EDEFDD4E20}" dt="2026-10-04T22:29:22.120" v="42" actId="27636"/>
+          <ac:spMkLst>
+            <pc:docMk/>
+            <pc:sldMk cId="0" sldId="306"/>
+            <ac:spMk id="3" creationId="{00000000-0000-0000-0000-000000000000}"/>
+          </ac:spMkLst>
+        </pc:spChg>
+      </pc:sldChg>
+      <pc:sldChg chg="modSp mod">
+        <pc:chgData name="Daniel Cregg" userId="a4417ebc-d1f9-4266-8a6c-2c7f21bbea7f" providerId="ADAL" clId="{B41FF6A5-8EE3-453F-9467-07EDEFDD4E20}" dt="2026-10-04T22:29:22.795" v="44" actId="27636"/>
+        <pc:sldMkLst>
+          <pc:docMk/>
+          <pc:sldMk cId="0" sldId="307"/>
+        </pc:sldMkLst>
+        <pc:spChg chg="mod">
+          <ac:chgData name="Daniel Cregg" userId="a4417ebc-d1f9-4266-8a6c-2c7f21bbea7f" providerId="ADAL" clId="{B41FF6A5-8EE3-453F-9467-07EDEFDD4E20}" dt="2026-10-04T22:29:22.795" v="44" actId="27636"/>
+          <ac:spMkLst>
+            <pc:docMk/>
+            <pc:sldMk cId="0" sldId="307"/>
+            <ac:spMk id="4" creationId="{00000000-0000-0000-0000-000000000000}"/>
+          </ac:spMkLst>
+        </pc:spChg>
+        <pc:spChg chg="mod">
+          <ac:chgData name="Daniel Cregg" userId="a4417ebc-d1f9-4266-8a6c-2c7f21bbea7f" providerId="ADAL" clId="{B41FF6A5-8EE3-453F-9467-07EDEFDD4E20}" dt="2026-10-04T22:29:22.792" v="43" actId="27636"/>
+          <ac:spMkLst>
+            <pc:docMk/>
+            <pc:sldMk cId="0" sldId="307"/>
+            <ac:spMk id="6" creationId="{00000000-0000-0000-0000-000000000000}"/>
+          </ac:spMkLst>
+        </pc:spChg>
+      </pc:sldChg>
+      <pc:sldChg chg="modSp mod">
+        <pc:chgData name="Daniel Cregg" userId="a4417ebc-d1f9-4266-8a6c-2c7f21bbea7f" providerId="ADAL" clId="{B41FF6A5-8EE3-453F-9467-07EDEFDD4E20}" dt="2026-10-04T22:29:23.206" v="45" actId="27636"/>
+        <pc:sldMkLst>
+          <pc:docMk/>
+          <pc:sldMk cId="0" sldId="308"/>
+        </pc:sldMkLst>
+        <pc:spChg chg="mod">
+          <ac:chgData name="Daniel Cregg" userId="a4417ebc-d1f9-4266-8a6c-2c7f21bbea7f" providerId="ADAL" clId="{B41FF6A5-8EE3-453F-9467-07EDEFDD4E20}" dt="2026-10-04T22:29:23.206" v="45" actId="27636"/>
+          <ac:spMkLst>
+            <pc:docMk/>
+            <pc:sldMk cId="0" sldId="308"/>
+            <ac:spMk id="3" creationId="{00000000-0000-0000-0000-000000000000}"/>
           </ac:spMkLst>
         </pc:spChg>
       </pc:sldChg>
@@ -376,7 +875,7 @@
           <a:p>
             <a:fld id="{44A5CEE2-6E65-48D0-90B9-EB2BBC28F974}" type="datetimeFigureOut">
               <a:rPr lang="en-IE" smtClean="0"/>
-              <a:t>09/10/2025</a:t>
+              <a:t>04/10/2026</a:t>
             </a:fld>
             <a:endParaRPr lang="en-IE"/>
           </a:p>
@@ -576,7 +1075,7 @@
           <a:p>
             <a:fld id="{44A5CEE2-6E65-48D0-90B9-EB2BBC28F974}" type="datetimeFigureOut">
               <a:rPr lang="en-IE" smtClean="0"/>
-              <a:t>09/10/2025</a:t>
+              <a:t>04/10/2026</a:t>
             </a:fld>
             <a:endParaRPr lang="en-IE"/>
           </a:p>
@@ -786,7 +1285,7 @@
           <a:p>
             <a:fld id="{44A5CEE2-6E65-48D0-90B9-EB2BBC28F974}" type="datetimeFigureOut">
               <a:rPr lang="en-IE" smtClean="0"/>
-              <a:t>09/10/2025</a:t>
+              <a:t>04/10/2026</a:t>
             </a:fld>
             <a:endParaRPr lang="en-IE"/>
           </a:p>
@@ -986,7 +1485,7 @@
           <a:p>
             <a:fld id="{44A5CEE2-6E65-48D0-90B9-EB2BBC28F974}" type="datetimeFigureOut">
               <a:rPr lang="en-IE" smtClean="0"/>
-              <a:t>09/10/2025</a:t>
+              <a:t>04/10/2026</a:t>
             </a:fld>
             <a:endParaRPr lang="en-IE"/>
           </a:p>
@@ -1262,7 +1761,7 @@
           <a:p>
             <a:fld id="{44A5CEE2-6E65-48D0-90B9-EB2BBC28F974}" type="datetimeFigureOut">
               <a:rPr lang="en-IE" smtClean="0"/>
-              <a:t>09/10/2025</a:t>
+              <a:t>04/10/2026</a:t>
             </a:fld>
             <a:endParaRPr lang="en-IE"/>
           </a:p>
@@ -1530,7 +2029,7 @@
           <a:p>
             <a:fld id="{44A5CEE2-6E65-48D0-90B9-EB2BBC28F974}" type="datetimeFigureOut">
               <a:rPr lang="en-IE" smtClean="0"/>
-              <a:t>09/10/2025</a:t>
+              <a:t>04/10/2026</a:t>
             </a:fld>
             <a:endParaRPr lang="en-IE"/>
           </a:p>
@@ -1945,7 +2444,7 @@
           <a:p>
             <a:fld id="{44A5CEE2-6E65-48D0-90B9-EB2BBC28F974}" type="datetimeFigureOut">
               <a:rPr lang="en-IE" smtClean="0"/>
-              <a:t>09/10/2025</a:t>
+              <a:t>04/10/2026</a:t>
             </a:fld>
             <a:endParaRPr lang="en-IE"/>
           </a:p>
@@ -2087,7 +2586,7 @@
           <a:p>
             <a:fld id="{44A5CEE2-6E65-48D0-90B9-EB2BBC28F974}" type="datetimeFigureOut">
               <a:rPr lang="en-IE" smtClean="0"/>
-              <a:t>09/10/2025</a:t>
+              <a:t>04/10/2026</a:t>
             </a:fld>
             <a:endParaRPr lang="en-IE"/>
           </a:p>
@@ -2200,7 +2699,7 @@
           <a:p>
             <a:fld id="{44A5CEE2-6E65-48D0-90B9-EB2BBC28F974}" type="datetimeFigureOut">
               <a:rPr lang="en-IE" smtClean="0"/>
-              <a:t>09/10/2025</a:t>
+              <a:t>04/10/2026</a:t>
             </a:fld>
             <a:endParaRPr lang="en-IE"/>
           </a:p>
@@ -2513,7 +3012,7 @@
           <a:p>
             <a:fld id="{44A5CEE2-6E65-48D0-90B9-EB2BBC28F974}" type="datetimeFigureOut">
               <a:rPr lang="en-IE" smtClean="0"/>
-              <a:t>09/10/2025</a:t>
+              <a:t>04/10/2026</a:t>
             </a:fld>
             <a:endParaRPr lang="en-IE"/>
           </a:p>
@@ -2802,7 +3301,7 @@
           <a:p>
             <a:fld id="{44A5CEE2-6E65-48D0-90B9-EB2BBC28F974}" type="datetimeFigureOut">
               <a:rPr lang="en-IE" smtClean="0"/>
-              <a:t>09/10/2025</a:t>
+              <a:t>04/10/2026</a:t>
             </a:fld>
             <a:endParaRPr lang="en-IE"/>
           </a:p>
@@ -3045,7 +3544,7 @@
           <a:p>
             <a:fld id="{44A5CEE2-6E65-48D0-90B9-EB2BBC28F974}" type="datetimeFigureOut">
               <a:rPr lang="en-IE" smtClean="0"/>
-              <a:t>09/10/2025</a:t>
+              <a:t>04/10/2026</a:t>
             </a:fld>
             <a:endParaRPr lang="en-IE"/>
           </a:p>
@@ -3446,7 +3945,7 @@
 </file>
 
 <file path=ppt/slides/slide1.xml><?xml version="1.0" encoding="utf-8"?>
-<p:sld xmlns:a="http://schemas.openxmlformats.org/drawingml/2006/main" xmlns:p="http://schemas.openxmlformats.org/presentationml/2006/main" xmlns:r="http://schemas.openxmlformats.org/officeDocument/2006/relationships">
+<p:sld xmlns:a="http://schemas.openxmlformats.org/drawingml/2006/main" xmlns:r="http://schemas.openxmlformats.org/officeDocument/2006/relationships" xmlns:p="http://schemas.openxmlformats.org/presentationml/2006/main">
   <p:cSld>
     <p:spTree>
       <p:nvGrpSpPr>
@@ -3454,7 +3953,14 @@
         <p:cNvGrpSpPr/>
         <p:nvPr/>
       </p:nvGrpSpPr>
-      <p:grpSpPr/>
+      <p:grpSpPr>
+        <a:xfrm>
+          <a:off x="0" y="0"/>
+          <a:ext cx="0" cy="0"/>
+          <a:chOff x="0" y="0"/>
+          <a:chExt cx="0" cy="0"/>
+        </a:xfrm>
+      </p:grpSpPr>
       <p:sp>
         <p:nvSpPr>
           <p:cNvPr id="2" name="Title 1"/>
@@ -3508,7 +4014,7 @@
 </file>
 
 <file path=ppt/slides/slide10.xml><?xml version="1.0" encoding="utf-8"?>
-<p:sld xmlns:a="http://schemas.openxmlformats.org/drawingml/2006/main" xmlns:p="http://schemas.openxmlformats.org/presentationml/2006/main" xmlns:r="http://schemas.openxmlformats.org/officeDocument/2006/relationships">
+<p:sld xmlns:a="http://schemas.openxmlformats.org/drawingml/2006/main" xmlns:r="http://schemas.openxmlformats.org/officeDocument/2006/relationships" xmlns:p="http://schemas.openxmlformats.org/presentationml/2006/main">
   <p:cSld>
     <p:spTree>
       <p:nvGrpSpPr>
@@ -3516,7 +4022,14 @@
         <p:cNvGrpSpPr/>
         <p:nvPr/>
       </p:nvGrpSpPr>
-      <p:grpSpPr/>
+      <p:grpSpPr>
+        <a:xfrm>
+          <a:off x="0" y="0"/>
+          <a:ext cx="0" cy="0"/>
+          <a:chOff x="0" y="0"/>
+          <a:chExt cx="0" cy="0"/>
+        </a:xfrm>
+      </p:grpSpPr>
       <p:sp>
         <p:nvSpPr>
           <p:cNvPr id="2" name="Title 1"/>
@@ -3562,25 +4075,21 @@
           </a:bodyPr>
           <a:lstStyle/>
           <a:p>
-            <a:pPr/>
             <a:r>
               <a:t>Sources: PDFs, Word files, web pages, wikis, code, database rows</a:t>
             </a:r>
           </a:p>
           <a:p>
-            <a:pPr/>
             <a:r>
               <a:t>Extract plain text: pypdf, pdfplumber, BeautifulSoup, docx2txt</a:t>
             </a:r>
           </a:p>
           <a:p>
-            <a:pPr/>
             <a:r>
               <a:t>Clean it: headers, footers, page numbers, mangled tables</a:t>
             </a:r>
           </a:p>
           <a:p>
-            <a:pPr/>
             <a:r>
               <a:t>Record where every piece came from (file, page, section): citations need it later</a:t>
             </a:r>
@@ -3825,7 +4334,7 @@
 </file>
 
 <file path=ppt/slides/slide11.xml><?xml version="1.0" encoding="utf-8"?>
-<p:sld xmlns:a="http://schemas.openxmlformats.org/drawingml/2006/main" xmlns:p="http://schemas.openxmlformats.org/presentationml/2006/main" xmlns:r="http://schemas.openxmlformats.org/officeDocument/2006/relationships">
+<p:sld xmlns:a="http://schemas.openxmlformats.org/drawingml/2006/main" xmlns:r="http://schemas.openxmlformats.org/officeDocument/2006/relationships" xmlns:p="http://schemas.openxmlformats.org/presentationml/2006/main">
   <p:cSld>
     <p:spTree>
       <p:nvGrpSpPr>
@@ -3833,7 +4342,14 @@
         <p:cNvGrpSpPr/>
         <p:nvPr/>
       </p:nvGrpSpPr>
-      <p:grpSpPr/>
+      <p:grpSpPr>
+        <a:xfrm>
+          <a:off x="0" y="0"/>
+          <a:ext cx="0" cy="0"/>
+          <a:chOff x="0" y="0"/>
+          <a:chExt cx="0" cy="0"/>
+        </a:xfrm>
+      </p:grpSpPr>
       <p:sp>
         <p:nvSpPr>
           <p:cNvPr id="2" name="Title 1"/>
@@ -3879,31 +4395,26 @@
           </a:bodyPr>
           <a:lstStyle/>
           <a:p>
-            <a:pPr/>
             <a:r>
               <a:t>Split each document into pieces of a few hundred words</a:t>
             </a:r>
           </a:p>
           <a:p>
-            <a:pPr/>
             <a:r>
               <a:t>Why: an embedding sums up a whole piece of text, so one topic per piece keeps it sharp</a:t>
             </a:r>
           </a:p>
           <a:p>
-            <a:pPr/>
             <a:r>
               <a:t>Small pieces also mean several fit in one prompt</a:t>
             </a:r>
           </a:p>
           <a:p>
-            <a:pPr/>
             <a:r>
               <a:t>Overlap: neighbouring chunks share a few sentences, so a fact on a boundary survives whole</a:t>
             </a:r>
           </a:p>
           <a:p>
-            <a:pPr/>
             <a:r>
               <a:t>Strategies: fixed size, by sentence, by paragraph or heading, by topic shift, by function for code</a:t>
             </a:r>
@@ -4197,7 +4708,7 @@
 </file>
 
 <file path=ppt/slides/slide12.xml><?xml version="1.0" encoding="utf-8"?>
-<p:sld xmlns:a="http://schemas.openxmlformats.org/drawingml/2006/main" xmlns:p="http://schemas.openxmlformats.org/presentationml/2006/main" xmlns:r="http://schemas.openxmlformats.org/officeDocument/2006/relationships">
+<p:sld xmlns:a="http://schemas.openxmlformats.org/drawingml/2006/main" xmlns:r="http://schemas.openxmlformats.org/officeDocument/2006/relationships" xmlns:p="http://schemas.openxmlformats.org/presentationml/2006/main">
   <p:cSld>
     <p:spTree>
       <p:nvGrpSpPr>
@@ -4205,7 +4716,14 @@
         <p:cNvGrpSpPr/>
         <p:nvPr/>
       </p:nvGrpSpPr>
-      <p:grpSpPr/>
+      <p:grpSpPr>
+        <a:xfrm>
+          <a:off x="0" y="0"/>
+          <a:ext cx="0" cy="0"/>
+          <a:chOff x="0" y="0"/>
+          <a:chExt cx="0" cy="0"/>
+        </a:xfrm>
+      </p:grpSpPr>
       <p:sp>
         <p:nvSpPr>
           <p:cNvPr id="2" name="Title 1"/>
@@ -4282,7 +4800,7 @@
             </a:fontRef>
           </p:style>
           <p:txBody>
-            <a:bodyPr rtlCol="0" anchor="ctr" wrap="square" lIns="109728" rIns="109728" tIns="54864" bIns="54864">
+            <a:bodyPr wrap="square" lIns="109728" tIns="54864" rIns="109728" bIns="54864" rtlCol="0" anchor="ctr">
               <a:noAutofit/>
             </a:bodyPr>
             <a:lstStyle/>
@@ -4338,7 +4856,7 @@
             </a:fontRef>
           </p:style>
           <p:txBody>
-            <a:bodyPr rtlCol="0" anchor="ctr" wrap="square" lIns="109728" rIns="109728" tIns="54864" bIns="54864">
+            <a:bodyPr wrap="square" lIns="109728" tIns="54864" rIns="109728" bIns="54864" rtlCol="0" anchor="ctr">
               <a:noAutofit/>
             </a:bodyPr>
             <a:lstStyle/>
@@ -4394,7 +4912,7 @@
             </a:fontRef>
           </p:style>
           <p:txBody>
-            <a:bodyPr rtlCol="0" anchor="ctr" wrap="square" lIns="109728" rIns="109728" tIns="54864" bIns="54864">
+            <a:bodyPr wrap="square" lIns="109728" tIns="54864" rIns="109728" bIns="54864" rtlCol="0" anchor="ctr">
               <a:noAutofit/>
             </a:bodyPr>
             <a:lstStyle/>
@@ -4512,19 +5030,16 @@
           </a:bodyPr>
           <a:lstStyle/>
           <a:p>
-            <a:pPr/>
             <a:r>
               <a:t>Each chunk starts 40 words before the previous one ended</a:t>
             </a:r>
           </a:p>
           <a:p>
-            <a:pPr/>
             <a:r>
               <a:t>A sentence straddling word 200 is cut in chunk 1 and whole in chunk 2</a:t>
             </a:r>
           </a:p>
           <a:p>
-            <a:pPr/>
             <a:r>
               <a:t>The price: those 40 words are embedded and stored twice</a:t>
             </a:r>
@@ -4720,7 +5235,7 @@
 </file>
 
 <file path=ppt/slides/slide13.xml><?xml version="1.0" encoding="utf-8"?>
-<p:sld xmlns:a="http://schemas.openxmlformats.org/drawingml/2006/main" xmlns:p="http://schemas.openxmlformats.org/presentationml/2006/main" xmlns:r="http://schemas.openxmlformats.org/officeDocument/2006/relationships">
+<p:sld xmlns:a="http://schemas.openxmlformats.org/drawingml/2006/main" xmlns:r="http://schemas.openxmlformats.org/officeDocument/2006/relationships" xmlns:p="http://schemas.openxmlformats.org/presentationml/2006/main">
   <p:cSld>
     <p:spTree>
       <p:nvGrpSpPr>
@@ -4728,7 +5243,14 @@
         <p:cNvGrpSpPr/>
         <p:nvPr/>
       </p:nvGrpSpPr>
-      <p:grpSpPr/>
+      <p:grpSpPr>
+        <a:xfrm>
+          <a:off x="0" y="0"/>
+          <a:ext cx="0" cy="0"/>
+          <a:chOff x="0" y="0"/>
+          <a:chExt cx="0" cy="0"/>
+        </a:xfrm>
+      </p:grpSpPr>
       <p:sp>
         <p:nvSpPr>
           <p:cNvPr id="2" name="Title 1"/>
@@ -4782,25 +5304,21 @@
             </a:r>
           </a:p>
           <a:p>
-            <a:pPr/>
             <a:r>
               <a:t>One sentence per chunk: as precise as it gets</a:t>
             </a:r>
           </a:p>
           <a:p>
-            <a:pPr/>
             <a:r>
               <a:t>One paragraph per chunk</a:t>
             </a:r>
           </a:p>
           <a:p>
-            <a:pPr/>
             <a:r>
               <a:t>One page per chunk</a:t>
             </a:r>
           </a:p>
           <a:p>
-            <a:pPr/>
             <a:r>
               <a:t>The whole manual as one chunk</a:t>
             </a:r>
@@ -5045,7 +5563,7 @@
 </file>
 
 <file path=ppt/slides/slide14.xml><?xml version="1.0" encoding="utf-8"?>
-<p:sld xmlns:a="http://schemas.openxmlformats.org/drawingml/2006/main" xmlns:p="http://schemas.openxmlformats.org/presentationml/2006/main" xmlns:r="http://schemas.openxmlformats.org/officeDocument/2006/relationships">
+<p:sld xmlns:a="http://schemas.openxmlformats.org/drawingml/2006/main" xmlns:r="http://schemas.openxmlformats.org/officeDocument/2006/relationships" xmlns:p="http://schemas.openxmlformats.org/presentationml/2006/main">
   <p:cSld>
     <p:spTree>
       <p:nvGrpSpPr>
@@ -5053,7 +5571,14 @@
         <p:cNvGrpSpPr/>
         <p:nvPr/>
       </p:nvGrpSpPr>
-      <p:grpSpPr/>
+      <p:grpSpPr>
+        <a:xfrm>
+          <a:off x="0" y="0"/>
+          <a:ext cx="0" cy="0"/>
+          <a:chOff x="0" y="0"/>
+          <a:chExt cx="0" cy="0"/>
+        </a:xfrm>
+      </p:grpSpPr>
       <p:sp>
         <p:nvSpPr>
           <p:cNvPr id="2" name="Title 1"/>
@@ -5095,23 +5620,20 @@
         </p:spPr>
         <p:txBody>
           <a:bodyPr>
-            <a:normAutofit fontScale="92500"/>
+            <a:normAutofit lnSpcReduction="10000"/>
           </a:bodyPr>
           <a:lstStyle/>
           <a:p>
-            <a:pPr/>
             <a:r>
               <a:t>Too small: "It must be replaced every 12 months." Replaced what? The chunk has lost its subject</a:t>
             </a:r>
           </a:p>
           <a:p>
-            <a:pPr/>
             <a:r>
               <a:t>Too large: the one relevant sentence arrives inside a page of other topics</a:t>
             </a:r>
           </a:p>
           <a:p>
-            <a:pPr/>
             <a:r>
               <a:t>Measured: "what is a variable" scores </a:t>
             </a:r>
@@ -5131,13 +5653,11 @@
             </a:r>
           </a:p>
           <a:p>
-            <a:pPr/>
             <a:r>
               <a:t>The tempting answer, one sentence, is easy to find and useless to read</a:t>
             </a:r>
           </a:p>
           <a:p>
-            <a:pPr/>
             <a:r>
               <a:t>There is no universal size: measure it on questions whose answers you know</a:t>
             </a:r>
@@ -5431,7 +5951,7 @@
 </file>
 
 <file path=ppt/slides/slide15.xml><?xml version="1.0" encoding="utf-8"?>
-<p:sld xmlns:a="http://schemas.openxmlformats.org/drawingml/2006/main" xmlns:p="http://schemas.openxmlformats.org/presentationml/2006/main" xmlns:r="http://schemas.openxmlformats.org/officeDocument/2006/relationships">
+<p:sld xmlns:a="http://schemas.openxmlformats.org/drawingml/2006/main" xmlns:r="http://schemas.openxmlformats.org/officeDocument/2006/relationships" xmlns:p="http://schemas.openxmlformats.org/presentationml/2006/main">
   <p:cSld>
     <p:spTree>
       <p:nvGrpSpPr>
@@ -5439,7 +5959,14 @@
         <p:cNvGrpSpPr/>
         <p:nvPr/>
       </p:nvGrpSpPr>
-      <p:grpSpPr/>
+      <p:grpSpPr>
+        <a:xfrm>
+          <a:off x="0" y="0"/>
+          <a:ext cx="0" cy="0"/>
+          <a:chOff x="0" y="0"/>
+          <a:chExt cx="0" cy="0"/>
+        </a:xfrm>
+      </p:grpSpPr>
       <p:sp>
         <p:nvSpPr>
           <p:cNvPr id="2" name="Title 1"/>
@@ -5481,11 +6008,10 @@
         </p:spPr>
         <p:txBody>
           <a:bodyPr>
-            <a:normAutofit fontScale="92500"/>
+            <a:normAutofit/>
           </a:bodyPr>
           <a:lstStyle/>
           <a:p>
-            <a:pPr/>
             <a:r>
               <a:t>An </a:t>
             </a:r>
@@ -5498,25 +6024,21 @@
             </a:r>
           </a:p>
           <a:p>
-            <a:pPr/>
             <a:r>
               <a:t>Texts with similar meanings get similar lists, whatever words they use</a:t>
             </a:r>
           </a:p>
           <a:p>
-            <a:pPr/>
             <a:r>
               <a:t>One chunk, one vector: 384 numbers for all-MiniLM-L6-v2, up to 3,072 for larger models</a:t>
             </a:r>
           </a:p>
           <a:p>
-            <a:pPr/>
             <a:r>
               <a:t>Use the same model for the chunks and the questions. Always</a:t>
             </a:r>
           </a:p>
           <a:p>
-            <a:pPr/>
             <a:r>
               <a:t>In 2026: OpenAI text-embedding-3, Gemini Embedding, Qwen3-Embedding (open), all-MiniLM-L6-v2 (small, free, runs on a laptop)</a:t>
             </a:r>
@@ -5810,7 +6332,7 @@
 </file>
 
 <file path=ppt/slides/slide16.xml><?xml version="1.0" encoding="utf-8"?>
-<p:sld xmlns:a="http://schemas.openxmlformats.org/drawingml/2006/main" xmlns:p="http://schemas.openxmlformats.org/presentationml/2006/main" xmlns:r="http://schemas.openxmlformats.org/officeDocument/2006/relationships">
+<p:sld xmlns:a="http://schemas.openxmlformats.org/drawingml/2006/main" xmlns:r="http://schemas.openxmlformats.org/officeDocument/2006/relationships" xmlns:p="http://schemas.openxmlformats.org/presentationml/2006/main">
   <p:cSld>
     <p:spTree>
       <p:nvGrpSpPr>
@@ -5818,7 +6340,14 @@
         <p:cNvGrpSpPr/>
         <p:nvPr/>
       </p:nvGrpSpPr>
-      <p:grpSpPr/>
+      <p:grpSpPr>
+        <a:xfrm>
+          <a:off x="0" y="0"/>
+          <a:ext cx="0" cy="0"/>
+          <a:chOff x="0" y="0"/>
+          <a:chExt cx="0" cy="0"/>
+        </a:xfrm>
+      </p:grpSpPr>
       <p:sp>
         <p:nvSpPr>
           <p:cNvPr id="2" name="Title 1"/>
@@ -5881,7 +6410,7 @@
           </a:fontRef>
         </p:style>
         <p:txBody>
-          <a:bodyPr rtlCol="0" anchor="t" wrap="none" lIns="137160" rIns="137160" tIns="91440" bIns="91440">
+          <a:bodyPr wrap="none" lIns="137160" tIns="91440" rIns="137160" bIns="91440" rtlCol="0" anchor="t">
             <a:noAutofit/>
           </a:bodyPr>
           <a:lstStyle/>
@@ -6312,13 +6841,11 @@
           </a:bodyPr>
           <a:lstStyle/>
           <a:p>
-            <a:pPr/>
             <a:r>
               <a:t>No single number means anything on its own. The whole list is the meaning</a:t>
             </a:r>
           </a:p>
           <a:p>
-            <a:pPr/>
             <a:r>
               <a:t>The model learned to produce these lists from huge amounts of text</a:t>
             </a:r>
@@ -6465,7 +6992,7 @@
 </file>
 
 <file path=ppt/slides/slide17.xml><?xml version="1.0" encoding="utf-8"?>
-<p:sld xmlns:a="http://schemas.openxmlformats.org/drawingml/2006/main" xmlns:p="http://schemas.openxmlformats.org/presentationml/2006/main" xmlns:r="http://schemas.openxmlformats.org/officeDocument/2006/relationships">
+<p:sld xmlns:a="http://schemas.openxmlformats.org/drawingml/2006/main" xmlns:r="http://schemas.openxmlformats.org/officeDocument/2006/relationships" xmlns:p="http://schemas.openxmlformats.org/presentationml/2006/main">
   <p:cSld>
     <p:spTree>
       <p:nvGrpSpPr>
@@ -6473,7 +7000,14 @@
         <p:cNvGrpSpPr/>
         <p:nvPr/>
       </p:nvGrpSpPr>
-      <p:grpSpPr/>
+      <p:grpSpPr>
+        <a:xfrm>
+          <a:off x="0" y="0"/>
+          <a:ext cx="0" cy="0"/>
+          <a:chOff x="0" y="0"/>
+          <a:chExt cx="0" cy="0"/>
+        </a:xfrm>
+      </p:grpSpPr>
       <p:sp>
         <p:nvSpPr>
           <p:cNvPr id="2" name="Title 1"/>
@@ -6515,7 +7049,7 @@
         </p:spPr>
         <p:txBody>
           <a:bodyPr>
-            <a:normAutofit fontScale="92500"/>
+            <a:normAutofit/>
           </a:bodyPr>
           <a:lstStyle/>
           <a:p>
@@ -6527,7 +7061,6 @@
             </a:r>
           </a:p>
           <a:p>
-            <a:pPr/>
             <a:r>
               <a:rPr b="1"/>
               <a:t>Cosine similarity</a:t>
@@ -6537,7 +7070,6 @@
             </a:r>
           </a:p>
           <a:p>
-            <a:pPr/>
             <a:r>
               <a:t>"A cat sits on the mat." and "A kitten is lying on the rug.": </a:t>
             </a:r>
@@ -6547,7 +7079,6 @@
             </a:r>
           </a:p>
           <a:p>
-            <a:pPr/>
             <a:r>
               <a:t>"A cat sits on the mat." and "The car engine is running fast.": </a:t>
             </a:r>
@@ -6557,7 +7088,6 @@
             </a:r>
           </a:p>
           <a:p>
-            <a:pPr/>
             <a:r>
               <a:t>"what is a variable" and "A variable is like a labeled box that stores information.": </a:t>
             </a:r>
@@ -6567,7 +7097,6 @@
             </a:r>
           </a:p>
           <a:p>
-            <a:pPr/>
             <a:r>
               <a:t>"what is a variable" and a sentence about bubble sort: </a:t>
             </a:r>
@@ -6865,7 +7394,7 @@
 </file>
 
 <file path=ppt/slides/slide18.xml><?xml version="1.0" encoding="utf-8"?>
-<p:sld xmlns:a="http://schemas.openxmlformats.org/drawingml/2006/main" xmlns:p="http://schemas.openxmlformats.org/presentationml/2006/main" xmlns:r="http://schemas.openxmlformats.org/officeDocument/2006/relationships">
+<p:sld xmlns:a="http://schemas.openxmlformats.org/drawingml/2006/main" xmlns:r="http://schemas.openxmlformats.org/officeDocument/2006/relationships" xmlns:p="http://schemas.openxmlformats.org/presentationml/2006/main">
   <p:cSld>
     <p:spTree>
       <p:nvGrpSpPr>
@@ -6873,7 +7402,14 @@
         <p:cNvGrpSpPr/>
         <p:nvPr/>
       </p:nvGrpSpPr>
-      <p:grpSpPr/>
+      <p:grpSpPr>
+        <a:xfrm>
+          <a:off x="0" y="0"/>
+          <a:ext cx="0" cy="0"/>
+          <a:chOff x="0" y="0"/>
+          <a:chExt cx="0" cy="0"/>
+        </a:xfrm>
+      </p:grpSpPr>
       <p:sp>
         <p:nvSpPr>
           <p:cNvPr id="2" name="Title 1"/>
@@ -6915,35 +7451,30 @@
         </p:spPr>
         <p:txBody>
           <a:bodyPr>
-            <a:normAutofit fontScale="92500"/>
+            <a:normAutofit/>
           </a:bodyPr>
           <a:lstStyle/>
           <a:p>
-            <a:pPr/>
             <a:r>
               <a:t>Keeps each chunk's vector, its text and its label (file, page) together</a:t>
             </a:r>
           </a:p>
           <a:p>
-            <a:pPr/>
             <a:r>
               <a:t>Finds the nearest vectors fast, even among millions, with approximate search (e.g. HNSW)</a:t>
             </a:r>
           </a:p>
           <a:p>
-            <a:pPr/>
             <a:r>
               <a:t>Popular: Pinecone (managed), Weaviate, Qdrant, Milvus, Chroma, pgvector (inside PostgreSQL)</a:t>
             </a:r>
           </a:p>
           <a:p>
-            <a:pPr/>
             <a:r>
               <a:t>FAISS: a fast similarity-search library rather than a full database</a:t>
             </a:r>
           </a:p>
           <a:p>
-            <a:pPr/>
             <a:r>
               <a:t>Metadata filters narrow the search: one product, after a date, only what this user may see</a:t>
             </a:r>
@@ -7237,7 +7768,7 @@
 </file>
 
 <file path=ppt/slides/slide19.xml><?xml version="1.0" encoding="utf-8"?>
-<p:sld xmlns:a="http://schemas.openxmlformats.org/drawingml/2006/main" xmlns:p="http://schemas.openxmlformats.org/presentationml/2006/main" xmlns:r="http://schemas.openxmlformats.org/officeDocument/2006/relationships">
+<p:sld xmlns:a="http://schemas.openxmlformats.org/drawingml/2006/main" xmlns:r="http://schemas.openxmlformats.org/officeDocument/2006/relationships" xmlns:p="http://schemas.openxmlformats.org/presentationml/2006/main">
   <p:cSld>
     <p:spTree>
       <p:nvGrpSpPr>
@@ -7245,7 +7776,14 @@
         <p:cNvGrpSpPr/>
         <p:nvPr/>
       </p:nvGrpSpPr>
-      <p:grpSpPr/>
+      <p:grpSpPr>
+        <a:xfrm>
+          <a:off x="0" y="0"/>
+          <a:ext cx="0" cy="0"/>
+          <a:chOff x="0" y="0"/>
+          <a:chExt cx="0" cy="0"/>
+        </a:xfrm>
+      </p:grpSpPr>
       <p:sp>
         <p:nvSpPr>
           <p:cNvPr id="2" name="Title 1"/>
@@ -7287,17 +7825,15 @@
         </p:spPr>
         <p:txBody>
           <a:bodyPr>
-            <a:normAutofit/>
+            <a:normAutofit lnSpcReduction="10000"/>
           </a:bodyPr>
           <a:lstStyle/>
           <a:p>
-            <a:pPr/>
             <a:r>
               <a:t>The question is embedded with the same model, then compared with every chunk</a:t>
             </a:r>
           </a:p>
           <a:p>
-            <a:pPr/>
             <a:r>
               <a:t>The database returns the k closest chunks (here k = 3), each with a score</a:t>
             </a:r>
@@ -7343,7 +7879,7 @@
           </a:fontRef>
         </p:style>
         <p:txBody>
-          <a:bodyPr rtlCol="0" anchor="t" wrap="none" lIns="137160" rIns="137160" tIns="91440" bIns="91440">
+          <a:bodyPr wrap="none" lIns="137160" tIns="91440" rIns="137160" bIns="91440" rtlCol="0" anchor="t">
             <a:noAutofit/>
           </a:bodyPr>
           <a:lstStyle/>
@@ -7610,7 +8146,6 @@
             </a:lvl9pPr>
           </a:lstStyle>
           <a:p>
-            <a:pPr/>
             <a:r>
               <a:t>Five short programming documents, cut into 14 chunks. The definition sits in the top chunk</a:t>
             </a:r>
@@ -7807,7 +8342,7 @@
 </file>
 
 <file path=ppt/slides/slide2.xml><?xml version="1.0" encoding="utf-8"?>
-<p:sld xmlns:a="http://schemas.openxmlformats.org/drawingml/2006/main" xmlns:p="http://schemas.openxmlformats.org/presentationml/2006/main" xmlns:r="http://schemas.openxmlformats.org/officeDocument/2006/relationships">
+<p:sld xmlns:a="http://schemas.openxmlformats.org/drawingml/2006/main" xmlns:r="http://schemas.openxmlformats.org/officeDocument/2006/relationships" xmlns:p="http://schemas.openxmlformats.org/presentationml/2006/main">
   <p:cSld>
     <p:spTree>
       <p:nvGrpSpPr>
@@ -7815,7 +8350,14 @@
         <p:cNvGrpSpPr/>
         <p:nvPr/>
       </p:nvGrpSpPr>
-      <p:grpSpPr/>
+      <p:grpSpPr>
+        <a:xfrm>
+          <a:off x="0" y="0"/>
+          <a:ext cx="0" cy="0"/>
+          <a:chOff x="0" y="0"/>
+          <a:chExt cx="0" cy="0"/>
+        </a:xfrm>
+      </p:grpSpPr>
       <p:sp>
         <p:nvSpPr>
           <p:cNvPr id="2" name="Title 1"/>
@@ -7865,44 +8407,54 @@
               <a:buNone/>
             </a:pPr>
             <a:r>
-              <a:rPr b="1"/>
+              <a:rPr b="1" dirty="0"/>
               <a:t>RAG: look it up first, then answer from what you found.</a:t>
             </a:r>
           </a:p>
           <a:p>
-            <a:pPr/>
-            <a:r>
-              <a:rPr b="1"/>
+            <a:r>
+              <a:rPr b="1" dirty="0"/>
               <a:t>Retrieval</a:t>
             </a:r>
             <a:r>
+              <a:rPr dirty="0"/>
               <a:t>: search a knowledge source for the passages relevant to the question</a:t>
             </a:r>
           </a:p>
           <a:p>
-            <a:pPr/>
-            <a:r>
-              <a:rPr b="1"/>
+            <a:r>
+              <a:rPr b="1" dirty="0"/>
               <a:t>Augmented</a:t>
             </a:r>
             <a:r>
+              <a:rPr dirty="0"/>
               <a:t>: add those passages to the prompt, beside the question</a:t>
             </a:r>
           </a:p>
           <a:p>
-            <a:pPr/>
-            <a:r>
-              <a:rPr b="1"/>
+            <a:r>
+              <a:rPr b="1" dirty="0"/>
               <a:t>Generation</a:t>
             </a:r>
             <a:r>
+              <a:rPr dirty="0"/>
               <a:t>: the model writes its answer from what it was just given</a:t>
             </a:r>
           </a:p>
           <a:p>
-            <a:pPr/>
-            <a:r>
-              <a:t>Named in a 2020 research paper. Its lead author, later: "We definitely would have put more thought into the name"</a:t>
+            <a:r>
+              <a:rPr dirty="0"/>
+              <a:t>Named in a 2020 research paper. Its lead author, later: </a:t>
+            </a:r>
+            <a:endParaRPr lang="en-US" dirty="0"/>
+          </a:p>
+          <a:p>
+            <a:pPr marL="0" indent="0" algn="ctr">
+              <a:buNone/>
+            </a:pPr>
+            <a:r>
+              <a:rPr i="1" dirty="0"/>
+              <a:t>"We definitely would have put more thought into the name"</a:t>
             </a:r>
           </a:p>
         </p:txBody>
@@ -8116,6 +8668,55 @@
                       </p:childTnLst>
                     </p:cTn>
                   </p:par>
+                  <p:par>
+                    <p:cTn id="19" fill="hold">
+                      <p:stCondLst>
+                        <p:cond delay="indefinite"/>
+                      </p:stCondLst>
+                      <p:childTnLst>
+                        <p:par>
+                          <p:cTn id="20" fill="hold">
+                            <p:stCondLst>
+                              <p:cond delay="0"/>
+                            </p:stCondLst>
+                            <p:childTnLst>
+                              <p:par>
+                                <p:cTn id="21" presetID="1" presetClass="entr" presetSubtype="0" fill="hold" grpId="0" nodeType="clickEffect">
+                                  <p:stCondLst>
+                                    <p:cond delay="0"/>
+                                  </p:stCondLst>
+                                  <p:childTnLst>
+                                    <p:set>
+                                      <p:cBhvr>
+                                        <p:cTn id="22" dur="1" fill="hold">
+                                          <p:stCondLst>
+                                            <p:cond delay="0"/>
+                                          </p:stCondLst>
+                                        </p:cTn>
+                                        <p:tgtEl>
+                                          <p:spTgt spid="3">
+                                            <p:txEl>
+                                              <p:pRg st="5" end="5"/>
+                                            </p:txEl>
+                                          </p:spTgt>
+                                        </p:tgtEl>
+                                        <p:attrNameLst>
+                                          <p:attrName>style.visibility</p:attrName>
+                                        </p:attrNameLst>
+                                      </p:cBhvr>
+                                      <p:to>
+                                        <p:strVal val="visible"/>
+                                      </p:to>
+                                    </p:set>
+                                  </p:childTnLst>
+                                </p:cTn>
+                              </p:par>
+                            </p:childTnLst>
+                          </p:cTn>
+                        </p:par>
+                      </p:childTnLst>
+                    </p:cTn>
+                  </p:par>
                 </p:childTnLst>
               </p:cTn>
               <p:prevCondLst>
@@ -8145,7 +8746,7 @@
 </file>
 
 <file path=ppt/slides/slide20.xml><?xml version="1.0" encoding="utf-8"?>
-<p:sld xmlns:a="http://schemas.openxmlformats.org/drawingml/2006/main" xmlns:p="http://schemas.openxmlformats.org/presentationml/2006/main" xmlns:r="http://schemas.openxmlformats.org/officeDocument/2006/relationships">
+<p:sld xmlns:a="http://schemas.openxmlformats.org/drawingml/2006/main" xmlns:r="http://schemas.openxmlformats.org/officeDocument/2006/relationships" xmlns:p="http://schemas.openxmlformats.org/presentationml/2006/main">
   <p:cSld>
     <p:spTree>
       <p:nvGrpSpPr>
@@ -8153,7 +8754,14 @@
         <p:cNvGrpSpPr/>
         <p:nvPr/>
       </p:nvGrpSpPr>
-      <p:grpSpPr/>
+      <p:grpSpPr>
+        <a:xfrm>
+          <a:off x="0" y="0"/>
+          <a:ext cx="0" cy="0"/>
+          <a:chOff x="0" y="0"/>
+          <a:chExt cx="0" cy="0"/>
+        </a:xfrm>
+      </p:grpSpPr>
       <p:sp>
         <p:nvSpPr>
           <p:cNvPr id="2" name="Title 1"/>
@@ -8218,25 +8826,21 @@
             </a:r>
           </a:p>
           <a:p>
-            <a:pPr/>
             <a:r>
               <a:t>Nothing useful: no words match</a:t>
             </a:r>
           </a:p>
           <a:p>
-            <a:pPr/>
             <a:r>
               <a:t>Three random chunks</a:t>
             </a:r>
           </a:p>
           <a:p>
-            <a:pPr/>
             <a:r>
               <a:t>The same top chunk as "what is a variable"</a:t>
             </a:r>
           </a:p>
           <a:p>
-            <a:pPr/>
             <a:r>
               <a:t>An error</a:t>
             </a:r>
@@ -8481,7 +9085,7 @@
 </file>
 
 <file path=ppt/slides/slide21.xml><?xml version="1.0" encoding="utf-8"?>
-<p:sld xmlns:a="http://schemas.openxmlformats.org/drawingml/2006/main" xmlns:p="http://schemas.openxmlformats.org/presentationml/2006/main" xmlns:r="http://schemas.openxmlformats.org/officeDocument/2006/relationships">
+<p:sld xmlns:a="http://schemas.openxmlformats.org/drawingml/2006/main" xmlns:r="http://schemas.openxmlformats.org/officeDocument/2006/relationships" xmlns:p="http://schemas.openxmlformats.org/presentationml/2006/main">
   <p:cSld>
     <p:spTree>
       <p:nvGrpSpPr>
@@ -8489,7 +9093,14 @@
         <p:cNvGrpSpPr/>
         <p:nvPr/>
       </p:nvGrpSpPr>
-      <p:grpSpPr/>
+      <p:grpSpPr>
+        <a:xfrm>
+          <a:off x="0" y="0"/>
+          <a:ext cx="0" cy="0"/>
+          <a:chOff x="0" y="0"/>
+          <a:chExt cx="0" cy="0"/>
+        </a:xfrm>
+      </p:grpSpPr>
       <p:sp>
         <p:nvSpPr>
           <p:cNvPr id="2" name="Title 1"/>
@@ -8552,7 +9163,7 @@
           </a:fontRef>
         </p:style>
         <p:txBody>
-          <a:bodyPr rtlCol="0" anchor="t" wrap="none" lIns="137160" rIns="137160" tIns="91440" bIns="91440">
+          <a:bodyPr wrap="none" lIns="137160" tIns="91440" rIns="137160" bIns="91440" rtlCol="0" anchor="t">
             <a:noAutofit/>
           </a:bodyPr>
           <a:lstStyle/>
@@ -8656,19 +9267,16 @@
           </a:bodyPr>
           <a:lstStyle/>
           <a:p>
-            <a:pPr/>
             <a:r>
               <a:t>Keyword search would find nothing here. Matching meaning, not words, is why embeddings exist</a:t>
             </a:r>
           </a:p>
           <a:p>
-            <a:pPr/>
             <a:r>
               <a:t>The common wrong answer, "no shared words, so no match", is how keyword search thinks</a:t>
             </a:r>
           </a:p>
           <a:p>
-            <a:pPr/>
             <a:r>
               <a:t>The scores are lower (0.31 against 0.42), but the ranking holds</a:t>
             </a:r>
@@ -8864,7 +9472,7 @@
 </file>
 
 <file path=ppt/slides/slide22.xml><?xml version="1.0" encoding="utf-8"?>
-<p:sld xmlns:a="http://schemas.openxmlformats.org/drawingml/2006/main" xmlns:p="http://schemas.openxmlformats.org/presentationml/2006/main" xmlns:r="http://schemas.openxmlformats.org/officeDocument/2006/relationships">
+<p:sld xmlns:a="http://schemas.openxmlformats.org/drawingml/2006/main" xmlns:r="http://schemas.openxmlformats.org/officeDocument/2006/relationships" xmlns:p="http://schemas.openxmlformats.org/presentationml/2006/main">
   <p:cSld>
     <p:spTree>
       <p:nvGrpSpPr>
@@ -8872,7 +9480,14 @@
         <p:cNvGrpSpPr/>
         <p:nvPr/>
       </p:nvGrpSpPr>
-      <p:grpSpPr/>
+      <p:grpSpPr>
+        <a:xfrm>
+          <a:off x="0" y="0"/>
+          <a:ext cx="0" cy="0"/>
+          <a:chOff x="0" y="0"/>
+          <a:chExt cx="0" cy="0"/>
+        </a:xfrm>
+      </p:grpSpPr>
       <p:sp>
         <p:nvSpPr>
           <p:cNvPr id="2" name="Title 1"/>
@@ -8914,7 +9529,7 @@
         </p:spPr>
         <p:txBody>
           <a:bodyPr>
-            <a:normAutofit/>
+            <a:normAutofit lnSpcReduction="10000"/>
           </a:bodyPr>
           <a:lstStyle/>
           <a:p>
@@ -8966,7 +9581,7 @@
           </a:fontRef>
         </p:style>
         <p:txBody>
-          <a:bodyPr rtlCol="0" anchor="t" wrap="none" lIns="137160" rIns="137160" tIns="91440" bIns="91440">
+          <a:bodyPr wrap="none" lIns="137160" tIns="91440" rIns="137160" bIns="91440" rtlCol="0" anchor="t">
             <a:noAutofit/>
           </a:bodyPr>
           <a:lstStyle/>
@@ -9347,7 +9962,6 @@
             </a:lvl9pPr>
           </a:lstStyle>
           <a:p>
-            <a:pPr/>
             <a:r>
               <a:t>Instructions, then the retrieved chunks with their labels, then the question</a:t>
             </a:r>
@@ -9445,7 +10059,7 @@
 </file>
 
 <file path=ppt/slides/slide23.xml><?xml version="1.0" encoding="utf-8"?>
-<p:sld xmlns:a="http://schemas.openxmlformats.org/drawingml/2006/main" xmlns:p="http://schemas.openxmlformats.org/presentationml/2006/main" xmlns:r="http://schemas.openxmlformats.org/officeDocument/2006/relationships">
+<p:sld xmlns:a="http://schemas.openxmlformats.org/drawingml/2006/main" xmlns:r="http://schemas.openxmlformats.org/officeDocument/2006/relationships" xmlns:p="http://schemas.openxmlformats.org/presentationml/2006/main">
   <p:cSld>
     <p:spTree>
       <p:nvGrpSpPr>
@@ -9453,7 +10067,14 @@
         <p:cNvGrpSpPr/>
         <p:nvPr/>
       </p:nvGrpSpPr>
-      <p:grpSpPr/>
+      <p:grpSpPr>
+        <a:xfrm>
+          <a:off x="0" y="0"/>
+          <a:ext cx="0" cy="0"/>
+          <a:chOff x="0" y="0"/>
+          <a:chExt cx="0" cy="0"/>
+        </a:xfrm>
+      </p:grpSpPr>
       <p:sp>
         <p:nvSpPr>
           <p:cNvPr id="2" name="Title 1"/>
@@ -9495,11 +10116,10 @@
         </p:spPr>
         <p:txBody>
           <a:bodyPr>
-            <a:normAutofit/>
+            <a:normAutofit lnSpcReduction="10000"/>
           </a:bodyPr>
           <a:lstStyle/>
           <a:p>
-            <a:pPr/>
             <a:r>
               <a:rPr b="1"/>
               <a:t>Grounded</a:t>
@@ -9509,13 +10129,11 @@
             </a:r>
           </a:p>
           <a:p>
-            <a:pPr/>
             <a:r>
               <a:t>Each chunk carries a label from the moment it is cut, and the label travels into the prompt</a:t>
             </a:r>
           </a:p>
           <a:p>
-            <a:pPr/>
             <a:r>
               <a:t>The model repeats the label it used: it has no other way to know a source</a:t>
             </a:r>
@@ -9561,7 +10179,7 @@
           </a:fontRef>
         </p:style>
         <p:txBody>
-          <a:bodyPr rtlCol="0" anchor="t" wrap="none" lIns="137160" rIns="137160" tIns="91440" bIns="91440">
+          <a:bodyPr wrap="none" lIns="137160" tIns="91440" rIns="137160" bIns="91440" rtlCol="0" anchor="t">
             <a:noAutofit/>
           </a:bodyPr>
           <a:lstStyle/>
@@ -9790,7 +10408,6 @@
             </a:lvl9pPr>
           </a:lstStyle>
           <a:p>
-            <a:pPr/>
             <a:r>
               <a:t>A citation with no label behind it is an invention</a:t>
             </a:r>
@@ -10036,7 +10653,7 @@
 </file>
 
 <file path=ppt/slides/slide24.xml><?xml version="1.0" encoding="utf-8"?>
-<p:sld xmlns:a="http://schemas.openxmlformats.org/drawingml/2006/main" xmlns:p="http://schemas.openxmlformats.org/presentationml/2006/main" xmlns:r="http://schemas.openxmlformats.org/officeDocument/2006/relationships">
+<p:sld xmlns:a="http://schemas.openxmlformats.org/drawingml/2006/main" xmlns:r="http://schemas.openxmlformats.org/officeDocument/2006/relationships" xmlns:p="http://schemas.openxmlformats.org/presentationml/2006/main">
   <p:cSld>
     <p:spTree>
       <p:nvGrpSpPr>
@@ -10044,7 +10661,14 @@
         <p:cNvGrpSpPr/>
         <p:nvPr/>
       </p:nvGrpSpPr>
-      <p:grpSpPr/>
+      <p:grpSpPr>
+        <a:xfrm>
+          <a:off x="0" y="0"/>
+          <a:ext cx="0" cy="0"/>
+          <a:chOff x="0" y="0"/>
+          <a:chExt cx="0" cy="0"/>
+        </a:xfrm>
+      </p:grpSpPr>
       <p:sp>
         <p:nvSpPr>
           <p:cNvPr id="2" name="Title 1"/>
@@ -10098,25 +10722,21 @@
             </a:r>
           </a:p>
           <a:p>
-            <a:pPr/>
             <a:r>
               <a:t>Yes: it only uses the retrieved text</a:t>
             </a:r>
           </a:p>
           <a:p>
-            <a:pPr/>
             <a:r>
               <a:t>It reduces them a lot, but not to zero</a:t>
             </a:r>
           </a:p>
           <a:p>
-            <a:pPr/>
             <a:r>
               <a:t>It makes no difference</a:t>
             </a:r>
           </a:p>
           <a:p>
-            <a:pPr/>
             <a:r>
               <a:t>It makes them worse</a:t>
             </a:r>
@@ -10361,7 +10981,7 @@
 </file>
 
 <file path=ppt/slides/slide25.xml><?xml version="1.0" encoding="utf-8"?>
-<p:sld xmlns:a="http://schemas.openxmlformats.org/drawingml/2006/main" xmlns:p="http://schemas.openxmlformats.org/presentationml/2006/main" xmlns:r="http://schemas.openxmlformats.org/officeDocument/2006/relationships">
+<p:sld xmlns:a="http://schemas.openxmlformats.org/drawingml/2006/main" xmlns:r="http://schemas.openxmlformats.org/officeDocument/2006/relationships" xmlns:p="http://schemas.openxmlformats.org/presentationml/2006/main">
   <p:cSld>
     <p:spTree>
       <p:nvGrpSpPr>
@@ -10369,7 +10989,14 @@
         <p:cNvGrpSpPr/>
         <p:nvPr/>
       </p:nvGrpSpPr>
-      <p:grpSpPr/>
+      <p:grpSpPr>
+        <a:xfrm>
+          <a:off x="0" y="0"/>
+          <a:ext cx="0" cy="0"/>
+          <a:chOff x="0" y="0"/>
+          <a:chExt cx="0" cy="0"/>
+        </a:xfrm>
+      </p:grpSpPr>
       <p:sp>
         <p:nvSpPr>
           <p:cNvPr id="2" name="Title 1"/>
@@ -10411,11 +11038,10 @@
         </p:spPr>
         <p:txBody>
           <a:bodyPr>
-            <a:normAutofit fontScale="85000"/>
+            <a:normAutofit fontScale="92500" lnSpcReduction="10000"/>
           </a:bodyPr>
           <a:lstStyle/>
           <a:p>
-            <a:pPr/>
             <a:r>
               <a:t>Stanford, 2024: legal research tools built on RAG, sold as hallucination-free, still made things up on 17–33% of 202 questions</a:t>
             </a:r>
@@ -10427,25 +11053,21 @@
             </a:r>
           </a:p>
           <a:p>
-            <a:pPr/>
             <a:r>
               <a:t>The model can misread a chunk, or blend two chunks into a claim neither makes</a:t>
             </a:r>
           </a:p>
           <a:p>
-            <a:pPr/>
             <a:r>
               <a:t>A real citation that doesn't support the claim is worse than none: it looks checked</a:t>
             </a:r>
           </a:p>
           <a:p>
-            <a:pPr/>
             <a:r>
               <a:t>When retrieval finds nothing useful, the model may answer from memory anyway</a:t>
             </a:r>
           </a:p>
           <a:p>
-            <a:pPr/>
             <a:r>
               <a:t>The common wrong answer, "yes, it's grounded now", forgets all three</a:t>
             </a:r>
@@ -10770,7 +11392,7 @@
 </file>
 
 <file path=ppt/slides/slide26.xml><?xml version="1.0" encoding="utf-8"?>
-<p:sld xmlns:a="http://schemas.openxmlformats.org/drawingml/2006/main" xmlns:p="http://schemas.openxmlformats.org/presentationml/2006/main" xmlns:r="http://schemas.openxmlformats.org/officeDocument/2006/relationships">
+<p:sld xmlns:a="http://schemas.openxmlformats.org/drawingml/2006/main" xmlns:r="http://schemas.openxmlformats.org/officeDocument/2006/relationships" xmlns:p="http://schemas.openxmlformats.org/presentationml/2006/main">
   <p:cSld>
     <p:spTree>
       <p:nvGrpSpPr>
@@ -10778,7 +11400,14 @@
         <p:cNvGrpSpPr/>
         <p:nvPr/>
       </p:nvGrpSpPr>
-      <p:grpSpPr/>
+      <p:grpSpPr>
+        <a:xfrm>
+          <a:off x="0" y="0"/>
+          <a:ext cx="0" cy="0"/>
+          <a:chOff x="0" y="0"/>
+          <a:chExt cx="0" cy="0"/>
+        </a:xfrm>
+      </p:grpSpPr>
       <p:sp>
         <p:nvSpPr>
           <p:cNvPr id="2" name="Title 1"/>
@@ -10830,7 +11459,7 @@
             <a:spLocks noGrp="1"/>
           </p:cNvSpPr>
           <p:nvPr>
-            <p:ph idx="2" sz="half"/>
+            <p:ph sz="half" idx="2"/>
           </p:nvPr>
         </p:nvSpPr>
         <p:spPr>
@@ -10841,35 +11470,30 @@
         </p:spPr>
         <p:txBody>
           <a:bodyPr>
-            <a:normAutofit fontScale="70000"/>
+            <a:normAutofit fontScale="77500" lnSpcReduction="10000"/>
           </a:bodyPr>
           <a:lstStyle/>
           <a:p>
-            <a:pPr/>
             <a:r>
               <a:t>Current answers without retraining the model</a:t>
             </a:r>
           </a:p>
           <a:p>
-            <a:pPr/>
             <a:r>
               <a:t>Answers grounded in your own documents</a:t>
             </a:r>
           </a:p>
           <a:p>
-            <a:pPr/>
             <a:r>
               <a:t>Citations a reader can check</a:t>
             </a:r>
           </a:p>
           <a:p>
-            <a:pPr/>
             <a:r>
               <a:t>Far cheaper than fine-tuning just to add facts</a:t>
             </a:r>
           </a:p>
           <a:p>
-            <a:pPr/>
             <a:r>
               <a:t>Access control: retrieve only what the asker may see</a:t>
             </a:r>
@@ -10883,7 +11507,7 @@
             <a:spLocks noGrp="1"/>
           </p:cNvSpPr>
           <p:nvPr>
-            <p:ph type="body" idx="3" sz="quarter"/>
+            <p:ph type="body" sz="quarter" idx="3"/>
           </p:nvPr>
         </p:nvSpPr>
         <p:spPr/>
@@ -10904,7 +11528,7 @@
             <a:spLocks noGrp="1"/>
           </p:cNvSpPr>
           <p:nvPr>
-            <p:ph idx="4" sz="quarter"/>
+            <p:ph sz="quarter" idx="4"/>
           </p:nvPr>
         </p:nvSpPr>
         <p:spPr>
@@ -10915,35 +11539,30 @@
         </p:spPr>
         <p:txBody>
           <a:bodyPr>
-            <a:normAutofit fontScale="70000"/>
+            <a:normAutofit fontScale="77500" lnSpcReduction="10000"/>
           </a:bodyPr>
           <a:lstStyle/>
           <a:p>
-            <a:pPr/>
             <a:r>
               <a:t>Latency: a search before every answer</a:t>
             </a:r>
           </a:p>
           <a:p>
-            <a:pPr/>
             <a:r>
               <a:t>Maintenance: parsing, chunking, embeddings and an index to keep current</a:t>
             </a:r>
           </a:p>
           <a:p>
-            <a:pPr/>
             <a:r>
               <a:t>Retrieval is the ceiling: wrong chunks in, wrong answer out</a:t>
             </a:r>
           </a:p>
           <a:p>
-            <a:pPr/>
             <a:r>
               <a:t>Chunking can split one fact across two pieces</a:t>
             </a:r>
           </a:p>
           <a:p>
-            <a:pPr/>
             <a:r>
               <a:t>Only a few chunks reach the model: what isn't retrieved might as well not exist</a:t>
             </a:r>
@@ -11483,7 +12102,7 @@
 </file>
 
 <file path=ppt/slides/slide27.xml><?xml version="1.0" encoding="utf-8"?>
-<p:sld xmlns:a="http://schemas.openxmlformats.org/drawingml/2006/main" xmlns:p="http://schemas.openxmlformats.org/presentationml/2006/main" xmlns:r="http://schemas.openxmlformats.org/officeDocument/2006/relationships">
+<p:sld xmlns:a="http://schemas.openxmlformats.org/drawingml/2006/main" xmlns:r="http://schemas.openxmlformats.org/officeDocument/2006/relationships" xmlns:p="http://schemas.openxmlformats.org/presentationml/2006/main">
   <p:cSld>
     <p:spTree>
       <p:nvGrpSpPr>
@@ -11491,7 +12110,14 @@
         <p:cNvGrpSpPr/>
         <p:nvPr/>
       </p:nvGrpSpPr>
-      <p:grpSpPr/>
+      <p:grpSpPr>
+        <a:xfrm>
+          <a:off x="0" y="0"/>
+          <a:ext cx="0" cy="0"/>
+          <a:chOff x="0" y="0"/>
+          <a:chExt cx="0" cy="0"/>
+        </a:xfrm>
+      </p:grpSpPr>
       <p:sp>
         <p:nvSpPr>
           <p:cNvPr id="2" name="Title 1"/>
@@ -11543,7 +12169,7 @@
             <a:spLocks noGrp="1"/>
           </p:cNvSpPr>
           <p:nvPr>
-            <p:ph idx="2" sz="half"/>
+            <p:ph sz="half" idx="2"/>
           </p:nvPr>
         </p:nvSpPr>
         <p:spPr>
@@ -11558,19 +12184,16 @@
           </a:bodyPr>
           <a:lstStyle/>
           <a:p>
-            <a:pPr/>
             <a:r>
               <a:t>Facts, documents, this morning's numbers</a:t>
             </a:r>
           </a:p>
           <a:p>
-            <a:pPr/>
             <a:r>
               <a:t>Updated by re-indexing, in minutes</a:t>
             </a:r>
           </a:p>
           <a:p>
-            <a:pPr/>
             <a:r>
               <a:t>Can show its source</a:t>
             </a:r>
@@ -11584,7 +12207,7 @@
             <a:spLocks noGrp="1"/>
           </p:cNvSpPr>
           <p:nvPr>
-            <p:ph type="body" idx="3" sz="quarter"/>
+            <p:ph type="body" sz="quarter" idx="3"/>
           </p:nvPr>
         </p:nvSpPr>
         <p:spPr/>
@@ -11605,7 +12228,7 @@
             <a:spLocks noGrp="1"/>
           </p:cNvSpPr>
           <p:nvPr>
-            <p:ph idx="4" sz="quarter"/>
+            <p:ph sz="quarter" idx="4"/>
           </p:nvPr>
         </p:nvSpPr>
         <p:spPr>
@@ -11620,19 +12243,16 @@
           </a:bodyPr>
           <a:lstStyle/>
           <a:p>
-            <a:pPr/>
             <a:r>
               <a:t>Style, format, a specialised skill</a:t>
             </a:r>
           </a:p>
           <a:p>
-            <a:pPr/>
             <a:r>
               <a:t>Updated by training again</a:t>
             </a:r>
           </a:p>
           <a:p>
-            <a:pPr/>
             <a:r>
               <a:t>Can't point to where it learned something</a:t>
             </a:r>
@@ -11657,7 +12277,7 @@
         </p:spPr>
         <p:txBody>
           <a:bodyPr wrap="square">
-            <a:normAutofit/>
+            <a:normAutofit lnSpcReduction="10000"/>
           </a:bodyPr>
           <a:lstStyle>
             <a:lvl1pPr marL="228600" indent="-228600" algn="l" defTabSz="914400" rtl="0" eaLnBrk="1" latinLnBrk="0" hangingPunct="1">
@@ -11824,7 +12444,6 @@
             </a:lvl9pPr>
           </a:lstStyle>
           <a:p>
-            <a:pPr/>
             <a:r>
               <a:t>New facts: RAG. New behaviour: fine-tuning. Many products use both</a:t>
             </a:r>
@@ -12218,7 +12837,7 @@
 </file>
 
 <file path=ppt/slides/slide28.xml><?xml version="1.0" encoding="utf-8"?>
-<p:sld xmlns:a="http://schemas.openxmlformats.org/drawingml/2006/main" xmlns:p="http://schemas.openxmlformats.org/presentationml/2006/main" xmlns:r="http://schemas.openxmlformats.org/officeDocument/2006/relationships">
+<p:sld xmlns:a="http://schemas.openxmlformats.org/drawingml/2006/main" xmlns:r="http://schemas.openxmlformats.org/officeDocument/2006/relationships" xmlns:p="http://schemas.openxmlformats.org/presentationml/2006/main">
   <p:cSld>
     <p:spTree>
       <p:nvGrpSpPr>
@@ -12226,7 +12845,14 @@
         <p:cNvGrpSpPr/>
         <p:nvPr/>
       </p:nvGrpSpPr>
-      <p:grpSpPr/>
+      <p:grpSpPr>
+        <a:xfrm>
+          <a:off x="0" y="0"/>
+          <a:ext cx="0" cy="0"/>
+          <a:chOff x="0" y="0"/>
+          <a:chExt cx="0" cy="0"/>
+        </a:xfrm>
+      </p:grpSpPr>
       <p:sp>
         <p:nvSpPr>
           <p:cNvPr id="2" name="Title 1"/>
@@ -12245,7 +12871,7 @@
           <a:lstStyle/>
           <a:p>
             <a:r>
-              <a:t>Break: ten minutes</a:t>
+              <a:t>Part 2: RAG in 2026</a:t>
             </a:r>
           </a:p>
         </p:txBody>
@@ -12266,7 +12892,7 @@
           <a:lstStyle/>
           <a:p>
             <a:r>
-              <a:t>Part 2: models now read a million tokens at once. Do we still need any of this?</a:t>
+              <a:t>Models now read a million tokens at once. Do we still need any of this?</a:t>
             </a:r>
           </a:p>
         </p:txBody>
@@ -12280,7 +12906,7 @@
 </file>
 
 <file path=ppt/slides/slide29.xml><?xml version="1.0" encoding="utf-8"?>
-<p:sld xmlns:a="http://schemas.openxmlformats.org/drawingml/2006/main" xmlns:p="http://schemas.openxmlformats.org/presentationml/2006/main" xmlns:r="http://schemas.openxmlformats.org/officeDocument/2006/relationships">
+<p:sld xmlns:a="http://schemas.openxmlformats.org/drawingml/2006/main" xmlns:r="http://schemas.openxmlformats.org/officeDocument/2006/relationships" xmlns:p="http://schemas.openxmlformats.org/presentationml/2006/main">
   <p:cSld>
     <p:spTree>
       <p:nvGrpSpPr>
@@ -12288,7 +12914,14 @@
         <p:cNvGrpSpPr/>
         <p:nvPr/>
       </p:nvGrpSpPr>
-      <p:grpSpPr/>
+      <p:grpSpPr>
+        <a:xfrm>
+          <a:off x="0" y="0"/>
+          <a:ext cx="0" cy="0"/>
+          <a:chOff x="0" y="0"/>
+          <a:chExt cx="0" cy="0"/>
+        </a:xfrm>
+      </p:grpSpPr>
       <p:sp>
         <p:nvSpPr>
           <p:cNvPr id="2" name="Title 1"/>
@@ -12330,35 +12963,30 @@
         </p:spPr>
         <p:txBody>
           <a:bodyPr>
-            <a:normAutofit fontScale="92500"/>
+            <a:normAutofit lnSpcReduction="10000"/>
           </a:bodyPr>
           <a:lstStyle/>
           <a:p>
-            <a:pPr/>
             <a:r>
               <a:t>2020: RAG was named when models could read a few thousand tokens at a time</a:t>
             </a:r>
           </a:p>
           <a:p>
-            <a:pPr/>
             <a:r>
               <a:t>2026: frontier models read about a million tokens at once, well over a thousand pages</a:t>
             </a:r>
           </a:p>
           <a:p>
-            <a:pPr/>
             <a:r>
               <a:t>So for a small document set, the best design is often: paste the whole thing in</a:t>
             </a:r>
           </a:p>
           <a:p>
-            <a:pPr/>
             <a:r>
               <a:t>Claude Projects works this way: everything goes in while it fits; past that, RAG switches on and holds up to 10x more</a:t>
             </a:r>
           </a:p>
           <a:p>
-            <a:pPr/>
             <a:r>
               <a:rPr b="1"/>
               <a:t>Long context didn't kill retrieval. It killed retrieval as the automatic choice</a:t>
@@ -12653,7 +13281,7 @@
 </file>
 
 <file path=ppt/slides/slide3.xml><?xml version="1.0" encoding="utf-8"?>
-<p:sld xmlns:a="http://schemas.openxmlformats.org/drawingml/2006/main" xmlns:p="http://schemas.openxmlformats.org/presentationml/2006/main" xmlns:r="http://schemas.openxmlformats.org/officeDocument/2006/relationships">
+<p:sld xmlns:a="http://schemas.openxmlformats.org/drawingml/2006/main" xmlns:r="http://schemas.openxmlformats.org/officeDocument/2006/relationships" xmlns:p="http://schemas.openxmlformats.org/presentationml/2006/main">
   <p:cSld>
     <p:spTree>
       <p:nvGrpSpPr>
@@ -12661,7 +13289,14 @@
         <p:cNvGrpSpPr/>
         <p:nvPr/>
       </p:nvGrpSpPr>
-      <p:grpSpPr/>
+      <p:grpSpPr>
+        <a:xfrm>
+          <a:off x="0" y="0"/>
+          <a:ext cx="0" cy="0"/>
+          <a:chOff x="0" y="0"/>
+          <a:chExt cx="0" cy="0"/>
+        </a:xfrm>
+      </p:grpSpPr>
       <p:sp>
         <p:nvSpPr>
           <p:cNvPr id="2" name="Title 1"/>
@@ -12713,7 +13348,7 @@
             <a:spLocks noGrp="1"/>
           </p:cNvSpPr>
           <p:nvPr>
-            <p:ph idx="2" sz="half"/>
+            <p:ph sz="half" idx="2"/>
           </p:nvPr>
         </p:nvSpPr>
         <p:spPr>
@@ -12724,23 +13359,20 @@
         </p:spPr>
         <p:txBody>
           <a:bodyPr>
-            <a:normAutofit fontScale="70000"/>
+            <a:normAutofit fontScale="92500" lnSpcReduction="20000"/>
           </a:bodyPr>
           <a:lstStyle/>
           <a:p>
-            <a:pPr/>
             <a:r>
               <a:t>Its website chatbot told a grieving passenger that a bereavement fare could be claimed after flying</a:t>
             </a:r>
           </a:p>
           <a:p>
-            <a:pPr/>
             <a:r>
               <a:t>The airline's own policy said the opposite</a:t>
             </a:r>
           </a:p>
           <a:p>
-            <a:pPr/>
             <a:r>
               <a:t>In effect, Air Canada argued its chatbot was "a separate legal entity". The tribunal called that "remarkable" and made it pay</a:t>
             </a:r>
@@ -12754,7 +13386,7 @@
             <a:spLocks noGrp="1"/>
           </p:cNvSpPr>
           <p:nvPr>
-            <p:ph type="body" idx="3" sz="quarter"/>
+            <p:ph type="body" sz="quarter" idx="3"/>
           </p:nvPr>
         </p:nvSpPr>
         <p:spPr/>
@@ -12775,7 +13407,7 @@
             <a:spLocks noGrp="1"/>
           </p:cNvSpPr>
           <p:nvPr>
-            <p:ph idx="4" sz="quarter"/>
+            <p:ph sz="quarter" idx="4"/>
           </p:nvPr>
         </p:nvSpPr>
         <p:spPr>
@@ -12786,23 +13418,20 @@
         </p:spPr>
         <p:txBody>
           <a:bodyPr>
-            <a:normAutofit fontScale="70000"/>
+            <a:normAutofit fontScale="92500" lnSpcReduction="20000"/>
           </a:bodyPr>
           <a:lstStyle/>
           <a:p>
-            <a:pPr/>
             <a:r>
               <a:t>Users kept being logged out when they switched computers</a:t>
             </a:r>
           </a:p>
           <a:p>
-            <a:pPr/>
             <a:r>
               <a:t>The support bot, "Sam", explained a one-device policy: "a core security feature"</a:t>
             </a:r>
           </a:p>
           <a:p>
-            <a:pPr/>
             <a:r>
               <a:t>There was no such policy; it was a bug. Users cancelled, and a co-founder apologised</a:t>
             </a:r>
@@ -12827,7 +13456,7 @@
         </p:spPr>
         <p:txBody>
           <a:bodyPr wrap="square">
-            <a:normAutofit fontScale="70000"/>
+            <a:normAutofit fontScale="70000" lnSpcReduction="10000"/>
           </a:bodyPr>
           <a:lstStyle>
             <a:lvl1pPr marL="228600" indent="-228600" algn="l" defTabSz="914400" rtl="0" eaLnBrk="1" latinLnBrk="0" hangingPunct="1">
@@ -12994,7 +13623,6 @@
             </a:lvl9pPr>
           </a:lstStyle>
           <a:p>
-            <a:pPr/>
             <a:r>
               <a:rPr b="1"/>
               <a:t>How do you make a model answer from your documents, not from its imagination?</a:t>
@@ -13389,7 +14017,7 @@
 </file>
 
 <file path=ppt/slides/slide30.xml><?xml version="1.0" encoding="utf-8"?>
-<p:sld xmlns:a="http://schemas.openxmlformats.org/drawingml/2006/main" xmlns:p="http://schemas.openxmlformats.org/presentationml/2006/main" xmlns:r="http://schemas.openxmlformats.org/officeDocument/2006/relationships">
+<p:sld xmlns:a="http://schemas.openxmlformats.org/drawingml/2006/main" xmlns:r="http://schemas.openxmlformats.org/officeDocument/2006/relationships" xmlns:p="http://schemas.openxmlformats.org/presentationml/2006/main">
   <p:cSld>
     <p:spTree>
       <p:nvGrpSpPr>
@@ -13397,7 +14025,14 @@
         <p:cNvGrpSpPr/>
         <p:nvPr/>
       </p:nvGrpSpPr>
-      <p:grpSpPr/>
+      <p:grpSpPr>
+        <a:xfrm>
+          <a:off x="0" y="0"/>
+          <a:ext cx="0" cy="0"/>
+          <a:chOff x="0" y="0"/>
+          <a:chExt cx="0" cy="0"/>
+        </a:xfrm>
+      </p:grpSpPr>
       <p:sp>
         <p:nvSpPr>
           <p:cNvPr id="2" name="Title 1"/>
@@ -13451,25 +14086,21 @@
             </a:r>
           </a:p>
           <a:p>
-            <a:pPr/>
             <a:r>
               <a:t>A chunk, embed and search pipeline with a vector database</a:t>
             </a:r>
           </a:p>
           <a:p>
-            <a:pPr/>
             <a:r>
               <a:t>Nothing: paste all five into every prompt</a:t>
             </a:r>
           </a:p>
           <a:p>
-            <a:pPr/>
             <a:r>
               <a:t>Fine-tune a model on them</a:t>
             </a:r>
           </a:p>
           <a:p>
-            <a:pPr/>
             <a:r>
               <a:t>Summarise each one, then throw the originals away</a:t>
             </a:r>
@@ -13714,7 +14345,7 @@
 </file>
 
 <file path=ppt/slides/slide31.xml><?xml version="1.0" encoding="utf-8"?>
-<p:sld xmlns:a="http://schemas.openxmlformats.org/drawingml/2006/main" xmlns:p="http://schemas.openxmlformats.org/presentationml/2006/main" xmlns:r="http://schemas.openxmlformats.org/officeDocument/2006/relationships">
+<p:sld xmlns:a="http://schemas.openxmlformats.org/drawingml/2006/main" xmlns:r="http://schemas.openxmlformats.org/officeDocument/2006/relationships" xmlns:p="http://schemas.openxmlformats.org/presentationml/2006/main">
   <p:cSld>
     <p:spTree>
       <p:nvGrpSpPr>
@@ -13722,7 +14353,14 @@
         <p:cNvGrpSpPr/>
         <p:nvPr/>
       </p:nvGrpSpPr>
-      <p:grpSpPr/>
+      <p:grpSpPr>
+        <a:xfrm>
+          <a:off x="0" y="0"/>
+          <a:ext cx="0" cy="0"/>
+          <a:chOff x="0" y="0"/>
+          <a:chExt cx="0" cy="0"/>
+        </a:xfrm>
+      </p:grpSpPr>
       <p:sp>
         <p:nvSpPr>
           <p:cNvPr id="2" name="Title 1"/>
@@ -13774,7 +14412,7 @@
             <a:spLocks noGrp="1"/>
           </p:cNvSpPr>
           <p:nvPr>
-            <p:ph idx="2" sz="half"/>
+            <p:ph sz="half" idx="2"/>
           </p:nvPr>
         </p:nvSpPr>
         <p:spPr>
@@ -13785,29 +14423,25 @@
         </p:spPr>
         <p:txBody>
           <a:bodyPr>
-            <a:normAutofit fontScale="70000"/>
+            <a:normAutofit fontScale="77500" lnSpcReduction="10000"/>
           </a:bodyPr>
           <a:lstStyle/>
           <a:p>
-            <a:pPr/>
             <a:r>
               <a:t>It fits comfortably in the window</a:t>
             </a:r>
           </a:p>
           <a:p>
-            <a:pPr/>
             <a:r>
               <a:t>Questions need the whole thing, not one fact</a:t>
             </a:r>
           </a:p>
           <a:p>
-            <a:pPr/>
             <a:r>
               <a:t>It changes rarely, and few people ask</a:t>
             </a:r>
           </a:p>
           <a:p>
-            <a:pPr/>
             <a:r>
               <a:t>No index to build, nothing to go stale</a:t>
             </a:r>
@@ -13821,7 +14455,7 @@
             <a:spLocks noGrp="1"/>
           </p:cNvSpPr>
           <p:nvPr>
-            <p:ph type="body" idx="3" sz="quarter"/>
+            <p:ph type="body" sz="quarter" idx="3"/>
           </p:nvPr>
         </p:nvSpPr>
         <p:spPr/>
@@ -13842,7 +14476,7 @@
             <a:spLocks noGrp="1"/>
           </p:cNvSpPr>
           <p:nvPr>
-            <p:ph idx="4" sz="quarter"/>
+            <p:ph sz="quarter" idx="4"/>
           </p:nvPr>
         </p:nvSpPr>
         <p:spPr>
@@ -13853,35 +14487,30 @@
         </p:spPr>
         <p:txBody>
           <a:bodyPr>
-            <a:normAutofit fontScale="70000"/>
+            <a:normAutofit fontScale="77500" lnSpcReduction="10000"/>
           </a:bodyPr>
           <a:lstStyle/>
           <a:p>
-            <a:pPr/>
             <a:r>
               <a:t>Too big to fit: thousands of documents</a:t>
             </a:r>
           </a:p>
           <a:p>
-            <a:pPr/>
             <a:r>
               <a:t>You must cite exactly which source said it</a:t>
             </a:r>
           </a:p>
           <a:p>
-            <a:pPr/>
             <a:r>
               <a:t>The data changes every day</a:t>
             </a:r>
           </a:p>
           <a:p>
-            <a:pPr/>
             <a:r>
               <a:t>Cost: every question would resend everything</a:t>
             </a:r>
           </a:p>
           <a:p>
-            <a:pPr/>
             <a:r>
               <a:t>Different users may see different documents</a:t>
             </a:r>
@@ -13906,7 +14535,7 @@
         </p:spPr>
         <p:txBody>
           <a:bodyPr wrap="square">
-            <a:normAutofit fontScale="70000"/>
+            <a:normAutofit fontScale="70000" lnSpcReduction="10000"/>
           </a:bodyPr>
           <a:lstStyle>
             <a:lvl1pPr marL="228600" indent="-228600" algn="l" defTabSz="914400" rtl="0" eaLnBrk="1" latinLnBrk="0" hangingPunct="1">
@@ -14073,7 +14702,6 @@
             </a:lvl9pPr>
           </a:lstStyle>
           <a:p>
-            <a:pPr/>
             <a:r>
               <a:t>The tempting answer, the pipeline, is a lot of machinery for 2,000 words a model can simply read</a:t>
             </a:r>
@@ -14614,7 +15242,7 @@
 </file>
 
 <file path=ppt/slides/slide32.xml><?xml version="1.0" encoding="utf-8"?>
-<p:sld xmlns:a="http://schemas.openxmlformats.org/drawingml/2006/main" xmlns:p="http://schemas.openxmlformats.org/presentationml/2006/main" xmlns:r="http://schemas.openxmlformats.org/officeDocument/2006/relationships">
+<p:sld xmlns:a="http://schemas.openxmlformats.org/drawingml/2006/main" xmlns:r="http://schemas.openxmlformats.org/officeDocument/2006/relationships" xmlns:p="http://schemas.openxmlformats.org/presentationml/2006/main">
   <p:cSld>
     <p:spTree>
       <p:nvGrpSpPr>
@@ -14622,7 +15250,14 @@
         <p:cNvGrpSpPr/>
         <p:nvPr/>
       </p:nvGrpSpPr>
-      <p:grpSpPr/>
+      <p:grpSpPr>
+        <a:xfrm>
+          <a:off x="0" y="0"/>
+          <a:ext cx="0" cy="0"/>
+          <a:chOff x="0" y="0"/>
+          <a:chExt cx="0" cy="0"/>
+        </a:xfrm>
+      </p:grpSpPr>
       <p:sp>
         <p:nvSpPr>
           <p:cNvPr id="2" name="Title 1"/>
@@ -14664,17 +15299,15 @@
         </p:spPr>
         <p:txBody>
           <a:bodyPr>
-            <a:normAutofit fontScale="92500"/>
+            <a:normAutofit lnSpcReduction="10000"/>
           </a:bodyPr>
           <a:lstStyle/>
           <a:p>
-            <a:pPr/>
             <a:r>
               <a:t>Context rot: Chroma tested 18 models in 2025; every one got less reliable as its input grew, even on simple tasks</a:t>
             </a:r>
           </a:p>
           <a:p>
-            <a:pPr/>
             <a:r>
               <a:t>In one test, a 300-token prompt holding just the relevant part beat the full 113,000-token history, for every model</a:t>
             </a:r>
@@ -14686,19 +15319,16 @@
             </a:r>
           </a:p>
           <a:p>
-            <a:pPr/>
             <a:r>
               <a:t>Lost in the middle: facts buried mid-prompt are used less reliably than facts at either end</a:t>
             </a:r>
           </a:p>
           <a:p>
-            <a:pPr/>
             <a:r>
               <a:t>Every token is paid for, and waited for, on every question</a:t>
             </a:r>
           </a:p>
           <a:p>
-            <a:pPr/>
             <a:r>
               <a:t>More tokens is not more understanding</a:t>
             </a:r>
@@ -15023,7 +15653,7 @@
 </file>
 
 <file path=ppt/slides/slide33.xml><?xml version="1.0" encoding="utf-8"?>
-<p:sld xmlns:a="http://schemas.openxmlformats.org/drawingml/2006/main" xmlns:p="http://schemas.openxmlformats.org/presentationml/2006/main" xmlns:r="http://schemas.openxmlformats.org/officeDocument/2006/relationships">
+<p:sld xmlns:a="http://schemas.openxmlformats.org/drawingml/2006/main" xmlns:r="http://schemas.openxmlformats.org/officeDocument/2006/relationships" xmlns:p="http://schemas.openxmlformats.org/presentationml/2006/main">
   <p:cSld>
     <p:spTree>
       <p:nvGrpSpPr>
@@ -15031,7 +15661,14 @@
         <p:cNvGrpSpPr/>
         <p:nvPr/>
       </p:nvGrpSpPr>
-      <p:grpSpPr/>
+      <p:grpSpPr>
+        <a:xfrm>
+          <a:off x="0" y="0"/>
+          <a:ext cx="0" cy="0"/>
+          <a:chOff x="0" y="0"/>
+          <a:chExt cx="0" cy="0"/>
+        </a:xfrm>
+      </p:grpSpPr>
       <p:sp>
         <p:nvSpPr>
           <p:cNvPr id="2" name="Title 1"/>
@@ -15108,7 +15745,7 @@
             </a:fontRef>
           </p:style>
           <p:txBody>
-            <a:bodyPr rtlCol="0" anchor="ctr" wrap="square" lIns="109728" rIns="109728" tIns="54864" bIns="54864">
+            <a:bodyPr wrap="square" lIns="109728" tIns="54864" rIns="109728" bIns="54864" rtlCol="0" anchor="ctr">
               <a:noAutofit/>
             </a:bodyPr>
             <a:lstStyle/>
@@ -15175,7 +15812,7 @@
             </a:fontRef>
           </p:style>
           <p:txBody>
-            <a:bodyPr rtlCol="0" anchor="ctr" wrap="square" lIns="109728" rIns="109728" tIns="54864" bIns="54864">
+            <a:bodyPr wrap="square" lIns="109728" tIns="54864" rIns="109728" bIns="54864" rtlCol="0" anchor="ctr">
               <a:noAutofit/>
             </a:bodyPr>
             <a:lstStyle/>
@@ -15242,7 +15879,7 @@
             </a:fontRef>
           </p:style>
           <p:txBody>
-            <a:bodyPr rtlCol="0" anchor="ctr" wrap="square" lIns="109728" rIns="109728" tIns="54864" bIns="54864">
+            <a:bodyPr wrap="square" lIns="109728" tIns="54864" rIns="109728" bIns="54864" rtlCol="0" anchor="ctr">
               <a:noAutofit/>
             </a:bodyPr>
             <a:lstStyle/>
@@ -15309,7 +15946,7 @@
             </a:fontRef>
           </p:style>
           <p:txBody>
-            <a:bodyPr rtlCol="0" anchor="ctr" wrap="square" lIns="109728" rIns="109728" tIns="54864" bIns="54864">
+            <a:bodyPr wrap="square" lIns="109728" tIns="54864" rIns="109728" bIns="54864" rtlCol="0" anchor="ctr">
               <a:noAutofit/>
             </a:bodyPr>
             <a:lstStyle/>
@@ -15477,19 +16114,16 @@
           </a:bodyPr>
           <a:lstStyle/>
           <a:p>
-            <a:pPr/>
             <a:r>
               <a:t>Retrieval finds the pieces; the long read joins them up</a:t>
             </a:r>
           </a:p>
           <a:p>
-            <a:pPr/>
             <a:r>
               <a:t>Bounded: cost stays proportional and every citation stays checkable</a:t>
             </a:r>
           </a:p>
           <a:p>
-            <a:pPr/>
             <a:r>
               <a:t>This is context engineering: deciding exactly what the model reads</a:t>
             </a:r>
@@ -15685,7 +16319,7 @@
 </file>
 
 <file path=ppt/slides/slide34.xml><?xml version="1.0" encoding="utf-8"?>
-<p:sld xmlns:a="http://schemas.openxmlformats.org/drawingml/2006/main" xmlns:p="http://schemas.openxmlformats.org/presentationml/2006/main" xmlns:r="http://schemas.openxmlformats.org/officeDocument/2006/relationships">
+<p:sld xmlns:a="http://schemas.openxmlformats.org/drawingml/2006/main" xmlns:r="http://schemas.openxmlformats.org/officeDocument/2006/relationships" xmlns:p="http://schemas.openxmlformats.org/presentationml/2006/main">
   <p:cSld>
     <p:spTree>
       <p:nvGrpSpPr>
@@ -15693,7 +16327,14 @@
         <p:cNvGrpSpPr/>
         <p:nvPr/>
       </p:nvGrpSpPr>
-      <p:grpSpPr/>
+      <p:grpSpPr>
+        <a:xfrm>
+          <a:off x="0" y="0"/>
+          <a:ext cx="0" cy="0"/>
+          <a:chOff x="0" y="0"/>
+          <a:chExt cx="0" cy="0"/>
+        </a:xfrm>
+      </p:grpSpPr>
       <p:sp>
         <p:nvSpPr>
           <p:cNvPr id="2" name="Title 1"/>
@@ -15754,25 +16395,21 @@
             </a:r>
           </a:p>
           <a:p>
-            <a:pPr/>
             <a:r>
               <a:t>An empty result</a:t>
             </a:r>
           </a:p>
           <a:p>
-            <a:pPr/>
             <a:r>
               <a:t>An error: no relevant chunks</a:t>
             </a:r>
           </a:p>
           <a:p>
-            <a:pPr/>
             <a:r>
               <a:t>Three chunks anyway</a:t>
             </a:r>
           </a:p>
           <a:p>
-            <a:pPr/>
             <a:r>
               <a:t>One chunk, flagged as a weak match</a:t>
             </a:r>
@@ -16017,7 +16654,7 @@
 </file>
 
 <file path=ppt/slides/slide35.xml><?xml version="1.0" encoding="utf-8"?>
-<p:sld xmlns:a="http://schemas.openxmlformats.org/drawingml/2006/main" xmlns:p="http://schemas.openxmlformats.org/presentationml/2006/main" xmlns:r="http://schemas.openxmlformats.org/officeDocument/2006/relationships">
+<p:sld xmlns:a="http://schemas.openxmlformats.org/drawingml/2006/main" xmlns:r="http://schemas.openxmlformats.org/officeDocument/2006/relationships" xmlns:p="http://schemas.openxmlformats.org/presentationml/2006/main">
   <p:cSld>
     <p:spTree>
       <p:nvGrpSpPr>
@@ -16025,7 +16662,14 @@
         <p:cNvGrpSpPr/>
         <p:nvPr/>
       </p:nvGrpSpPr>
-      <p:grpSpPr/>
+      <p:grpSpPr>
+        <a:xfrm>
+          <a:off x="0" y="0"/>
+          <a:ext cx="0" cy="0"/>
+          <a:chOff x="0" y="0"/>
+          <a:chExt cx="0" cy="0"/>
+        </a:xfrm>
+      </p:grpSpPr>
       <p:sp>
         <p:nvSpPr>
           <p:cNvPr id="2" name="Title 1"/>
@@ -16088,7 +16732,7 @@
           </a:fontRef>
         </p:style>
         <p:txBody>
-          <a:bodyPr rtlCol="0" anchor="t" wrap="none" lIns="137160" rIns="137160" tIns="91440" bIns="91440">
+          <a:bodyPr wrap="none" lIns="137160" tIns="91440" rIns="137160" bIns="91440" rtlCol="0" anchor="t">
             <a:noAutofit/>
           </a:bodyPr>
           <a:lstStyle/>
@@ -16192,19 +16836,16 @@
           </a:bodyPr>
           <a:lstStyle/>
           <a:p>
-            <a:pPr/>
             <a:r>
               <a:t>Search ranks every chunk and returns the top k, always. "Relevant" is not a concept it has</a:t>
             </a:r>
           </a:p>
           <a:p>
-            <a:pPr/>
             <a:r>
               <a:t>The score is the only signal: a 0.20 threshold drops all three, and keeps the best chunks for both variable questions</a:t>
             </a:r>
           </a:p>
           <a:p>
-            <a:pPr/>
             <a:r>
               <a:t>The common wrong answer, "an empty result", assumes search knows when to stop</a:t>
             </a:r>
@@ -16400,7 +17041,7 @@
 </file>
 
 <file path=ppt/slides/slide36.xml><?xml version="1.0" encoding="utf-8"?>
-<p:sld xmlns:a="http://schemas.openxmlformats.org/drawingml/2006/main" xmlns:p="http://schemas.openxmlformats.org/presentationml/2006/main" xmlns:r="http://schemas.openxmlformats.org/officeDocument/2006/relationships">
+<p:sld xmlns:a="http://schemas.openxmlformats.org/drawingml/2006/main" xmlns:r="http://schemas.openxmlformats.org/officeDocument/2006/relationships" xmlns:p="http://schemas.openxmlformats.org/presentationml/2006/main">
   <p:cSld>
     <p:spTree>
       <p:nvGrpSpPr>
@@ -16408,7 +17049,14 @@
         <p:cNvGrpSpPr/>
         <p:nvPr/>
       </p:nvGrpSpPr>
-      <p:grpSpPr/>
+      <p:grpSpPr>
+        <a:xfrm>
+          <a:off x="0" y="0"/>
+          <a:ext cx="0" cy="0"/>
+          <a:chOff x="0" y="0"/>
+          <a:chExt cx="0" cy="0"/>
+        </a:xfrm>
+      </p:grpSpPr>
       <p:sp>
         <p:nvSpPr>
           <p:cNvPr id="2" name="Title 1"/>
@@ -16471,7 +17119,7 @@
           </a:fontRef>
         </p:style>
         <p:txBody>
-          <a:bodyPr rtlCol="0" anchor="t" wrap="none" lIns="137160" rIns="137160" tIns="91440" bIns="91440">
+          <a:bodyPr wrap="none" lIns="137160" tIns="91440" rIns="137160" bIns="91440" rtlCol="0" anchor="t">
             <a:noAutofit/>
           </a:bodyPr>
           <a:lstStyle/>
@@ -16594,19 +17242,16 @@
           </a:bodyPr>
           <a:lstStyle/>
           <a:p>
-            <a:pPr/>
             <a:r>
               <a:t>No error: both models make 384 numbers, so the sums run. The right chunk isn't even in the top three</a:t>
             </a:r>
           </a:p>
           <a:p>
-            <a:pPr/>
             <a:r>
               <a:t>It can half-work by luck (a linked-list question still found its chunks), so the bug hides</a:t>
             </a:r>
           </a:p>
           <a:p>
-            <a:pPr/>
             <a:r>
               <a:t>Google's own docs: gemini-embedding-001 and gemini-embedding-2 are incompatible, so upgrading means re-embedding everything</a:t>
             </a:r>
@@ -16802,7 +17447,7 @@
 </file>
 
 <file path=ppt/slides/slide37.xml><?xml version="1.0" encoding="utf-8"?>
-<p:sld xmlns:a="http://schemas.openxmlformats.org/drawingml/2006/main" xmlns:p="http://schemas.openxmlformats.org/presentationml/2006/main" xmlns:r="http://schemas.openxmlformats.org/officeDocument/2006/relationships">
+<p:sld xmlns:a="http://schemas.openxmlformats.org/drawingml/2006/main" xmlns:r="http://schemas.openxmlformats.org/officeDocument/2006/relationships" xmlns:p="http://schemas.openxmlformats.org/presentationml/2006/main">
   <p:cSld>
     <p:spTree>
       <p:nvGrpSpPr>
@@ -16810,7 +17455,14 @@
         <p:cNvGrpSpPr/>
         <p:nvPr/>
       </p:nvGrpSpPr>
-      <p:grpSpPr/>
+      <p:grpSpPr>
+        <a:xfrm>
+          <a:off x="0" y="0"/>
+          <a:ext cx="0" cy="0"/>
+          <a:chOff x="0" y="0"/>
+          <a:chExt cx="0" cy="0"/>
+        </a:xfrm>
+      </p:grpSpPr>
       <p:sp>
         <p:nvSpPr>
           <p:cNvPr id="2" name="Title 1"/>
@@ -16864,25 +17516,21 @@
             </a:r>
           </a:p>
           <a:p>
-            <a:pPr/>
             <a:r>
               <a:t>What is a variable?</a:t>
             </a:r>
           </a:p>
           <a:p>
-            <a:pPr/>
             <a:r>
               <a:t>How can my code remember a number for later?</a:t>
             </a:r>
           </a:p>
           <a:p>
-            <a:pPr/>
             <a:r>
               <a:t>Which topics do these five documents cover?</a:t>
             </a:r>
           </a:p>
           <a:p>
-            <a:pPr/>
             <a:r>
               <a:t>How do I bake sourdough?</a:t>
             </a:r>
@@ -17127,7 +17775,7 @@
 </file>
 
 <file path=ppt/slides/slide38.xml><?xml version="1.0" encoding="utf-8"?>
-<p:sld xmlns:a="http://schemas.openxmlformats.org/drawingml/2006/main" xmlns:p="http://schemas.openxmlformats.org/presentationml/2006/main" xmlns:r="http://schemas.openxmlformats.org/officeDocument/2006/relationships">
+<p:sld xmlns:a="http://schemas.openxmlformats.org/drawingml/2006/main" xmlns:r="http://schemas.openxmlformats.org/officeDocument/2006/relationships" xmlns:p="http://schemas.openxmlformats.org/presentationml/2006/main">
   <p:cSld>
     <p:spTree>
       <p:nvGrpSpPr>
@@ -17135,7 +17783,14 @@
         <p:cNvGrpSpPr/>
         <p:nvPr/>
       </p:nvGrpSpPr>
-      <p:grpSpPr/>
+      <p:grpSpPr>
+        <a:xfrm>
+          <a:off x="0" y="0"/>
+          <a:ext cx="0" cy="0"/>
+          <a:chOff x="0" y="0"/>
+          <a:chExt cx="0" cy="0"/>
+        </a:xfrm>
+      </p:grpSpPr>
       <p:sp>
         <p:nvSpPr>
           <p:cNvPr id="2" name="Title 1"/>
@@ -17198,7 +17853,7 @@
           </a:fontRef>
         </p:style>
         <p:txBody>
-          <a:bodyPr rtlCol="0" anchor="t" wrap="none" lIns="137160" rIns="137160" tIns="91440" bIns="91440">
+          <a:bodyPr wrap="none" lIns="137160" tIns="91440" rIns="137160" bIns="91440" rtlCol="0" anchor="t">
             <a:noAutofit/>
           </a:bodyPr>
           <a:lstStyle/>
@@ -17302,19 +17957,16 @@
           </a:bodyPr>
           <a:lstStyle/>
           <a:p>
-            <a:pPr/>
             <a:r>
               <a:t>3 chunks from 3 documents: the other 2 are never seen</a:t>
             </a:r>
           </a:p>
           <a:p>
-            <a:pPr/>
             <a:r>
               <a:t>From those chunks, 6 of 9 replies said "I don't know" and 3 listed only the three documents they saw. From all five, 9 of 9 named every topic</a:t>
             </a:r>
           </a:p>
           <a:p>
-            <a:pPr/>
             <a:r>
               <a:t>Top-k suits local questions, whose answer lives in one place. A global question needs the whole corpus</a:t>
             </a:r>
@@ -17510,7 +18162,7 @@
 </file>
 
 <file path=ppt/slides/slide39.xml><?xml version="1.0" encoding="utf-8"?>
-<p:sld xmlns:a="http://schemas.openxmlformats.org/drawingml/2006/main" xmlns:p="http://schemas.openxmlformats.org/presentationml/2006/main" xmlns:r="http://schemas.openxmlformats.org/officeDocument/2006/relationships">
+<p:sld xmlns:a="http://schemas.openxmlformats.org/drawingml/2006/main" xmlns:r="http://schemas.openxmlformats.org/officeDocument/2006/relationships" xmlns:p="http://schemas.openxmlformats.org/presentationml/2006/main">
   <p:cSld>
     <p:spTree>
       <p:nvGrpSpPr>
@@ -17518,7 +18170,14 @@
         <p:cNvGrpSpPr/>
         <p:nvPr/>
       </p:nvGrpSpPr>
-      <p:grpSpPr/>
+      <p:grpSpPr>
+        <a:xfrm>
+          <a:off x="0" y="0"/>
+          <a:ext cx="0" cy="0"/>
+          <a:chOff x="0" y="0"/>
+          <a:chExt cx="0" cy="0"/>
+        </a:xfrm>
+      </p:grpSpPr>
       <p:sp>
         <p:nvSpPr>
           <p:cNvPr id="2" name="Title 1"/>
@@ -17564,25 +18223,21 @@
           </a:bodyPr>
           <a:lstStyle/>
           <a:p>
-            <a:pPr/>
             <a:r>
               <a:t>May 2024: asked how to stop cheese sliding off pizza, Google's AI Overview suggested adding "1/8 cup of non-toxic glue to the sauce"</a:t>
             </a:r>
           </a:p>
           <a:p>
-            <a:pPr/>
             <a:r>
               <a:t>The source: an 11-year-old joke comment on Reddit</a:t>
             </a:r>
           </a:p>
           <a:p>
-            <a:pPr/>
             <a:r>
               <a:t>Retrieval worked. The source was real. It was a joke</a:t>
             </a:r>
           </a:p>
           <a:p>
-            <a:pPr/>
             <a:r>
               <a:rPr b="1"/>
               <a:t>RAG makes a model as reliable as what it retrieves, and no more</a:t>
@@ -17828,7 +18483,7 @@
 </file>
 
 <file path=ppt/slides/slide4.xml><?xml version="1.0" encoding="utf-8"?>
-<p:sld xmlns:a="http://schemas.openxmlformats.org/drawingml/2006/main" xmlns:p="http://schemas.openxmlformats.org/presentationml/2006/main" xmlns:r="http://schemas.openxmlformats.org/officeDocument/2006/relationships">
+<p:sld xmlns:a="http://schemas.openxmlformats.org/drawingml/2006/main" xmlns:r="http://schemas.openxmlformats.org/officeDocument/2006/relationships" xmlns:p="http://schemas.openxmlformats.org/presentationml/2006/main">
   <p:cSld>
     <p:spTree>
       <p:nvGrpSpPr>
@@ -17836,7 +18491,14 @@
         <p:cNvGrpSpPr/>
         <p:nvPr/>
       </p:nvGrpSpPr>
-      <p:grpSpPr/>
+      <p:grpSpPr>
+        <a:xfrm>
+          <a:off x="0" y="0"/>
+          <a:ext cx="0" cy="0"/>
+          <a:chOff x="0" y="0"/>
+          <a:chExt cx="0" cy="0"/>
+        </a:xfrm>
+      </p:grpSpPr>
       <p:sp>
         <p:nvSpPr>
           <p:cNvPr id="2" name="Title 1"/>
@@ -17888,7 +18550,7 @@
             <a:spLocks noGrp="1"/>
           </p:cNvSpPr>
           <p:nvPr>
-            <p:ph idx="2" sz="half"/>
+            <p:ph sz="half" idx="2"/>
           </p:nvPr>
         </p:nvSpPr>
         <p:spPr>
@@ -17899,29 +18561,25 @@
         </p:spPr>
         <p:txBody>
           <a:bodyPr>
-            <a:normAutofit fontScale="85000"/>
+            <a:normAutofit fontScale="92500" lnSpcReduction="10000"/>
           </a:bodyPr>
           <a:lstStyle/>
           <a:p>
-            <a:pPr/>
             <a:r>
               <a:t>Why models need it; web RAG and private RAG</a:t>
             </a:r>
           </a:p>
           <a:p>
-            <a:pPr/>
             <a:r>
               <a:t>The pipeline: load, chunk, embed, store, search, generate</a:t>
             </a:r>
           </a:p>
           <a:p>
-            <a:pPr/>
             <a:r>
               <a:t>Grounding and citations</a:t>
             </a:r>
           </a:p>
           <a:p>
-            <a:pPr/>
             <a:r>
               <a:t>What RAG fixes, and what it costs</a:t>
             </a:r>
@@ -17935,7 +18593,7 @@
             <a:spLocks noGrp="1"/>
           </p:cNvSpPr>
           <p:nvPr>
-            <p:ph type="body" idx="3" sz="quarter"/>
+            <p:ph type="body" sz="quarter" idx="3"/>
           </p:nvPr>
         </p:nvSpPr>
         <p:spPr/>
@@ -17956,7 +18614,7 @@
             <a:spLocks noGrp="1"/>
           </p:cNvSpPr>
           <p:nvPr>
-            <p:ph idx="4" sz="quarter"/>
+            <p:ph sz="quarter" idx="4"/>
           </p:nvPr>
         </p:nvSpPr>
         <p:spPr>
@@ -17967,35 +18625,30 @@
         </p:spPr>
         <p:txBody>
           <a:bodyPr>
-            <a:normAutofit fontScale="85000"/>
+            <a:normAutofit fontScale="92500" lnSpcReduction="10000"/>
           </a:bodyPr>
           <a:lstStyle/>
           <a:p>
-            <a:pPr/>
             <a:r>
               <a:t>Million-token context windows: when to skip RAG</a:t>
             </a:r>
           </a:p>
           <a:p>
-            <a:pPr/>
             <a:r>
               <a:t>When retrieval goes wrong</a:t>
             </a:r>
           </a:p>
           <a:p>
-            <a:pPr/>
             <a:r>
               <a:t>Better retrieval: hybrid, rerank, graph, agentic</a:t>
             </a:r>
           </a:p>
           <a:p>
-            <a:pPr/>
             <a:r>
               <a:t>How coding assistants find your code</a:t>
             </a:r>
           </a:p>
           <a:p>
-            <a:pPr/>
             <a:r>
               <a:t>Try it now: ground an answer by hand</a:t>
             </a:r>
@@ -18486,7 +19139,7 @@
 </file>
 
 <file path=ppt/slides/slide40.xml><?xml version="1.0" encoding="utf-8"?>
-<p:sld xmlns:a="http://schemas.openxmlformats.org/drawingml/2006/main" xmlns:p="http://schemas.openxmlformats.org/presentationml/2006/main" xmlns:r="http://schemas.openxmlformats.org/officeDocument/2006/relationships">
+<p:sld xmlns:a="http://schemas.openxmlformats.org/drawingml/2006/main" xmlns:r="http://schemas.openxmlformats.org/officeDocument/2006/relationships" xmlns:p="http://schemas.openxmlformats.org/presentationml/2006/main">
   <p:cSld>
     <p:spTree>
       <p:nvGrpSpPr>
@@ -18494,7 +19147,14 @@
         <p:cNvGrpSpPr/>
         <p:nvPr/>
       </p:nvGrpSpPr>
-      <p:grpSpPr/>
+      <p:grpSpPr>
+        <a:xfrm>
+          <a:off x="0" y="0"/>
+          <a:ext cx="0" cy="0"/>
+          <a:chOff x="0" y="0"/>
+          <a:chExt cx="0" cy="0"/>
+        </a:xfrm>
+      </p:grpSpPr>
       <p:sp>
         <p:nvSpPr>
           <p:cNvPr id="2" name="Title 1"/>
@@ -18540,13 +19200,11 @@
           </a:bodyPr>
           <a:lstStyle/>
           <a:p>
-            <a:pPr/>
             <a:r>
               <a:t>Whatever lands in the prompt can steer the model, including instructions hidden in a document</a:t>
             </a:r>
           </a:p>
           <a:p>
-            <a:pPr/>
             <a:r>
               <a:t>June 2025, "EchoLeak": one email, never even opened, was pulled into Microsoft 365 Copilot's context, and hidden instructions in it made Copilot leak internal data</a:t>
             </a:r>
@@ -18558,13 +19216,11 @@
             </a:r>
           </a:p>
           <a:p>
-            <a:pPr/>
             <a:r>
               <a:t>Poisoning: plant crafted documents, and the system retrieves them on cue</a:t>
             </a:r>
           </a:p>
           <a:p>
-            <a:pPr/>
             <a:r>
               <a:t>So filter what gets indexed, respect permissions, and never let retrieved text trigger actions unchecked</a:t>
             </a:r>
@@ -18840,7 +19496,7 @@
 </file>
 
 <file path=ppt/slides/slide41.xml><?xml version="1.0" encoding="utf-8"?>
-<p:sld xmlns:a="http://schemas.openxmlformats.org/drawingml/2006/main" xmlns:p="http://schemas.openxmlformats.org/presentationml/2006/main" xmlns:r="http://schemas.openxmlformats.org/officeDocument/2006/relationships">
+<p:sld xmlns:a="http://schemas.openxmlformats.org/drawingml/2006/main" xmlns:r="http://schemas.openxmlformats.org/officeDocument/2006/relationships" xmlns:p="http://schemas.openxmlformats.org/presentationml/2006/main">
   <p:cSld>
     <p:spTree>
       <p:nvGrpSpPr>
@@ -18848,7 +19504,14 @@
         <p:cNvGrpSpPr/>
         <p:nvPr/>
       </p:nvGrpSpPr>
-      <p:grpSpPr/>
+      <p:grpSpPr>
+        <a:xfrm>
+          <a:off x="0" y="0"/>
+          <a:ext cx="0" cy="0"/>
+          <a:chOff x="0" y="0"/>
+          <a:chExt cx="0" cy="0"/>
+        </a:xfrm>
+      </p:grpSpPr>
       <p:sp>
         <p:nvSpPr>
           <p:cNvPr id="2" name="Title 1"/>
@@ -18927,7 +19590,7 @@
             </a:fontRef>
           </p:style>
           <p:txBody>
-            <a:bodyPr rtlCol="0" anchor="ctr" wrap="square" lIns="109728" rIns="109728" tIns="54864" bIns="54864">
+            <a:bodyPr wrap="square" lIns="109728" tIns="54864" rIns="109728" bIns="54864" rtlCol="0" anchor="ctr">
               <a:noAutofit/>
             </a:bodyPr>
             <a:lstStyle/>
@@ -18997,7 +19660,7 @@
             </a:fontRef>
           </p:style>
           <p:txBody>
-            <a:bodyPr rtlCol="0" anchor="ctr" wrap="square" lIns="109728" rIns="109728" tIns="54864" bIns="54864">
+            <a:bodyPr wrap="square" lIns="109728" tIns="54864" rIns="109728" bIns="54864" rtlCol="0" anchor="ctr">
               <a:noAutofit/>
             </a:bodyPr>
             <a:lstStyle/>
@@ -19055,7 +19718,7 @@
             </a:fontRef>
           </p:style>
           <p:txBody>
-            <a:bodyPr rtlCol="0" anchor="ctr" wrap="square" lIns="109728" rIns="109728" tIns="54864" bIns="54864">
+            <a:bodyPr wrap="square" lIns="109728" tIns="54864" rIns="109728" bIns="54864" rtlCol="0" anchor="ctr">
               <a:noAutofit/>
             </a:bodyPr>
             <a:lstStyle/>
@@ -19113,7 +19776,7 @@
             </a:fontRef>
           </p:style>
           <p:txBody>
-            <a:bodyPr rtlCol="0" anchor="ctr" wrap="square" lIns="109728" rIns="109728" tIns="54864" bIns="54864">
+            <a:bodyPr wrap="square" lIns="109728" tIns="54864" rIns="109728" bIns="54864" rtlCol="0" anchor="ctr">
               <a:noAutofit/>
             </a:bodyPr>
             <a:lstStyle/>
@@ -19171,7 +19834,7 @@
             </a:fontRef>
           </p:style>
           <p:txBody>
-            <a:bodyPr rtlCol="0" anchor="ctr" wrap="square" lIns="109728" rIns="109728" tIns="54864" bIns="54864">
+            <a:bodyPr wrap="square" lIns="109728" tIns="54864" rIns="109728" bIns="54864" rtlCol="0" anchor="ctr">
               <a:noAutofit/>
             </a:bodyPr>
             <a:lstStyle/>
@@ -19223,7 +19886,6 @@
           </a:bodyPr>
           <a:lstStyle/>
           <a:p>
-            <a:pPr/>
             <a:r>
               <a:t>Each layer costs more, and fixes a failure of the one below it</a:t>
             </a:r>
@@ -19321,7 +19983,7 @@
 </file>
 
 <file path=ppt/slides/slide42.xml><?xml version="1.0" encoding="utf-8"?>
-<p:sld xmlns:a="http://schemas.openxmlformats.org/drawingml/2006/main" xmlns:p="http://schemas.openxmlformats.org/presentationml/2006/main" xmlns:r="http://schemas.openxmlformats.org/officeDocument/2006/relationships">
+<p:sld xmlns:a="http://schemas.openxmlformats.org/drawingml/2006/main" xmlns:r="http://schemas.openxmlformats.org/officeDocument/2006/relationships" xmlns:p="http://schemas.openxmlformats.org/presentationml/2006/main">
   <p:cSld>
     <p:spTree>
       <p:nvGrpSpPr>
@@ -19329,7 +19991,14 @@
         <p:cNvGrpSpPr/>
         <p:nvPr/>
       </p:nvGrpSpPr>
-      <p:grpSpPr/>
+      <p:grpSpPr>
+        <a:xfrm>
+          <a:off x="0" y="0"/>
+          <a:ext cx="0" cy="0"/>
+          <a:chOff x="0" y="0"/>
+          <a:chExt cx="0" cy="0"/>
+        </a:xfrm>
+      </p:grpSpPr>
       <p:sp>
         <p:nvSpPr>
           <p:cNvPr id="2" name="Title 1"/>
@@ -19381,7 +20050,7 @@
             <a:spLocks noGrp="1"/>
           </p:cNvSpPr>
           <p:nvPr>
-            <p:ph idx="2" sz="half"/>
+            <p:ph sz="half" idx="2"/>
           </p:nvPr>
         </p:nvSpPr>
         <p:spPr>
@@ -19392,17 +20061,15 @@
         </p:spPr>
         <p:txBody>
           <a:bodyPr>
-            <a:normAutofit fontScale="92500"/>
+            <a:normAutofit/>
           </a:bodyPr>
           <a:lstStyle/>
           <a:p>
-            <a:pPr/>
             <a:r>
               <a:t>"how do I quit" finds "resignation process"</a:t>
             </a:r>
           </a:p>
           <a:p>
-            <a:pPr/>
             <a:r>
               <a:t>The wording varies; the idea doesn't</a:t>
             </a:r>
@@ -19416,7 +20083,7 @@
             <a:spLocks noGrp="1"/>
           </p:cNvSpPr>
           <p:nvPr>
-            <p:ph type="body" idx="3" sz="quarter"/>
+            <p:ph type="body" sz="quarter" idx="3"/>
           </p:nvPr>
         </p:nvSpPr>
         <p:spPr/>
@@ -19437,7 +20104,7 @@
             <a:spLocks noGrp="1"/>
           </p:cNvSpPr>
           <p:nvPr>
-            <p:ph idx="4" sz="quarter"/>
+            <p:ph sz="quarter" idx="4"/>
           </p:nvPr>
         </p:nvSpPr>
         <p:spPr>
@@ -19448,11 +20115,10 @@
         </p:spPr>
         <p:txBody>
           <a:bodyPr>
-            <a:normAutofit fontScale="92500"/>
+            <a:normAutofit/>
           </a:bodyPr>
           <a:lstStyle/>
           <a:p>
-            <a:pPr/>
             <a:r>
               <a:t>ERR_4021, </a:t>
             </a:r>
@@ -19467,13 +20133,11 @@
             </a:r>
           </a:p>
           <a:p>
-            <a:pPr/>
             <a:r>
               <a:t>Names, codes, file paths: exact strings</a:t>
             </a:r>
           </a:p>
           <a:p>
-            <a:pPr/>
             <a:r>
               <a:t>An embedding blurs the exact spelling</a:t>
             </a:r>
@@ -19498,7 +20162,7 @@
         </p:spPr>
         <p:txBody>
           <a:bodyPr wrap="square">
-            <a:normAutofit fontScale="92500"/>
+            <a:normAutofit fontScale="92500" lnSpcReduction="10000"/>
           </a:bodyPr>
           <a:lstStyle>
             <a:lvl1pPr marL="228600" indent="-228600" algn="l" defTabSz="914400" rtl="0" eaLnBrk="1" latinLnBrk="0" hangingPunct="1">
@@ -19665,7 +20329,6 @@
             </a:lvl9pPr>
           </a:lstStyle>
           <a:p>
-            <a:pPr/>
             <a:r>
               <a:rPr b="1"/>
               <a:t>Hybrid retrieval</a:t>
@@ -20014,7 +20677,7 @@
 </file>
 
 <file path=ppt/slides/slide43.xml><?xml version="1.0" encoding="utf-8"?>
-<p:sld xmlns:a="http://schemas.openxmlformats.org/drawingml/2006/main" xmlns:p="http://schemas.openxmlformats.org/presentationml/2006/main" xmlns:r="http://schemas.openxmlformats.org/officeDocument/2006/relationships">
+<p:sld xmlns:a="http://schemas.openxmlformats.org/drawingml/2006/main" xmlns:r="http://schemas.openxmlformats.org/officeDocument/2006/relationships" xmlns:p="http://schemas.openxmlformats.org/presentationml/2006/main">
   <p:cSld>
     <p:spTree>
       <p:nvGrpSpPr>
@@ -20022,7 +20685,14 @@
         <p:cNvGrpSpPr/>
         <p:nvPr/>
       </p:nvGrpSpPr>
-      <p:grpSpPr/>
+      <p:grpSpPr>
+        <a:xfrm>
+          <a:off x="0" y="0"/>
+          <a:ext cx="0" cy="0"/>
+          <a:chOff x="0" y="0"/>
+          <a:chExt cx="0" cy="0"/>
+        </a:xfrm>
+      </p:grpSpPr>
       <p:sp>
         <p:nvSpPr>
           <p:cNvPr id="2" name="Title 1"/>
@@ -20068,7 +20738,6 @@
           </a:bodyPr>
           <a:lstStyle/>
           <a:p>
-            <a:pPr/>
             <a:r>
               <a:rPr b="1"/>
               <a:t>Rerank</a:t>
@@ -20078,7 +20747,6 @@
             </a:r>
           </a:p>
           <a:p>
-            <a:pPr/>
             <a:r>
               <a:rPr b="1"/>
               <a:t>Contextual retrieval</a:t>
@@ -20094,7 +20762,6 @@
             </a:r>
           </a:p>
           <a:p>
-            <a:pPr/>
             <a:r>
               <a:t>Anthropic, 2024: context plus keyword search cut failed retrievals by 49%; adding a reranker, by 67%</a:t>
             </a:r>
@@ -20358,7 +21025,7 @@
 </file>
 
 <file path=ppt/slides/slide44.xml><?xml version="1.0" encoding="utf-8"?>
-<p:sld xmlns:a="http://schemas.openxmlformats.org/drawingml/2006/main" xmlns:p="http://schemas.openxmlformats.org/presentationml/2006/main" xmlns:r="http://schemas.openxmlformats.org/officeDocument/2006/relationships">
+<p:sld xmlns:a="http://schemas.openxmlformats.org/drawingml/2006/main" xmlns:r="http://schemas.openxmlformats.org/officeDocument/2006/relationships" xmlns:p="http://schemas.openxmlformats.org/presentationml/2006/main">
   <p:cSld>
     <p:spTree>
       <p:nvGrpSpPr>
@@ -20366,7 +21033,14 @@
         <p:cNvGrpSpPr/>
         <p:nvPr/>
       </p:nvGrpSpPr>
-      <p:grpSpPr/>
+      <p:grpSpPr>
+        <a:xfrm>
+          <a:off x="0" y="0"/>
+          <a:ext cx="0" cy="0"/>
+          <a:chOff x="0" y="0"/>
+          <a:chExt cx="0" cy="0"/>
+        </a:xfrm>
+      </p:grpSpPr>
       <p:sp>
         <p:nvSpPr>
           <p:cNvPr id="2" name="Title 1"/>
@@ -20418,7 +21092,7 @@
             <a:spLocks noGrp="1"/>
           </p:cNvSpPr>
           <p:nvPr>
-            <p:ph idx="2" sz="half"/>
+            <p:ph sz="half" idx="2"/>
           </p:nvPr>
         </p:nvSpPr>
         <p:spPr>
@@ -20429,23 +21103,20 @@
         </p:spPr>
         <p:txBody>
           <a:bodyPr>
-            <a:normAutofit fontScale="85000"/>
+            <a:normAutofit fontScale="92500"/>
           </a:bodyPr>
           <a:lstStyle/>
           <a:p>
-            <a:pPr/>
             <a:r>
               <a:t>A model extracts entities and relationships into a graph, and summarises clusters ahead of time</a:t>
             </a:r>
           </a:p>
           <a:p>
-            <a:pPr/>
             <a:r>
               <a:t>Answers global questions like "What are the main themes?" that top-k can't (Microsoft, 2024)</a:t>
             </a:r>
           </a:p>
           <a:p>
-            <a:pPr/>
             <a:r>
               <a:t>Expensive to build; worth it for large, connected corpora</a:t>
             </a:r>
@@ -20459,7 +21130,7 @@
             <a:spLocks noGrp="1"/>
           </p:cNvSpPr>
           <p:nvPr>
-            <p:ph type="body" idx="3" sz="quarter"/>
+            <p:ph type="body" sz="quarter" idx="3"/>
           </p:nvPr>
         </p:nvSpPr>
         <p:spPr/>
@@ -20480,7 +21151,7 @@
             <a:spLocks noGrp="1"/>
           </p:cNvSpPr>
           <p:nvPr>
-            <p:ph idx="4" sz="quarter"/>
+            <p:ph sz="quarter" idx="4"/>
           </p:nvPr>
         </p:nvSpPr>
         <p:spPr>
@@ -20491,23 +21162,20 @@
         </p:spPr>
         <p:txBody>
           <a:bodyPr>
-            <a:normAutofit fontScale="85000"/>
+            <a:normAutofit fontScale="92500"/>
           </a:bodyPr>
           <a:lstStyle/>
           <a:p>
-            <a:pPr/>
             <a:r>
               <a:t>Retrieves images, tables, slides, audio and video, not only text</a:t>
             </a:r>
           </a:p>
           <a:p>
-            <a:pPr/>
             <a:r>
               <a:t>2026: one embedding model can put text, images, video, audio and PDFs in one space (Gemini Embedding 2)</a:t>
             </a:r>
           </a:p>
           <a:p>
-            <a:pPr/>
             <a:r>
               <a:t>For when the answer is in a chart, not a sentence</a:t>
             </a:r>
@@ -20851,7 +21519,7 @@
 </file>
 
 <file path=ppt/slides/slide45.xml><?xml version="1.0" encoding="utf-8"?>
-<p:sld xmlns:a="http://schemas.openxmlformats.org/drawingml/2006/main" xmlns:p="http://schemas.openxmlformats.org/presentationml/2006/main" xmlns:r="http://schemas.openxmlformats.org/officeDocument/2006/relationships">
+<p:sld xmlns:a="http://schemas.openxmlformats.org/drawingml/2006/main" xmlns:r="http://schemas.openxmlformats.org/officeDocument/2006/relationships" xmlns:p="http://schemas.openxmlformats.org/presentationml/2006/main">
   <p:cSld>
     <p:spTree>
       <p:nvGrpSpPr>
@@ -20859,7 +21527,14 @@
         <p:cNvGrpSpPr/>
         <p:nvPr/>
       </p:nvGrpSpPr>
-      <p:grpSpPr/>
+      <p:grpSpPr>
+        <a:xfrm>
+          <a:off x="0" y="0"/>
+          <a:ext cx="0" cy="0"/>
+          <a:chOff x="0" y="0"/>
+          <a:chExt cx="0" cy="0"/>
+        </a:xfrm>
+      </p:grpSpPr>
       <p:sp>
         <p:nvSpPr>
           <p:cNvPr id="2" name="Title 1"/>
@@ -20936,7 +21611,7 @@
             </a:fontRef>
           </p:style>
           <p:txBody>
-            <a:bodyPr rtlCol="0" anchor="ctr" wrap="square" lIns="109728" rIns="109728" tIns="54864" bIns="54864">
+            <a:bodyPr wrap="square" lIns="109728" tIns="54864" rIns="109728" bIns="54864" rtlCol="0" anchor="ctr">
               <a:noAutofit/>
             </a:bodyPr>
             <a:lstStyle/>
@@ -20992,7 +21667,7 @@
             </a:fontRef>
           </p:style>
           <p:txBody>
-            <a:bodyPr rtlCol="0" anchor="ctr" wrap="square" lIns="109728" rIns="109728" tIns="54864" bIns="54864">
+            <a:bodyPr wrap="square" lIns="109728" tIns="54864" rIns="109728" bIns="54864" rtlCol="0" anchor="ctr">
               <a:noAutofit/>
             </a:bodyPr>
             <a:lstStyle/>
@@ -21048,7 +21723,7 @@
             </a:fontRef>
           </p:style>
           <p:txBody>
-            <a:bodyPr rtlCol="0" anchor="ctr" wrap="square" lIns="109728" rIns="109728" tIns="54864" bIns="54864">
+            <a:bodyPr wrap="square" lIns="109728" tIns="54864" rIns="109728" bIns="54864" rtlCol="0" anchor="ctr">
               <a:noAutofit/>
             </a:bodyPr>
             <a:lstStyle/>
@@ -21104,7 +21779,7 @@
             </a:fontRef>
           </p:style>
           <p:txBody>
-            <a:bodyPr rtlCol="0" anchor="ctr" wrap="square" lIns="109728" rIns="109728" tIns="54864" bIns="54864">
+            <a:bodyPr wrap="square" lIns="109728" tIns="54864" rIns="109728" bIns="54864" rtlCol="0" anchor="ctr">
               <a:noAutofit/>
             </a:bodyPr>
             <a:lstStyle/>
@@ -21160,7 +21835,7 @@
             </a:fontRef>
           </p:style>
           <p:txBody>
-            <a:bodyPr rtlCol="0" anchor="ctr" wrap="square" lIns="109728" rIns="109728" tIns="54864" bIns="54864">
+            <a:bodyPr wrap="square" lIns="109728" tIns="54864" rIns="109728" bIns="54864" rtlCol="0" anchor="ctr">
               <a:noAutofit/>
             </a:bodyPr>
             <a:lstStyle/>
@@ -21352,29 +22027,25 @@
         </p:spPr>
         <p:txBody>
           <a:bodyPr>
-            <a:normAutofit fontScale="92500"/>
+            <a:normAutofit lnSpcReduction="10000"/>
           </a:bodyPr>
           <a:lstStyle/>
           <a:p>
-            <a:pPr/>
             <a:r>
               <a:t>Router: picks the right source for each question: documents, web or database</a:t>
             </a:r>
           </a:p>
           <a:p>
-            <a:pPr/>
             <a:r>
               <a:t>Multi-agent: specialists search different sources and pool what they find</a:t>
             </a:r>
           </a:p>
           <a:p>
-            <a:pPr/>
             <a:r>
               <a:t>Deep-research tools are this at scale: dozens of searches for one question</a:t>
             </a:r>
           </a:p>
           <a:p>
-            <a:pPr/>
             <a:r>
               <a:t>More calls and cost per question; much better on hard, multi-step questions</a:t>
             </a:r>
@@ -21619,7 +22290,7 @@
 </file>
 
 <file path=ppt/slides/slide46.xml><?xml version="1.0" encoding="utf-8"?>
-<p:sld xmlns:a="http://schemas.openxmlformats.org/drawingml/2006/main" xmlns:p="http://schemas.openxmlformats.org/presentationml/2006/main" xmlns:r="http://schemas.openxmlformats.org/officeDocument/2006/relationships">
+<p:sld xmlns:a="http://schemas.openxmlformats.org/drawingml/2006/main" xmlns:r="http://schemas.openxmlformats.org/officeDocument/2006/relationships" xmlns:p="http://schemas.openxmlformats.org/presentationml/2006/main">
   <p:cSld>
     <p:spTree>
       <p:nvGrpSpPr>
@@ -21627,7 +22298,14 @@
         <p:cNvGrpSpPr/>
         <p:nvPr/>
       </p:nvGrpSpPr>
-      <p:grpSpPr/>
+      <p:grpSpPr>
+        <a:xfrm>
+          <a:off x="0" y="0"/>
+          <a:ext cx="0" cy="0"/>
+          <a:chOff x="0" y="0"/>
+          <a:chExt cx="0" cy="0"/>
+        </a:xfrm>
+      </p:grpSpPr>
       <p:sp>
         <p:nvSpPr>
           <p:cNvPr id="2" name="Title 1"/>
@@ -21679,7 +22357,7 @@
             <a:spLocks noGrp="1"/>
           </p:cNvSpPr>
           <p:nvPr>
-            <p:ph idx="2" sz="half"/>
+            <p:ph sz="half" idx="2"/>
           </p:nvPr>
         </p:nvSpPr>
         <p:spPr>
@@ -21694,19 +22372,16 @@
           </a:bodyPr>
           <a:lstStyle/>
           <a:p>
-            <a:pPr/>
             <a:r>
               <a:t>No index: the model runs grep and glob, reads files, and repeats</a:t>
             </a:r>
           </a:p>
           <a:p>
-            <a:pPr/>
             <a:r>
               <a:t>Its creator, 2026: early versions used RAG and a local vector database, but "agentic search generally works better"</a:t>
             </a:r>
           </a:p>
           <a:p>
-            <a:pPr/>
             <a:r>
               <a:t>Simpler: no index to go stale, no copy of your code elsewhere</a:t>
             </a:r>
@@ -21720,7 +22395,7 @@
             <a:spLocks noGrp="1"/>
           </p:cNvSpPr>
           <p:nvPr>
-            <p:ph type="body" idx="3" sz="quarter"/>
+            <p:ph type="body" sz="quarter" idx="3"/>
           </p:nvPr>
         </p:nvSpPr>
         <p:spPr/>
@@ -21741,7 +22416,7 @@
             <a:spLocks noGrp="1"/>
           </p:cNvSpPr>
           <p:nvPr>
-            <p:ph idx="4" sz="quarter"/>
+            <p:ph sz="quarter" idx="4"/>
           </p:nvPr>
         </p:nvSpPr>
         <p:spPr>
@@ -21756,19 +22431,16 @@
           </a:bodyPr>
           <a:lstStyle/>
           <a:p>
-            <a:pPr/>
             <a:r>
               <a:t>Splits your repo into chunks by syntax and embeds them</a:t>
             </a:r>
           </a:p>
           <a:p>
-            <a:pPr/>
             <a:r>
               <a:t>Its measurement, 2025: adding semantic search answered codebase questions 12.5% more accurately on average (6.5–23.5% by model)</a:t>
             </a:r>
           </a:p>
           <a:p>
-            <a:pPr/>
             <a:r>
               <a:t>Its conclusion: grep and embeddings together beat either alone</a:t>
             </a:r>
@@ -21960,7 +22632,6 @@
             </a:lvl9pPr>
           </a:lstStyle>
           <a:p>
-            <a:pPr/>
             <a:r>
               <a:t>Who's right? Each company measured its own product. Same problem, two answers: finding the right context is the whole game</a:t>
             </a:r>
@@ -22354,7 +23025,7 @@
 </file>
 
 <file path=ppt/slides/slide47.xml><?xml version="1.0" encoding="utf-8"?>
-<p:sld xmlns:a="http://schemas.openxmlformats.org/drawingml/2006/main" xmlns:p="http://schemas.openxmlformats.org/presentationml/2006/main" xmlns:r="http://schemas.openxmlformats.org/officeDocument/2006/relationships">
+<p:sld xmlns:a="http://schemas.openxmlformats.org/drawingml/2006/main" xmlns:r="http://schemas.openxmlformats.org/officeDocument/2006/relationships" xmlns:p="http://schemas.openxmlformats.org/presentationml/2006/main">
   <p:cSld>
     <p:spTree>
       <p:nvGrpSpPr>
@@ -22362,7 +23033,14 @@
         <p:cNvGrpSpPr/>
         <p:nvPr/>
       </p:nvGrpSpPr>
-      <p:grpSpPr/>
+      <p:grpSpPr>
+        <a:xfrm>
+          <a:off x="0" y="0"/>
+          <a:ext cx="0" cy="0"/>
+          <a:chOff x="0" y="0"/>
+          <a:chExt cx="0" cy="0"/>
+        </a:xfrm>
+      </p:grpSpPr>
       <p:sp>
         <p:nvSpPr>
           <p:cNvPr id="2" name="Title 1"/>
@@ -22404,7 +23082,7 @@
         </p:spPr>
         <p:txBody>
           <a:bodyPr>
-            <a:normAutofit/>
+            <a:normAutofit lnSpcReduction="10000"/>
           </a:bodyPr>
           <a:lstStyle/>
           <a:p>
@@ -22474,7 +23152,7 @@
             </a:fontRef>
           </p:style>
           <p:txBody>
-            <a:bodyPr rtlCol="0" anchor="ctr" wrap="square" lIns="109728" rIns="109728" tIns="54864" bIns="54864">
+            <a:bodyPr wrap="square" lIns="109728" tIns="54864" rIns="109728" bIns="54864" rtlCol="0" anchor="ctr">
               <a:noAutofit/>
             </a:bodyPr>
             <a:lstStyle/>
@@ -22541,7 +23219,7 @@
             </a:fontRef>
           </p:style>
           <p:txBody>
-            <a:bodyPr rtlCol="0" anchor="ctr" wrap="square" lIns="109728" rIns="109728" tIns="54864" bIns="54864">
+            <a:bodyPr wrap="square" lIns="109728" tIns="54864" rIns="109728" bIns="54864" rtlCol="0" anchor="ctr">
               <a:noAutofit/>
             </a:bodyPr>
             <a:lstStyle/>
@@ -22608,7 +23286,7 @@
             </a:fontRef>
           </p:style>
           <p:txBody>
-            <a:bodyPr rtlCol="0" anchor="ctr" wrap="square" lIns="109728" rIns="109728" tIns="54864" bIns="54864">
+            <a:bodyPr wrap="square" lIns="109728" tIns="54864" rIns="109728" bIns="54864" rtlCol="0" anchor="ctr">
               <a:noAutofit/>
             </a:bodyPr>
             <a:lstStyle/>
@@ -22900,7 +23578,6 @@
             </a:lvl9pPr>
           </a:lstStyle>
           <a:p>
-            <a:pPr/>
             <a:r>
               <a:t>No index, no embeddings: retrieval is a loop the agent runs at question time</a:t>
             </a:r>
@@ -22998,7 +23675,7 @@
 </file>
 
 <file path=ppt/slides/slide48.xml><?xml version="1.0" encoding="utf-8"?>
-<p:sld xmlns:a="http://schemas.openxmlformats.org/drawingml/2006/main" xmlns:p="http://schemas.openxmlformats.org/presentationml/2006/main" xmlns:r="http://schemas.openxmlformats.org/officeDocument/2006/relationships">
+<p:sld xmlns:a="http://schemas.openxmlformats.org/drawingml/2006/main" xmlns:r="http://schemas.openxmlformats.org/officeDocument/2006/relationships" xmlns:p="http://schemas.openxmlformats.org/presentationml/2006/main">
   <p:cSld>
     <p:spTree>
       <p:nvGrpSpPr>
@@ -23006,7 +23683,14 @@
         <p:cNvGrpSpPr/>
         <p:nvPr/>
       </p:nvGrpSpPr>
-      <p:grpSpPr/>
+      <p:grpSpPr>
+        <a:xfrm>
+          <a:off x="0" y="0"/>
+          <a:ext cx="0" cy="0"/>
+          <a:chOff x="0" y="0"/>
+          <a:chExt cx="0" cy="0"/>
+        </a:xfrm>
+      </p:grpSpPr>
       <p:sp>
         <p:nvSpPr>
           <p:cNvPr id="2" name="Title 1"/>
@@ -23069,7 +23753,7 @@
           </a:fontRef>
         </p:style>
         <p:txBody>
-          <a:bodyPr rtlCol="0" anchor="t" wrap="none" lIns="137160" rIns="137160" tIns="91440" bIns="91440">
+          <a:bodyPr wrap="none" lIns="137160" tIns="91440" rIns="137160" bIns="91440" rtlCol="0" anchor="t">
             <a:noAutofit/>
           </a:bodyPr>
           <a:lstStyle/>
@@ -23190,19 +23874,16 @@
           </a:bodyPr>
           <a:lstStyle/>
           <a:p>
-            <a:pPr/>
             <a:r>
               <a:t>grep for "retry" finds nothing, so a naive agent reports there is no retry limit: confidently wrong</a:t>
             </a:r>
           </a:p>
           <a:p>
-            <a:pPr/>
             <a:r>
               <a:t>A good agent treats the empty result as a clue, and tries "attempt" and "backoff"</a:t>
             </a:r>
           </a:p>
           <a:p>
-            <a:pPr/>
             <a:r>
               <a:t>On an 8-file toy repo, an embedding search ranked net/http_client.py first (0.53; the runner-up 0.08): the gap an index fills</a:t>
             </a:r>
@@ -23398,7 +24079,7 @@
 </file>
 
 <file path=ppt/slides/slide49.xml><?xml version="1.0" encoding="utf-8"?>
-<p:sld xmlns:a="http://schemas.openxmlformats.org/drawingml/2006/main" xmlns:p="http://schemas.openxmlformats.org/presentationml/2006/main" xmlns:r="http://schemas.openxmlformats.org/officeDocument/2006/relationships">
+<p:sld xmlns:a="http://schemas.openxmlformats.org/drawingml/2006/main" xmlns:r="http://schemas.openxmlformats.org/officeDocument/2006/relationships" xmlns:p="http://schemas.openxmlformats.org/presentationml/2006/main">
   <p:cSld>
     <p:spTree>
       <p:nvGrpSpPr>
@@ -23406,7 +24087,14 @@
         <p:cNvGrpSpPr/>
         <p:nvPr/>
       </p:nvGrpSpPr>
-      <p:grpSpPr/>
+      <p:grpSpPr>
+        <a:xfrm>
+          <a:off x="0" y="0"/>
+          <a:ext cx="0" cy="0"/>
+          <a:chOff x="0" y="0"/>
+          <a:chExt cx="0" cy="0"/>
+        </a:xfrm>
+      </p:grpSpPr>
       <p:sp>
         <p:nvSpPr>
           <p:cNvPr id="2" name="Title 1"/>
@@ -23452,25 +24140,21 @@
           </a:bodyPr>
           <a:lstStyle/>
           <a:p>
-            <a:pPr/>
             <a:r>
               <a:t>Gemini API File Search (Nov 2025): upload files; Google chunks, embeds, retrieves and cites</a:t>
             </a:r>
           </a:p>
           <a:p>
-            <a:pPr/>
             <a:r>
               <a:t>OpenAI file search, Claude Projects, NotebookLM: the same pipeline, out of sight</a:t>
             </a:r>
           </a:p>
           <a:p>
-            <a:pPr/>
             <a:r>
               <a:t>You still decide what goes in, how it is labelled, and how answers get checked</a:t>
             </a:r>
           </a:p>
           <a:p>
-            <a:pPr/>
             <a:r>
               <a:t>When it answers wrongly, knowing the six steps is how you find which one failed</a:t>
             </a:r>
@@ -23715,7 +24399,7 @@
 </file>
 
 <file path=ppt/slides/slide5.xml><?xml version="1.0" encoding="utf-8"?>
-<p:sld xmlns:a="http://schemas.openxmlformats.org/drawingml/2006/main" xmlns:p="http://schemas.openxmlformats.org/presentationml/2006/main" xmlns:r="http://schemas.openxmlformats.org/officeDocument/2006/relationships">
+<p:sld xmlns:a="http://schemas.openxmlformats.org/drawingml/2006/main" xmlns:r="http://schemas.openxmlformats.org/officeDocument/2006/relationships" xmlns:p="http://schemas.openxmlformats.org/presentationml/2006/main">
   <p:cSld>
     <p:spTree>
       <p:nvGrpSpPr>
@@ -23723,7 +24407,14 @@
         <p:cNvGrpSpPr/>
         <p:nvPr/>
       </p:nvGrpSpPr>
-      <p:grpSpPr/>
+      <p:grpSpPr>
+        <a:xfrm>
+          <a:off x="0" y="0"/>
+          <a:ext cx="0" cy="0"/>
+          <a:chOff x="0" y="0"/>
+          <a:chExt cx="0" cy="0"/>
+        </a:xfrm>
+      </p:grpSpPr>
       <p:sp>
         <p:nvSpPr>
           <p:cNvPr id="2" name="Title 1"/>
@@ -23777,7 +24468,7 @@
 </file>
 
 <file path=ppt/slides/slide50.xml><?xml version="1.0" encoding="utf-8"?>
-<p:sld xmlns:a="http://schemas.openxmlformats.org/drawingml/2006/main" xmlns:p="http://schemas.openxmlformats.org/presentationml/2006/main" xmlns:r="http://schemas.openxmlformats.org/officeDocument/2006/relationships">
+<p:sld xmlns:a="http://schemas.openxmlformats.org/drawingml/2006/main" xmlns:r="http://schemas.openxmlformats.org/officeDocument/2006/relationships" xmlns:p="http://schemas.openxmlformats.org/presentationml/2006/main">
   <p:cSld>
     <p:spTree>
       <p:nvGrpSpPr>
@@ -23785,7 +24476,14 @@
         <p:cNvGrpSpPr/>
         <p:nvPr/>
       </p:nvGrpSpPr>
-      <p:grpSpPr/>
+      <p:grpSpPr>
+        <a:xfrm>
+          <a:off x="0" y="0"/>
+          <a:ext cx="0" cy="0"/>
+          <a:chOff x="0" y="0"/>
+          <a:chExt cx="0" cy="0"/>
+        </a:xfrm>
+      </p:grpSpPr>
       <p:sp>
         <p:nvSpPr>
           <p:cNvPr id="2" name="Title 1"/>
@@ -23879,7 +24577,7 @@
           </a:fontRef>
         </p:style>
         <p:txBody>
-          <a:bodyPr rtlCol="0" anchor="t" wrap="none" lIns="137160" rIns="137160" tIns="91440" bIns="91440">
+          <a:bodyPr wrap="none" lIns="137160" tIns="91440" rIns="137160" bIns="91440" rtlCol="0" anchor="t">
             <a:noAutofit/>
           </a:bodyPr>
           <a:lstStyle/>
@@ -24241,13 +24939,11 @@
             </a:lvl9pPr>
           </a:lstStyle>
           <a:p>
-            <a:pPr/>
             <a:r>
               <a:t>Look closely at Q2: the context mentions a handling fee but never says how much</a:t>
             </a:r>
           </a:p>
           <a:p>
-            <a:pPr/>
             <a:r>
               <a:t>Then delete the sentence starting "If the context does not contain..." and ask again</a:t>
             </a:r>
@@ -24394,7 +25090,7 @@
 </file>
 
 <file path=ppt/slides/slide51.xml><?xml version="1.0" encoding="utf-8"?>
-<p:sld xmlns:a="http://schemas.openxmlformats.org/drawingml/2006/main" xmlns:p="http://schemas.openxmlformats.org/presentationml/2006/main" xmlns:r="http://schemas.openxmlformats.org/officeDocument/2006/relationships">
+<p:sld xmlns:a="http://schemas.openxmlformats.org/drawingml/2006/main" xmlns:r="http://schemas.openxmlformats.org/officeDocument/2006/relationships" xmlns:p="http://schemas.openxmlformats.org/presentationml/2006/main">
   <p:cSld>
     <p:spTree>
       <p:nvGrpSpPr>
@@ -24402,7 +25098,14 @@
         <p:cNvGrpSpPr/>
         <p:nvPr/>
       </p:nvGrpSpPr>
-      <p:grpSpPr/>
+      <p:grpSpPr>
+        <a:xfrm>
+          <a:off x="0" y="0"/>
+          <a:ext cx="0" cy="0"/>
+          <a:chOff x="0" y="0"/>
+          <a:chExt cx="0" cy="0"/>
+        </a:xfrm>
+      </p:grpSpPr>
       <p:sp>
         <p:nvSpPr>
           <p:cNvPr id="2" name="Title 1"/>
@@ -24444,35 +25147,30 @@
         </p:spPr>
         <p:txBody>
           <a:bodyPr>
-            <a:normAutofit fontScale="85000"/>
+            <a:normAutofit fontScale="92500"/>
           </a:bodyPr>
           <a:lstStyle/>
           <a:p>
-            <a:pPr/>
             <a:r>
               <a:t>Retrieval would have found the right chunk: the fee sentence is the closest text there is</a:t>
             </a:r>
           </a:p>
           <a:p>
-            <a:pPr/>
             <a:r>
               <a:t>That chunk still doesn't hold the answer: found and answerable are different things</a:t>
             </a:r>
           </a:p>
           <a:p>
-            <a:pPr/>
             <a:r>
               <a:t>We ran it 5 times on each of 3 models (October 2026): not one of 30 replies invented a fee</a:t>
             </a:r>
           </a:p>
           <a:p>
-            <a:pPr/>
             <a:r>
               <a:t>With the permission line, 15 of 15 said exactly "I don't know"; without it, 13 different wordings: fine for a reader, hard for code to check</a:t>
             </a:r>
           </a:p>
           <a:p>
-            <a:pPr/>
             <a:r>
               <a:t>If your model did invent a fee, you saw the failure live. Either way, test near misses, not just off-topic questions</a:t>
             </a:r>
@@ -24766,7 +25464,7 @@
 </file>
 
 <file path=ppt/slides/slide52.xml><?xml version="1.0" encoding="utf-8"?>
-<p:sld xmlns:a="http://schemas.openxmlformats.org/drawingml/2006/main" xmlns:p="http://schemas.openxmlformats.org/presentationml/2006/main" xmlns:r="http://schemas.openxmlformats.org/officeDocument/2006/relationships">
+<p:sld xmlns:a="http://schemas.openxmlformats.org/drawingml/2006/main" xmlns:r="http://schemas.openxmlformats.org/officeDocument/2006/relationships" xmlns:p="http://schemas.openxmlformats.org/presentationml/2006/main">
   <p:cSld>
     <p:spTree>
       <p:nvGrpSpPr>
@@ -24774,7 +25472,14 @@
         <p:cNvGrpSpPr/>
         <p:nvPr/>
       </p:nvGrpSpPr>
-      <p:grpSpPr/>
+      <p:grpSpPr>
+        <a:xfrm>
+          <a:off x="0" y="0"/>
+          <a:ext cx="0" cy="0"/>
+          <a:chOff x="0" y="0"/>
+          <a:chExt cx="0" cy="0"/>
+        </a:xfrm>
+      </p:grpSpPr>
       <p:sp>
         <p:nvSpPr>
           <p:cNvPr id="2" name="Title 1"/>
@@ -24826,7 +25531,7 @@
             <a:spLocks noGrp="1"/>
           </p:cNvSpPr>
           <p:nvPr>
-            <p:ph idx="2" sz="half"/>
+            <p:ph sz="half" idx="2"/>
           </p:nvPr>
         </p:nvSpPr>
         <p:spPr>
@@ -24837,35 +25542,30 @@
         </p:spPr>
         <p:txBody>
           <a:bodyPr>
-            <a:normAutofit fontScale="77500"/>
+            <a:normAutofit fontScale="85000" lnSpcReduction="10000"/>
           </a:bodyPr>
           <a:lstStyle/>
           <a:p>
-            <a:pPr/>
             <a:r>
               <a:t>A pipeline for a corpus that would fit in the prompt</a:t>
             </a:r>
           </a:p>
           <a:p>
-            <a:pPr/>
             <a:r>
               <a:t>A chunk size chosen once and never measured</a:t>
             </a:r>
           </a:p>
           <a:p>
-            <a:pPr/>
             <a:r>
               <a:t>Questions embedded with a different model from the chunks</a:t>
             </a:r>
           </a:p>
           <a:p>
-            <a:pPr/>
             <a:r>
               <a:t>A threshold written without checking distance versus similarity</a:t>
             </a:r>
           </a:p>
           <a:p>
-            <a:pPr/>
             <a:r>
               <a:t>Chunks with no labels, so no citations</a:t>
             </a:r>
@@ -24879,7 +25579,7 @@
             <a:spLocks noGrp="1"/>
           </p:cNvSpPr>
           <p:nvPr>
-            <p:ph type="body" idx="3" sz="quarter"/>
+            <p:ph type="body" sz="quarter" idx="3"/>
           </p:nvPr>
         </p:nvSpPr>
         <p:spPr/>
@@ -24900,7 +25600,7 @@
             <a:spLocks noGrp="1"/>
           </p:cNvSpPr>
           <p:nvPr>
-            <p:ph idx="4" sz="quarter"/>
+            <p:ph sz="quarter" idx="4"/>
           </p:nvPr>
         </p:nvSpPr>
         <p:spPr>
@@ -24911,35 +25611,30 @@
         </p:spPr>
         <p:txBody>
           <a:bodyPr>
-            <a:normAutofit fontScale="77500"/>
+            <a:normAutofit fontScale="85000" lnSpcReduction="10000"/>
           </a:bodyPr>
           <a:lstStyle/>
           <a:p>
-            <a:pPr/>
             <a:r>
               <a:t>Blaming the model before looking at what was retrieved</a:t>
             </a:r>
           </a:p>
           <a:p>
-            <a:pPr/>
             <a:r>
               <a:t>A stale index: right answers to last month's question</a:t>
             </a:r>
           </a:p>
           <a:p>
-            <a:pPr/>
             <a:r>
               <a:t>A global question asked of a top-k system</a:t>
             </a:r>
           </a:p>
           <a:p>
-            <a:pPr/>
             <a:r>
               <a:t>Testing the off-topic question but never the near miss</a:t>
             </a:r>
           </a:p>
           <a:p>
-            <a:pPr/>
             <a:r>
               <a:t>No set of questions with known answers to test against</a:t>
             </a:r>
@@ -25479,7 +26174,7 @@
 </file>
 
 <file path=ppt/slides/slide53.xml><?xml version="1.0" encoding="utf-8"?>
-<p:sld xmlns:a="http://schemas.openxmlformats.org/drawingml/2006/main" xmlns:p="http://schemas.openxmlformats.org/presentationml/2006/main" xmlns:r="http://schemas.openxmlformats.org/officeDocument/2006/relationships">
+<p:sld xmlns:a="http://schemas.openxmlformats.org/drawingml/2006/main" xmlns:r="http://schemas.openxmlformats.org/officeDocument/2006/relationships" xmlns:p="http://schemas.openxmlformats.org/presentationml/2006/main">
   <p:cSld>
     <p:spTree>
       <p:nvGrpSpPr>
@@ -25487,7 +26182,14 @@
         <p:cNvGrpSpPr/>
         <p:nvPr/>
       </p:nvGrpSpPr>
-      <p:grpSpPr/>
+      <p:grpSpPr>
+        <a:xfrm>
+          <a:off x="0" y="0"/>
+          <a:ext cx="0" cy="0"/>
+          <a:chOff x="0" y="0"/>
+          <a:chExt cx="0" cy="0"/>
+        </a:xfrm>
+      </p:grpSpPr>
       <p:sp>
         <p:nvSpPr>
           <p:cNvPr id="2" name="Title 1"/>
@@ -25529,35 +26231,30 @@
         </p:spPr>
         <p:txBody>
           <a:bodyPr>
-            <a:normAutofit fontScale="92500"/>
+            <a:normAutofit lnSpcReduction="10000"/>
           </a:bodyPr>
           <a:lstStyle/>
           <a:p>
-            <a:pPr/>
             <a:r>
               <a:t>RAG: retrieve the relevant passages, put them in the prompt, generate from them</a:t>
             </a:r>
           </a:p>
           <a:p>
-            <a:pPr/>
             <a:r>
               <a:t>Index once (load, chunk, embed, store); for each question, embed it, search, generate</a:t>
             </a:r>
           </a:p>
           <a:p>
-            <a:pPr/>
             <a:r>
               <a:t>Embeddings match meaning, not words; use one model throughout; there is always a nearest neighbour</a:t>
             </a:r>
           </a:p>
           <a:p>
-            <a:pPr/>
             <a:r>
               <a:t>Grounding and citations reduce made-up answers; they don't remove them</a:t>
             </a:r>
           </a:p>
           <a:p>
-            <a:pPr/>
             <a:r>
               <a:t>2026: if it fits, paste it; if not, retrieve then read, with hybrid search, reranking or an agent doing the searching</a:t>
             </a:r>
@@ -25851,7 +26548,7 @@
 </file>
 
 <file path=ppt/slides/slide6.xml><?xml version="1.0" encoding="utf-8"?>
-<p:sld xmlns:a="http://schemas.openxmlformats.org/drawingml/2006/main" xmlns:p="http://schemas.openxmlformats.org/presentationml/2006/main" xmlns:r="http://schemas.openxmlformats.org/officeDocument/2006/relationships">
+<p:sld xmlns:a="http://schemas.openxmlformats.org/drawingml/2006/main" xmlns:r="http://schemas.openxmlformats.org/officeDocument/2006/relationships" xmlns:p="http://schemas.openxmlformats.org/presentationml/2006/main">
   <p:cSld>
     <p:spTree>
       <p:nvGrpSpPr>
@@ -25859,7 +26556,14 @@
         <p:cNvGrpSpPr/>
         <p:nvPr/>
       </p:nvGrpSpPr>
-      <p:grpSpPr/>
+      <p:grpSpPr>
+        <a:xfrm>
+          <a:off x="0" y="0"/>
+          <a:ext cx="0" cy="0"/>
+          <a:chOff x="0" y="0"/>
+          <a:chExt cx="0" cy="0"/>
+        </a:xfrm>
+      </p:grpSpPr>
       <p:sp>
         <p:nvSpPr>
           <p:cNvPr id="2" name="Title 1"/>
@@ -25905,31 +26609,26 @@
           </a:bodyPr>
           <a:lstStyle/>
           <a:p>
-            <a:pPr/>
             <a:r>
               <a:t>Its knowledge stops at its training cutoff</a:t>
             </a:r>
           </a:p>
           <a:p>
-            <a:pPr/>
             <a:r>
               <a:t>It has never seen your documents: your code, your wiki, your contracts</a:t>
             </a:r>
           </a:p>
           <a:p>
-            <a:pPr/>
             <a:r>
               <a:t>Asked anyway, it writes the most plausible answer, which may be invented</a:t>
             </a:r>
           </a:p>
           <a:p>
-            <a:pPr/>
             <a:r>
               <a:t>Retraining to add facts is slow and costly, and out of date by the next change</a:t>
             </a:r>
           </a:p>
           <a:p>
-            <a:pPr/>
             <a:r>
               <a:rPr b="1"/>
               <a:t>So don't teach the model your documents: find the relevant piece and put it in the prompt</a:t>
@@ -26224,7 +26923,7 @@
 </file>
 
 <file path=ppt/slides/slide7.xml><?xml version="1.0" encoding="utf-8"?>
-<p:sld xmlns:a="http://schemas.openxmlformats.org/drawingml/2006/main" xmlns:p="http://schemas.openxmlformats.org/presentationml/2006/main" xmlns:r="http://schemas.openxmlformats.org/officeDocument/2006/relationships">
+<p:sld xmlns:a="http://schemas.openxmlformats.org/drawingml/2006/main" xmlns:r="http://schemas.openxmlformats.org/officeDocument/2006/relationships" xmlns:p="http://schemas.openxmlformats.org/presentationml/2006/main">
   <p:cSld>
     <p:spTree>
       <p:nvGrpSpPr>
@@ -26232,7 +26931,14 @@
         <p:cNvGrpSpPr/>
         <p:nvPr/>
       </p:nvGrpSpPr>
-      <p:grpSpPr/>
+      <p:grpSpPr>
+        <a:xfrm>
+          <a:off x="0" y="0"/>
+          <a:ext cx="0" cy="0"/>
+          <a:chOff x="0" y="0"/>
+          <a:chExt cx="0" cy="0"/>
+        </a:xfrm>
+      </p:grpSpPr>
       <p:sp>
         <p:nvSpPr>
           <p:cNvPr id="2" name="Title 1"/>
@@ -26284,7 +26990,7 @@
             <a:spLocks noGrp="1"/>
           </p:cNvSpPr>
           <p:nvPr>
-            <p:ph idx="2" sz="half"/>
+            <p:ph sz="half" idx="2"/>
           </p:nvPr>
         </p:nvSpPr>
         <p:spPr>
@@ -26295,29 +27001,25 @@
         </p:spPr>
         <p:txBody>
           <a:bodyPr>
-            <a:normAutofit fontScale="77500"/>
+            <a:normAutofit fontScale="85000" lnSpcReduction="10000"/>
           </a:bodyPr>
           <a:lstStyle/>
           <a:p>
-            <a:pPr/>
             <a:r>
               <a:t>Retrieves from search engines and public websites, live</a:t>
             </a:r>
           </a:p>
           <a:p>
-            <a:pPr/>
             <a:r>
               <a:t>Broad and current; you don't control the sources</a:t>
             </a:r>
           </a:p>
           <a:p>
-            <a:pPr/>
             <a:r>
               <a:t>The search engine does the retrieving</a:t>
             </a:r>
           </a:p>
           <a:p>
-            <a:pPr/>
             <a:r>
               <a:t>Perplexity, ChatGPT search, Google's AI Overviews</a:t>
             </a:r>
@@ -26331,7 +27033,7 @@
             <a:spLocks noGrp="1"/>
           </p:cNvSpPr>
           <p:nvPr>
-            <p:ph type="body" idx="3" sz="quarter"/>
+            <p:ph type="body" sz="quarter" idx="3"/>
           </p:nvPr>
         </p:nvSpPr>
         <p:spPr/>
@@ -26352,7 +27054,7 @@
             <a:spLocks noGrp="1"/>
           </p:cNvSpPr>
           <p:nvPr>
-            <p:ph idx="4" sz="quarter"/>
+            <p:ph sz="quarter" idx="4"/>
           </p:nvPr>
         </p:nvSpPr>
         <p:spPr>
@@ -26363,29 +27065,25 @@
         </p:spPr>
         <p:txBody>
           <a:bodyPr>
-            <a:normAutofit fontScale="77500"/>
+            <a:normAutofit fontScale="85000" lnSpcReduction="10000"/>
           </a:bodyPr>
           <a:lstStyle/>
           <a:p>
-            <a:pPr/>
             <a:r>
               <a:t>Retrieves from your own documents: wikis, PDFs, tickets, code</a:t>
             </a:r>
           </a:p>
           <a:p>
-            <a:pPr/>
             <a:r>
               <a:t>Narrow and controlled: only what you put in</a:t>
             </a:r>
           </a:p>
           <a:p>
-            <a:pPr/>
             <a:r>
               <a:t>Usually a vector database you build and maintain</a:t>
             </a:r>
           </a:p>
           <a:p>
-            <a:pPr/>
             <a:r>
               <a:t>NotebookLM, company help bots, Claude and ChatGPT Projects</a:t>
             </a:r>
@@ -26410,7 +27108,7 @@
         </p:spPr>
         <p:txBody>
           <a:bodyPr wrap="square">
-            <a:normAutofit fontScale="77500"/>
+            <a:normAutofit fontScale="77500" lnSpcReduction="10000"/>
           </a:bodyPr>
           <a:lstStyle>
             <a:lvl1pPr marL="228600" indent="-228600" algn="l" defTabSz="914400" rtl="0" eaLnBrk="1" latinLnBrk="0" hangingPunct="1">
@@ -26577,7 +27275,6 @@
             </a:lvl9pPr>
           </a:lstStyle>
           <a:p>
-            <a:pPr/>
             <a:r>
               <a:t>Same recipe either way: fetch first, then answer from what was fetched</a:t>
             </a:r>
@@ -27069,7 +27766,7 @@
 </file>
 
 <file path=ppt/slides/slide8.xml><?xml version="1.0" encoding="utf-8"?>
-<p:sld xmlns:a="http://schemas.openxmlformats.org/drawingml/2006/main" xmlns:p="http://schemas.openxmlformats.org/presentationml/2006/main" xmlns:r="http://schemas.openxmlformats.org/officeDocument/2006/relationships">
+<p:sld xmlns:a="http://schemas.openxmlformats.org/drawingml/2006/main" xmlns:r="http://schemas.openxmlformats.org/officeDocument/2006/relationships" xmlns:p="http://schemas.openxmlformats.org/presentationml/2006/main">
   <p:cSld>
     <p:spTree>
       <p:nvGrpSpPr>
@@ -27077,7 +27774,14 @@
         <p:cNvGrpSpPr/>
         <p:nvPr/>
       </p:nvGrpSpPr>
-      <p:grpSpPr/>
+      <p:grpSpPr>
+        <a:xfrm>
+          <a:off x="0" y="0"/>
+          <a:ext cx="0" cy="0"/>
+          <a:chOff x="0" y="0"/>
+          <a:chExt cx="0" cy="0"/>
+        </a:xfrm>
+      </p:grpSpPr>
       <p:sp>
         <p:nvSpPr>
           <p:cNvPr id="2" name="Title 1"/>
@@ -27119,7 +27823,7 @@
         </p:spPr>
         <p:txBody>
           <a:bodyPr>
-            <a:normAutofit/>
+            <a:normAutofit lnSpcReduction="10000"/>
           </a:bodyPr>
           <a:lstStyle/>
           <a:p>
@@ -27185,7 +27889,7 @@
             </a:fontRef>
           </p:style>
           <p:txBody>
-            <a:bodyPr rtlCol="0" anchor="ctr" wrap="square" lIns="109728" rIns="109728" tIns="54864" bIns="54864">
+            <a:bodyPr wrap="square" lIns="109728" tIns="54864" rIns="109728" bIns="54864" rtlCol="0" anchor="ctr">
               <a:noAutofit/>
             </a:bodyPr>
             <a:lstStyle/>
@@ -27252,7 +27956,7 @@
             </a:fontRef>
           </p:style>
           <p:txBody>
-            <a:bodyPr rtlCol="0" anchor="ctr" wrap="square" lIns="109728" rIns="109728" tIns="54864" bIns="54864">
+            <a:bodyPr wrap="square" lIns="109728" tIns="54864" rIns="109728" bIns="54864" rtlCol="0" anchor="ctr">
               <a:noAutofit/>
             </a:bodyPr>
             <a:lstStyle/>
@@ -27319,7 +28023,7 @@
             </a:fontRef>
           </p:style>
           <p:txBody>
-            <a:bodyPr rtlCol="0" anchor="ctr" wrap="square" lIns="109728" rIns="109728" tIns="54864" bIns="54864">
+            <a:bodyPr wrap="square" lIns="109728" tIns="54864" rIns="109728" bIns="54864" rtlCol="0" anchor="ctr">
               <a:noAutofit/>
             </a:bodyPr>
             <a:lstStyle/>
@@ -27386,7 +28090,7 @@
             </a:fontRef>
           </p:style>
           <p:txBody>
-            <a:bodyPr rtlCol="0" anchor="ctr" wrap="square" lIns="109728" rIns="109728" tIns="54864" bIns="54864">
+            <a:bodyPr wrap="square" lIns="109728" tIns="54864" rIns="109728" bIns="54864" rtlCol="0" anchor="ctr">
               <a:noAutofit/>
             </a:bodyPr>
             <a:lstStyle/>
@@ -27717,7 +28421,6 @@
             </a:lvl9pPr>
           </a:lstStyle>
           <a:p>
-            <a:pPr/>
             <a:r>
               <a:t>The result is a searchable index: every chunk's vector, its text and where it came from</a:t>
             </a:r>
@@ -27815,7 +28518,7 @@
 </file>
 
 <file path=ppt/slides/slide9.xml><?xml version="1.0" encoding="utf-8"?>
-<p:sld xmlns:a="http://schemas.openxmlformats.org/drawingml/2006/main" xmlns:p="http://schemas.openxmlformats.org/presentationml/2006/main" xmlns:r="http://schemas.openxmlformats.org/officeDocument/2006/relationships">
+<p:sld xmlns:a="http://schemas.openxmlformats.org/drawingml/2006/main" xmlns:r="http://schemas.openxmlformats.org/officeDocument/2006/relationships" xmlns:p="http://schemas.openxmlformats.org/presentationml/2006/main">
   <p:cSld>
     <p:spTree>
       <p:nvGrpSpPr>
@@ -27823,7 +28526,14 @@
         <p:cNvGrpSpPr/>
         <p:nvPr/>
       </p:nvGrpSpPr>
-      <p:grpSpPr/>
+      <p:grpSpPr>
+        <a:xfrm>
+          <a:off x="0" y="0"/>
+          <a:ext cx="0" cy="0"/>
+          <a:chOff x="0" y="0"/>
+          <a:chExt cx="0" cy="0"/>
+        </a:xfrm>
+      </p:grpSpPr>
       <p:sp>
         <p:nvSpPr>
           <p:cNvPr id="2" name="Title 1"/>
@@ -27865,7 +28575,7 @@
         </p:spPr>
         <p:txBody>
           <a:bodyPr>
-            <a:normAutofit/>
+            <a:normAutofit lnSpcReduction="10000"/>
           </a:bodyPr>
           <a:lstStyle/>
           <a:p>
@@ -27931,7 +28641,7 @@
             </a:fontRef>
           </p:style>
           <p:txBody>
-            <a:bodyPr rtlCol="0" anchor="ctr" wrap="square" lIns="109728" rIns="109728" tIns="54864" bIns="54864">
+            <a:bodyPr wrap="square" lIns="109728" tIns="54864" rIns="109728" bIns="54864" rtlCol="0" anchor="ctr">
               <a:noAutofit/>
             </a:bodyPr>
             <a:lstStyle/>
@@ -27998,7 +28708,7 @@
             </a:fontRef>
           </p:style>
           <p:txBody>
-            <a:bodyPr rtlCol="0" anchor="ctr" wrap="square" lIns="109728" rIns="109728" tIns="54864" bIns="54864">
+            <a:bodyPr wrap="square" lIns="109728" tIns="54864" rIns="109728" bIns="54864" rtlCol="0" anchor="ctr">
               <a:noAutofit/>
             </a:bodyPr>
             <a:lstStyle/>
@@ -28065,7 +28775,7 @@
             </a:fontRef>
           </p:style>
           <p:txBody>
-            <a:bodyPr rtlCol="0" anchor="ctr" wrap="square" lIns="109728" rIns="109728" tIns="54864" bIns="54864">
+            <a:bodyPr wrap="square" lIns="109728" tIns="54864" rIns="109728" bIns="54864" rtlCol="0" anchor="ctr">
               <a:noAutofit/>
             </a:bodyPr>
             <a:lstStyle/>
@@ -28132,7 +28842,7 @@
             </a:fontRef>
           </p:style>
           <p:txBody>
-            <a:bodyPr rtlCol="0" anchor="ctr" wrap="square" lIns="109728" rIns="109728" tIns="54864" bIns="54864">
+            <a:bodyPr wrap="square" lIns="109728" tIns="54864" rIns="109728" bIns="54864" rtlCol="0" anchor="ctr">
               <a:noAutofit/>
             </a:bodyPr>
             <a:lstStyle/>
@@ -28463,7 +29173,6 @@
             </a:lvl9pPr>
           </a:lstStyle>
           <a:p>
-            <a:pPr/>
             <a:r>
               <a:t>Only the last step uses the language model. Everything before it is search</a:t>
             </a:r>

</xml_diff>